<commit_message>
Updated community assembly presentation
</commit_message>
<xml_diff>
--- a/Projects/Chapter1/community-assembly.pptx
+++ b/Projects/Chapter1/community-assembly.pptx
@@ -9,7 +9,7 @@
   </p:notesMasterIdLst>
   <p:sldIdLst>
     <p:sldId id="256" r:id="rId2"/>
-    <p:sldId id="257" r:id="rId3"/>
+    <p:sldId id="279" r:id="rId3"/>
     <p:sldId id="264" r:id="rId4"/>
     <p:sldId id="268" r:id="rId5"/>
     <p:sldId id="269" r:id="rId6"/>
@@ -136,6 +136,788 @@
 </file>
 
 <file path=ppt/diagrams/colors1.xml><?xml version="1.0" encoding="utf-8"?>
+<dgm:colorsDef xmlns:dgm="http://schemas.openxmlformats.org/drawingml/2006/diagram" xmlns:a="http://schemas.openxmlformats.org/drawingml/2006/main" uniqueId="urn:microsoft.com/office/officeart/2005/8/colors/colorful4">
+  <dgm:title val=""/>
+  <dgm:desc val=""/>
+  <dgm:catLst>
+    <dgm:cat type="colorful" pri="10400"/>
+  </dgm:catLst>
+  <dgm:styleLbl name="node0">
+    <dgm:fillClrLst meth="repeat">
+      <a:schemeClr val="accent3"/>
+    </dgm:fillClrLst>
+    <dgm:linClrLst meth="repeat">
+      <a:schemeClr val="lt1"/>
+    </dgm:linClrLst>
+    <dgm:effectClrLst/>
+    <dgm:txLinClrLst/>
+    <dgm:txFillClrLst/>
+    <dgm:txEffectClrLst/>
+  </dgm:styleLbl>
+  <dgm:styleLbl name="node1">
+    <dgm:fillClrLst>
+      <a:schemeClr val="accent4"/>
+      <a:schemeClr val="accent5"/>
+    </dgm:fillClrLst>
+    <dgm:linClrLst meth="repeat">
+      <a:schemeClr val="lt1"/>
+    </dgm:linClrLst>
+    <dgm:effectClrLst/>
+    <dgm:txLinClrLst/>
+    <dgm:txFillClrLst/>
+    <dgm:txEffectClrLst/>
+  </dgm:styleLbl>
+  <dgm:styleLbl name="alignNode1">
+    <dgm:fillClrLst>
+      <a:schemeClr val="accent4"/>
+      <a:schemeClr val="accent5"/>
+    </dgm:fillClrLst>
+    <dgm:linClrLst>
+      <a:schemeClr val="accent4"/>
+      <a:schemeClr val="accent5"/>
+    </dgm:linClrLst>
+    <dgm:effectClrLst/>
+    <dgm:txLinClrLst/>
+    <dgm:txFillClrLst/>
+    <dgm:txEffectClrLst/>
+  </dgm:styleLbl>
+  <dgm:styleLbl name="lnNode1">
+    <dgm:fillClrLst>
+      <a:schemeClr val="accent4"/>
+      <a:schemeClr val="accent5"/>
+    </dgm:fillClrLst>
+    <dgm:linClrLst meth="repeat">
+      <a:schemeClr val="lt1"/>
+    </dgm:linClrLst>
+    <dgm:effectClrLst/>
+    <dgm:txLinClrLst/>
+    <dgm:txFillClrLst/>
+    <dgm:txEffectClrLst/>
+  </dgm:styleLbl>
+  <dgm:styleLbl name="vennNode1">
+    <dgm:fillClrLst>
+      <a:schemeClr val="accent4">
+        <a:alpha val="50000"/>
+      </a:schemeClr>
+      <a:schemeClr val="accent5">
+        <a:alpha val="50000"/>
+      </a:schemeClr>
+    </dgm:fillClrLst>
+    <dgm:linClrLst meth="repeat">
+      <a:schemeClr val="lt1"/>
+    </dgm:linClrLst>
+    <dgm:effectClrLst/>
+    <dgm:txLinClrLst/>
+    <dgm:txFillClrLst/>
+    <dgm:txEffectClrLst/>
+  </dgm:styleLbl>
+  <dgm:styleLbl name="node2">
+    <dgm:fillClrLst>
+      <a:schemeClr val="accent5"/>
+    </dgm:fillClrLst>
+    <dgm:linClrLst meth="repeat">
+      <a:schemeClr val="lt1"/>
+    </dgm:linClrLst>
+    <dgm:effectClrLst/>
+    <dgm:txLinClrLst/>
+    <dgm:txFillClrLst/>
+    <dgm:txEffectClrLst/>
+  </dgm:styleLbl>
+  <dgm:styleLbl name="node3">
+    <dgm:fillClrLst>
+      <a:schemeClr val="accent6"/>
+    </dgm:fillClrLst>
+    <dgm:linClrLst meth="repeat">
+      <a:schemeClr val="lt1"/>
+    </dgm:linClrLst>
+    <dgm:effectClrLst/>
+    <dgm:txLinClrLst/>
+    <dgm:txFillClrLst/>
+    <dgm:txEffectClrLst/>
+  </dgm:styleLbl>
+  <dgm:styleLbl name="node4">
+    <dgm:fillClrLst>
+      <a:schemeClr val="accent1"/>
+    </dgm:fillClrLst>
+    <dgm:linClrLst meth="repeat">
+      <a:schemeClr val="lt1"/>
+    </dgm:linClrLst>
+    <dgm:effectClrLst/>
+    <dgm:txLinClrLst/>
+    <dgm:txFillClrLst/>
+    <dgm:txEffectClrLst/>
+  </dgm:styleLbl>
+  <dgm:styleLbl name="fgImgPlace1">
+    <dgm:fillClrLst>
+      <a:schemeClr val="accent4">
+        <a:tint val="50000"/>
+      </a:schemeClr>
+      <a:schemeClr val="accent5">
+        <a:tint val="50000"/>
+      </a:schemeClr>
+    </dgm:fillClrLst>
+    <dgm:linClrLst meth="repeat">
+      <a:schemeClr val="lt1"/>
+    </dgm:linClrLst>
+    <dgm:effectClrLst/>
+    <dgm:txLinClrLst/>
+    <dgm:txFillClrLst meth="repeat">
+      <a:schemeClr val="lt1"/>
+    </dgm:txFillClrLst>
+    <dgm:txEffectClrLst/>
+  </dgm:styleLbl>
+  <dgm:styleLbl name="alignImgPlace1">
+    <dgm:fillClrLst>
+      <a:schemeClr val="accent4">
+        <a:tint val="50000"/>
+      </a:schemeClr>
+      <a:schemeClr val="accent5">
+        <a:tint val="20000"/>
+      </a:schemeClr>
+    </dgm:fillClrLst>
+    <dgm:linClrLst meth="repeat">
+      <a:schemeClr val="lt1"/>
+    </dgm:linClrLst>
+    <dgm:effectClrLst/>
+    <dgm:txLinClrLst/>
+    <dgm:txFillClrLst meth="repeat">
+      <a:schemeClr val="lt1"/>
+    </dgm:txFillClrLst>
+    <dgm:txEffectClrLst/>
+  </dgm:styleLbl>
+  <dgm:styleLbl name="bgImgPlace1">
+    <dgm:fillClrLst>
+      <a:schemeClr val="accent4">
+        <a:tint val="50000"/>
+      </a:schemeClr>
+      <a:schemeClr val="accent5">
+        <a:tint val="20000"/>
+      </a:schemeClr>
+    </dgm:fillClrLst>
+    <dgm:linClrLst meth="repeat">
+      <a:schemeClr val="lt1"/>
+    </dgm:linClrLst>
+    <dgm:effectClrLst/>
+    <dgm:txLinClrLst/>
+    <dgm:txFillClrLst meth="repeat">
+      <a:schemeClr val="lt1"/>
+    </dgm:txFillClrLst>
+    <dgm:txEffectClrLst/>
+  </dgm:styleLbl>
+  <dgm:styleLbl name="sibTrans2D1">
+    <dgm:fillClrLst>
+      <a:schemeClr val="accent4"/>
+      <a:schemeClr val="accent5"/>
+    </dgm:fillClrLst>
+    <dgm:linClrLst meth="repeat">
+      <a:schemeClr val="lt1"/>
+    </dgm:linClrLst>
+    <dgm:effectClrLst/>
+    <dgm:txLinClrLst/>
+    <dgm:txFillClrLst/>
+    <dgm:txEffectClrLst/>
+  </dgm:styleLbl>
+  <dgm:styleLbl name="fgSibTrans2D1">
+    <dgm:fillClrLst>
+      <a:schemeClr val="accent4"/>
+      <a:schemeClr val="accent5"/>
+    </dgm:fillClrLst>
+    <dgm:linClrLst meth="repeat">
+      <a:schemeClr val="lt1"/>
+    </dgm:linClrLst>
+    <dgm:effectClrLst/>
+    <dgm:txLinClrLst/>
+    <dgm:txFillClrLst meth="repeat">
+      <a:schemeClr val="lt1"/>
+    </dgm:txFillClrLst>
+    <dgm:txEffectClrLst/>
+  </dgm:styleLbl>
+  <dgm:styleLbl name="bgSibTrans2D1">
+    <dgm:fillClrLst>
+      <a:schemeClr val="accent4"/>
+      <a:schemeClr val="accent5"/>
+    </dgm:fillClrLst>
+    <dgm:linClrLst meth="repeat">
+      <a:schemeClr val="lt1"/>
+    </dgm:linClrLst>
+    <dgm:effectClrLst/>
+    <dgm:txLinClrLst/>
+    <dgm:txFillClrLst meth="repeat">
+      <a:schemeClr val="lt1"/>
+    </dgm:txFillClrLst>
+    <dgm:txEffectClrLst/>
+  </dgm:styleLbl>
+  <dgm:styleLbl name="sibTrans1D1">
+    <dgm:fillClrLst/>
+    <dgm:linClrLst>
+      <a:schemeClr val="accent4"/>
+      <a:schemeClr val="accent5"/>
+    </dgm:linClrLst>
+    <dgm:effectClrLst/>
+    <dgm:txLinClrLst/>
+    <dgm:txFillClrLst meth="repeat">
+      <a:schemeClr val="tx1"/>
+    </dgm:txFillClrLst>
+    <dgm:txEffectClrLst/>
+  </dgm:styleLbl>
+  <dgm:styleLbl name="callout">
+    <dgm:fillClrLst meth="repeat">
+      <a:schemeClr val="accent4"/>
+    </dgm:fillClrLst>
+    <dgm:linClrLst meth="repeat">
+      <a:schemeClr val="accent4">
+        <a:tint val="50000"/>
+      </a:schemeClr>
+    </dgm:linClrLst>
+    <dgm:effectClrLst/>
+    <dgm:txLinClrLst/>
+    <dgm:txFillClrLst meth="repeat">
+      <a:schemeClr val="tx1"/>
+    </dgm:txFillClrLst>
+    <dgm:txEffectClrLst/>
+  </dgm:styleLbl>
+  <dgm:styleLbl name="asst0">
+    <dgm:fillClrLst meth="repeat">
+      <a:schemeClr val="accent4"/>
+    </dgm:fillClrLst>
+    <dgm:linClrLst meth="repeat">
+      <a:schemeClr val="lt1">
+        <a:shade val="80000"/>
+      </a:schemeClr>
+    </dgm:linClrLst>
+    <dgm:effectClrLst/>
+    <dgm:txLinClrLst/>
+    <dgm:txFillClrLst/>
+    <dgm:txEffectClrLst/>
+  </dgm:styleLbl>
+  <dgm:styleLbl name="asst1">
+    <dgm:fillClrLst meth="repeat">
+      <a:schemeClr val="accent5"/>
+    </dgm:fillClrLst>
+    <dgm:linClrLst meth="repeat">
+      <a:schemeClr val="lt1">
+        <a:shade val="80000"/>
+      </a:schemeClr>
+    </dgm:linClrLst>
+    <dgm:effectClrLst/>
+    <dgm:txLinClrLst/>
+    <dgm:txFillClrLst/>
+    <dgm:txEffectClrLst/>
+  </dgm:styleLbl>
+  <dgm:styleLbl name="asst2">
+    <dgm:fillClrLst>
+      <a:schemeClr val="accent6"/>
+    </dgm:fillClrLst>
+    <dgm:linClrLst meth="repeat">
+      <a:schemeClr val="lt1"/>
+    </dgm:linClrLst>
+    <dgm:effectClrLst/>
+    <dgm:txLinClrLst/>
+    <dgm:txFillClrLst/>
+    <dgm:txEffectClrLst/>
+  </dgm:styleLbl>
+  <dgm:styleLbl name="asst3">
+    <dgm:fillClrLst>
+      <a:schemeClr val="accent1"/>
+    </dgm:fillClrLst>
+    <dgm:linClrLst meth="repeat">
+      <a:schemeClr val="lt1"/>
+    </dgm:linClrLst>
+    <dgm:effectClrLst/>
+    <dgm:txLinClrLst/>
+    <dgm:txFillClrLst/>
+    <dgm:txEffectClrLst/>
+  </dgm:styleLbl>
+  <dgm:styleLbl name="asst4">
+    <dgm:fillClrLst>
+      <a:schemeClr val="accent2"/>
+    </dgm:fillClrLst>
+    <dgm:linClrLst meth="repeat">
+      <a:schemeClr val="lt1"/>
+    </dgm:linClrLst>
+    <dgm:effectClrLst/>
+    <dgm:txLinClrLst/>
+    <dgm:txFillClrLst/>
+    <dgm:txEffectClrLst/>
+  </dgm:styleLbl>
+  <dgm:styleLbl name="parChTrans2D1">
+    <dgm:fillClrLst meth="repeat">
+      <a:schemeClr val="accent4"/>
+    </dgm:fillClrLst>
+    <dgm:linClrLst meth="repeat">
+      <a:schemeClr val="lt1"/>
+    </dgm:linClrLst>
+    <dgm:effectClrLst/>
+    <dgm:txLinClrLst/>
+    <dgm:txFillClrLst meth="repeat">
+      <a:schemeClr val="lt1"/>
+    </dgm:txFillClrLst>
+    <dgm:txEffectClrLst/>
+  </dgm:styleLbl>
+  <dgm:styleLbl name="parChTrans2D2">
+    <dgm:fillClrLst meth="repeat">
+      <a:schemeClr val="accent5"/>
+    </dgm:fillClrLst>
+    <dgm:linClrLst meth="repeat">
+      <a:schemeClr val="lt1"/>
+    </dgm:linClrLst>
+    <dgm:effectClrLst/>
+    <dgm:txLinClrLst/>
+    <dgm:txFillClrLst/>
+    <dgm:txEffectClrLst/>
+  </dgm:styleLbl>
+  <dgm:styleLbl name="parChTrans2D3">
+    <dgm:fillClrLst meth="repeat">
+      <a:schemeClr val="accent5"/>
+    </dgm:fillClrLst>
+    <dgm:linClrLst meth="repeat">
+      <a:schemeClr val="lt1"/>
+    </dgm:linClrLst>
+    <dgm:effectClrLst/>
+    <dgm:txLinClrLst/>
+    <dgm:txFillClrLst/>
+    <dgm:txEffectClrLst/>
+  </dgm:styleLbl>
+  <dgm:styleLbl name="parChTrans2D4">
+    <dgm:fillClrLst meth="repeat">
+      <a:schemeClr val="accent6"/>
+    </dgm:fillClrLst>
+    <dgm:linClrLst meth="repeat">
+      <a:schemeClr val="lt1"/>
+    </dgm:linClrLst>
+    <dgm:effectClrLst/>
+    <dgm:txLinClrLst/>
+    <dgm:txFillClrLst meth="repeat">
+      <a:schemeClr val="lt1"/>
+    </dgm:txFillClrLst>
+    <dgm:txEffectClrLst/>
+  </dgm:styleLbl>
+  <dgm:styleLbl name="parChTrans1D1">
+    <dgm:fillClrLst meth="repeat">
+      <a:schemeClr val="accent4"/>
+    </dgm:fillClrLst>
+    <dgm:linClrLst meth="repeat">
+      <a:schemeClr val="accent4"/>
+    </dgm:linClrLst>
+    <dgm:effectClrLst/>
+    <dgm:txLinClrLst/>
+    <dgm:txFillClrLst meth="repeat">
+      <a:schemeClr val="tx1"/>
+    </dgm:txFillClrLst>
+    <dgm:txEffectClrLst/>
+  </dgm:styleLbl>
+  <dgm:styleLbl name="parChTrans1D2">
+    <dgm:fillClrLst meth="repeat">
+      <a:schemeClr val="accent4">
+        <a:tint val="90000"/>
+      </a:schemeClr>
+    </dgm:fillClrLst>
+    <dgm:linClrLst meth="repeat">
+      <a:schemeClr val="accent5"/>
+    </dgm:linClrLst>
+    <dgm:effectClrLst/>
+    <dgm:txLinClrLst/>
+    <dgm:txFillClrLst meth="repeat">
+      <a:schemeClr val="tx1"/>
+    </dgm:txFillClrLst>
+    <dgm:txEffectClrLst/>
+  </dgm:styleLbl>
+  <dgm:styleLbl name="parChTrans1D3">
+    <dgm:fillClrLst meth="repeat">
+      <a:schemeClr val="accent4">
+        <a:tint val="70000"/>
+      </a:schemeClr>
+    </dgm:fillClrLst>
+    <dgm:linClrLst meth="repeat">
+      <a:schemeClr val="accent6"/>
+    </dgm:linClrLst>
+    <dgm:effectClrLst/>
+    <dgm:txLinClrLst/>
+    <dgm:txFillClrLst meth="repeat">
+      <a:schemeClr val="tx1"/>
+    </dgm:txFillClrLst>
+    <dgm:txEffectClrLst/>
+  </dgm:styleLbl>
+  <dgm:styleLbl name="parChTrans1D4">
+    <dgm:fillClrLst meth="repeat">
+      <a:schemeClr val="accent4">
+        <a:tint val="50000"/>
+      </a:schemeClr>
+    </dgm:fillClrLst>
+    <dgm:linClrLst meth="repeat">
+      <a:schemeClr val="accent1"/>
+    </dgm:linClrLst>
+    <dgm:effectClrLst/>
+    <dgm:txLinClrLst/>
+    <dgm:txFillClrLst meth="repeat">
+      <a:schemeClr val="tx1"/>
+    </dgm:txFillClrLst>
+    <dgm:txEffectClrLst/>
+  </dgm:styleLbl>
+  <dgm:styleLbl name="fgAcc1">
+    <dgm:fillClrLst meth="repeat">
+      <a:schemeClr val="lt1">
+        <a:alpha val="90000"/>
+      </a:schemeClr>
+    </dgm:fillClrLst>
+    <dgm:linClrLst>
+      <a:schemeClr val="accent4"/>
+      <a:schemeClr val="accent5"/>
+    </dgm:linClrLst>
+    <dgm:effectClrLst/>
+    <dgm:txLinClrLst/>
+    <dgm:txFillClrLst meth="repeat">
+      <a:schemeClr val="dk1"/>
+    </dgm:txFillClrLst>
+    <dgm:txEffectClrLst/>
+  </dgm:styleLbl>
+  <dgm:styleLbl name="conFgAcc1">
+    <dgm:fillClrLst meth="repeat">
+      <a:schemeClr val="lt1">
+        <a:alpha val="90000"/>
+      </a:schemeClr>
+    </dgm:fillClrLst>
+    <dgm:linClrLst>
+      <a:schemeClr val="accent4"/>
+      <a:schemeClr val="accent5"/>
+    </dgm:linClrLst>
+    <dgm:effectClrLst/>
+    <dgm:txLinClrLst/>
+    <dgm:txFillClrLst meth="repeat">
+      <a:schemeClr val="dk1"/>
+    </dgm:txFillClrLst>
+    <dgm:txEffectClrLst/>
+  </dgm:styleLbl>
+  <dgm:styleLbl name="alignAcc1">
+    <dgm:fillClrLst meth="repeat">
+      <a:schemeClr val="lt1">
+        <a:alpha val="90000"/>
+      </a:schemeClr>
+    </dgm:fillClrLst>
+    <dgm:linClrLst>
+      <a:schemeClr val="accent4"/>
+      <a:schemeClr val="accent5"/>
+    </dgm:linClrLst>
+    <dgm:effectClrLst/>
+    <dgm:txLinClrLst/>
+    <dgm:txFillClrLst meth="repeat">
+      <a:schemeClr val="dk1"/>
+    </dgm:txFillClrLst>
+    <dgm:txEffectClrLst/>
+  </dgm:styleLbl>
+  <dgm:styleLbl name="trAlignAcc1">
+    <dgm:fillClrLst meth="repeat">
+      <a:schemeClr val="lt1">
+        <a:alpha val="40000"/>
+      </a:schemeClr>
+    </dgm:fillClrLst>
+    <dgm:linClrLst meth="repeat">
+      <a:schemeClr val="accent4"/>
+    </dgm:linClrLst>
+    <dgm:effectClrLst/>
+    <dgm:txLinClrLst/>
+    <dgm:txFillClrLst meth="repeat">
+      <a:schemeClr val="dk1"/>
+    </dgm:txFillClrLst>
+    <dgm:txEffectClrLst/>
+  </dgm:styleLbl>
+  <dgm:styleLbl name="bgAcc1">
+    <dgm:fillClrLst meth="repeat">
+      <a:schemeClr val="lt1">
+        <a:alpha val="90000"/>
+      </a:schemeClr>
+    </dgm:fillClrLst>
+    <dgm:linClrLst>
+      <a:schemeClr val="accent4"/>
+      <a:schemeClr val="accent5"/>
+    </dgm:linClrLst>
+    <dgm:effectClrLst/>
+    <dgm:txLinClrLst/>
+    <dgm:txFillClrLst meth="repeat">
+      <a:schemeClr val="dk1"/>
+    </dgm:txFillClrLst>
+    <dgm:txEffectClrLst/>
+  </dgm:styleLbl>
+  <dgm:styleLbl name="solidFgAcc1">
+    <dgm:fillClrLst meth="repeat">
+      <a:schemeClr val="lt1"/>
+    </dgm:fillClrLst>
+    <dgm:linClrLst>
+      <a:schemeClr val="accent4"/>
+      <a:schemeClr val="accent5"/>
+    </dgm:linClrLst>
+    <dgm:effectClrLst/>
+    <dgm:txLinClrLst/>
+    <dgm:txFillClrLst meth="repeat">
+      <a:schemeClr val="dk1"/>
+    </dgm:txFillClrLst>
+    <dgm:txEffectClrLst/>
+  </dgm:styleLbl>
+  <dgm:styleLbl name="solidAlignAcc1">
+    <dgm:fillClrLst meth="repeat">
+      <a:schemeClr val="lt1"/>
+    </dgm:fillClrLst>
+    <dgm:linClrLst>
+      <a:schemeClr val="accent4"/>
+      <a:schemeClr val="accent5"/>
+    </dgm:linClrLst>
+    <dgm:effectClrLst/>
+    <dgm:txLinClrLst/>
+    <dgm:txFillClrLst meth="repeat">
+      <a:schemeClr val="dk1"/>
+    </dgm:txFillClrLst>
+    <dgm:txEffectClrLst/>
+  </dgm:styleLbl>
+  <dgm:styleLbl name="solidBgAcc1">
+    <dgm:fillClrLst meth="repeat">
+      <a:schemeClr val="lt1"/>
+    </dgm:fillClrLst>
+    <dgm:linClrLst>
+      <a:schemeClr val="accent4"/>
+      <a:schemeClr val="accent5"/>
+    </dgm:linClrLst>
+    <dgm:effectClrLst/>
+    <dgm:txLinClrLst/>
+    <dgm:txFillClrLst meth="repeat">
+      <a:schemeClr val="dk1"/>
+    </dgm:txFillClrLst>
+    <dgm:txEffectClrLst/>
+  </dgm:styleLbl>
+  <dgm:styleLbl name="fgAccFollowNode1">
+    <dgm:fillClrLst>
+      <a:schemeClr val="accent4">
+        <a:tint val="40000"/>
+        <a:alpha val="90000"/>
+      </a:schemeClr>
+      <a:schemeClr val="accent5">
+        <a:tint val="40000"/>
+        <a:alpha val="90000"/>
+      </a:schemeClr>
+    </dgm:fillClrLst>
+    <dgm:linClrLst>
+      <a:schemeClr val="accent4">
+        <a:tint val="40000"/>
+        <a:alpha val="90000"/>
+      </a:schemeClr>
+      <a:schemeClr val="accent5">
+        <a:tint val="40000"/>
+        <a:alpha val="90000"/>
+      </a:schemeClr>
+    </dgm:linClrLst>
+    <dgm:effectClrLst/>
+    <dgm:txLinClrLst/>
+    <dgm:txFillClrLst meth="repeat">
+      <a:schemeClr val="dk1"/>
+    </dgm:txFillClrLst>
+    <dgm:txEffectClrLst/>
+  </dgm:styleLbl>
+  <dgm:styleLbl name="alignAccFollowNode1">
+    <dgm:fillClrLst>
+      <a:schemeClr val="accent4">
+        <a:tint val="40000"/>
+        <a:alpha val="90000"/>
+      </a:schemeClr>
+      <a:schemeClr val="accent5">
+        <a:tint val="40000"/>
+        <a:alpha val="90000"/>
+      </a:schemeClr>
+    </dgm:fillClrLst>
+    <dgm:linClrLst>
+      <a:schemeClr val="accent4">
+        <a:tint val="40000"/>
+        <a:alpha val="90000"/>
+      </a:schemeClr>
+      <a:schemeClr val="accent5">
+        <a:tint val="40000"/>
+        <a:alpha val="90000"/>
+      </a:schemeClr>
+    </dgm:linClrLst>
+    <dgm:effectClrLst/>
+    <dgm:txLinClrLst/>
+    <dgm:txFillClrLst meth="repeat">
+      <a:schemeClr val="dk1"/>
+    </dgm:txFillClrLst>
+    <dgm:txEffectClrLst/>
+  </dgm:styleLbl>
+  <dgm:styleLbl name="bgAccFollowNode1">
+    <dgm:fillClrLst>
+      <a:schemeClr val="accent4">
+        <a:tint val="40000"/>
+        <a:alpha val="90000"/>
+      </a:schemeClr>
+      <a:schemeClr val="accent5">
+        <a:tint val="40000"/>
+        <a:alpha val="90000"/>
+      </a:schemeClr>
+    </dgm:fillClrLst>
+    <dgm:linClrLst>
+      <a:schemeClr val="accent4">
+        <a:tint val="40000"/>
+        <a:alpha val="90000"/>
+      </a:schemeClr>
+      <a:schemeClr val="accent5">
+        <a:tint val="40000"/>
+        <a:alpha val="90000"/>
+      </a:schemeClr>
+    </dgm:linClrLst>
+    <dgm:effectClrLst/>
+    <dgm:txLinClrLst/>
+    <dgm:txFillClrLst meth="repeat">
+      <a:schemeClr val="dk1"/>
+    </dgm:txFillClrLst>
+    <dgm:txEffectClrLst/>
+  </dgm:styleLbl>
+  <dgm:styleLbl name="fgAcc0">
+    <dgm:fillClrLst meth="repeat">
+      <a:schemeClr val="lt1">
+        <a:alpha val="90000"/>
+      </a:schemeClr>
+    </dgm:fillClrLst>
+    <dgm:linClrLst>
+      <a:schemeClr val="accent3"/>
+    </dgm:linClrLst>
+    <dgm:effectClrLst/>
+    <dgm:txLinClrLst/>
+    <dgm:txFillClrLst meth="repeat">
+      <a:schemeClr val="dk1"/>
+    </dgm:txFillClrLst>
+    <dgm:txEffectClrLst/>
+  </dgm:styleLbl>
+  <dgm:styleLbl name="fgAcc2">
+    <dgm:fillClrLst meth="repeat">
+      <a:schemeClr val="lt1">
+        <a:alpha val="90000"/>
+      </a:schemeClr>
+    </dgm:fillClrLst>
+    <dgm:linClrLst>
+      <a:schemeClr val="accent5"/>
+    </dgm:linClrLst>
+    <dgm:effectClrLst/>
+    <dgm:txLinClrLst/>
+    <dgm:txFillClrLst meth="repeat">
+      <a:schemeClr val="dk1"/>
+    </dgm:txFillClrLst>
+    <dgm:txEffectClrLst/>
+  </dgm:styleLbl>
+  <dgm:styleLbl name="fgAcc3">
+    <dgm:fillClrLst meth="repeat">
+      <a:schemeClr val="lt1">
+        <a:alpha val="90000"/>
+      </a:schemeClr>
+    </dgm:fillClrLst>
+    <dgm:linClrLst>
+      <a:schemeClr val="accent6"/>
+    </dgm:linClrLst>
+    <dgm:effectClrLst/>
+    <dgm:txLinClrLst/>
+    <dgm:txFillClrLst meth="repeat">
+      <a:schemeClr val="dk1"/>
+    </dgm:txFillClrLst>
+    <dgm:txEffectClrLst/>
+  </dgm:styleLbl>
+  <dgm:styleLbl name="fgAcc4">
+    <dgm:fillClrLst meth="repeat">
+      <a:schemeClr val="lt1">
+        <a:alpha val="90000"/>
+      </a:schemeClr>
+    </dgm:fillClrLst>
+    <dgm:linClrLst>
+      <a:schemeClr val="accent1"/>
+    </dgm:linClrLst>
+    <dgm:effectClrLst/>
+    <dgm:txLinClrLst/>
+    <dgm:txFillClrLst meth="repeat">
+      <a:schemeClr val="dk1"/>
+    </dgm:txFillClrLst>
+    <dgm:txEffectClrLst/>
+  </dgm:styleLbl>
+  <dgm:styleLbl name="bgShp">
+    <dgm:fillClrLst meth="repeat">
+      <a:schemeClr val="accent4">
+        <a:tint val="40000"/>
+      </a:schemeClr>
+    </dgm:fillClrLst>
+    <dgm:linClrLst meth="repeat">
+      <a:schemeClr val="dk1"/>
+    </dgm:linClrLst>
+    <dgm:effectClrLst/>
+    <dgm:txLinClrLst/>
+    <dgm:txFillClrLst meth="repeat">
+      <a:schemeClr val="dk1"/>
+    </dgm:txFillClrLst>
+    <dgm:txEffectClrLst/>
+  </dgm:styleLbl>
+  <dgm:styleLbl name="dkBgShp">
+    <dgm:fillClrLst meth="repeat">
+      <a:schemeClr val="accent4">
+        <a:shade val="90000"/>
+      </a:schemeClr>
+    </dgm:fillClrLst>
+    <dgm:linClrLst meth="repeat">
+      <a:schemeClr val="dk1"/>
+    </dgm:linClrLst>
+    <dgm:effectClrLst/>
+    <dgm:txLinClrLst/>
+    <dgm:txFillClrLst meth="repeat">
+      <a:schemeClr val="lt1"/>
+    </dgm:txFillClrLst>
+    <dgm:txEffectClrLst/>
+  </dgm:styleLbl>
+  <dgm:styleLbl name="trBgShp">
+    <dgm:fillClrLst meth="repeat">
+      <a:schemeClr val="accent4">
+        <a:tint val="50000"/>
+        <a:alpha val="40000"/>
+      </a:schemeClr>
+    </dgm:fillClrLst>
+    <dgm:linClrLst meth="repeat">
+      <a:schemeClr val="accent4"/>
+    </dgm:linClrLst>
+    <dgm:effectClrLst/>
+    <dgm:txLinClrLst/>
+    <dgm:txFillClrLst meth="repeat">
+      <a:schemeClr val="lt1"/>
+    </dgm:txFillClrLst>
+    <dgm:txEffectClrLst/>
+  </dgm:styleLbl>
+  <dgm:styleLbl name="fgShp">
+    <dgm:fillClrLst meth="repeat">
+      <a:schemeClr val="accent4">
+        <a:tint val="40000"/>
+      </a:schemeClr>
+    </dgm:fillClrLst>
+    <dgm:linClrLst meth="repeat">
+      <a:schemeClr val="lt1"/>
+    </dgm:linClrLst>
+    <dgm:effectClrLst/>
+    <dgm:txLinClrLst/>
+    <dgm:txFillClrLst meth="repeat">
+      <a:schemeClr val="dk1"/>
+    </dgm:txFillClrLst>
+    <dgm:txEffectClrLst/>
+  </dgm:styleLbl>
+  <dgm:styleLbl name="revTx">
+    <dgm:fillClrLst meth="repeat">
+      <a:schemeClr val="lt1">
+        <a:alpha val="0"/>
+      </a:schemeClr>
+    </dgm:fillClrLst>
+    <dgm:linClrLst meth="repeat">
+      <a:schemeClr val="dk1">
+        <a:alpha val="0"/>
+      </a:schemeClr>
+    </dgm:linClrLst>
+    <dgm:effectClrLst/>
+    <dgm:txLinClrLst/>
+    <dgm:txFillClrLst meth="repeat">
+      <a:schemeClr val="tx1"/>
+    </dgm:txFillClrLst>
+    <dgm:txEffectClrLst/>
+  </dgm:styleLbl>
+</dgm:colorsDef>
+</file>
+
+<file path=ppt/diagrams/colors2.xml><?xml version="1.0" encoding="utf-8"?>
 <dgm:colorsDef xmlns:dgm="http://schemas.openxmlformats.org/drawingml/2006/diagram" xmlns:a="http://schemas.openxmlformats.org/drawingml/2006/main" uniqueId="urn:microsoft.com/office/officeart/2005/8/colors/colorful1">
   <dgm:title val=""/>
   <dgm:desc val=""/>
@@ -1055,6 +1837,202 @@
 </file>
 
 <file path=ppt/diagrams/data1.xml><?xml version="1.0" encoding="utf-8"?>
+<dgm:dataModel xmlns:dgm="http://schemas.openxmlformats.org/drawingml/2006/diagram" xmlns:a="http://schemas.openxmlformats.org/drawingml/2006/main">
+  <dgm:ptLst>
+    <dgm:pt modelId="{8F4A8053-4923-A24E-AEC5-81BF6014CBC8}" type="doc">
+      <dgm:prSet loTypeId="urn:microsoft.com/office/officeart/2005/8/layout/venn1" loCatId="" qsTypeId="urn:microsoft.com/office/officeart/2005/8/quickstyle/simple1" qsCatId="simple" csTypeId="urn:microsoft.com/office/officeart/2005/8/colors/colorful4" csCatId="colorful" phldr="1"/>
+      <dgm:spPr/>
+    </dgm:pt>
+    <dgm:pt modelId="{7F8359A3-B9CF-6D4B-8037-57FE1863EDF2}">
+      <dgm:prSet phldrT="[Text]"/>
+      <dgm:spPr/>
+      <dgm:t>
+        <a:bodyPr/>
+        <a:lstStyle/>
+        <a:p>
+          <a:r>
+            <a:rPr lang="en-US" dirty="0"/>
+            <a:t>Selection</a:t>
+          </a:r>
+        </a:p>
+      </dgm:t>
+    </dgm:pt>
+    <dgm:pt modelId="{B0B7F09A-A873-7049-9697-5CF8A7964645}" type="parTrans" cxnId="{22E0002F-3AB5-A944-A9A5-20F9CD6BC590}">
+      <dgm:prSet/>
+      <dgm:spPr/>
+      <dgm:t>
+        <a:bodyPr/>
+        <a:lstStyle/>
+        <a:p>
+          <a:endParaRPr lang="en-US"/>
+        </a:p>
+      </dgm:t>
+    </dgm:pt>
+    <dgm:pt modelId="{B699ECE7-0CE4-8B41-A16C-D2DA25295E5A}" type="sibTrans" cxnId="{22E0002F-3AB5-A944-A9A5-20F9CD6BC590}">
+      <dgm:prSet/>
+      <dgm:spPr/>
+      <dgm:t>
+        <a:bodyPr/>
+        <a:lstStyle/>
+        <a:p>
+          <a:endParaRPr lang="en-US"/>
+        </a:p>
+      </dgm:t>
+    </dgm:pt>
+    <dgm:pt modelId="{0475E55C-BC76-CC49-A6EA-4425DC97CB71}">
+      <dgm:prSet phldrT="[Text]"/>
+      <dgm:spPr/>
+      <dgm:t>
+        <a:bodyPr/>
+        <a:lstStyle/>
+        <a:p>
+          <a:r>
+            <a:rPr lang="en-US" dirty="0"/>
+            <a:t>Dispersal</a:t>
+          </a:r>
+        </a:p>
+      </dgm:t>
+    </dgm:pt>
+    <dgm:pt modelId="{CAC93909-FC75-1A4A-AC6C-8A176D84B327}" type="parTrans" cxnId="{6C7751D4-1294-EB42-9CAD-B69CD70ABD32}">
+      <dgm:prSet/>
+      <dgm:spPr/>
+      <dgm:t>
+        <a:bodyPr/>
+        <a:lstStyle/>
+        <a:p>
+          <a:endParaRPr lang="en-US"/>
+        </a:p>
+      </dgm:t>
+    </dgm:pt>
+    <dgm:pt modelId="{6589743F-27BF-6740-9E4C-996261639427}" type="sibTrans" cxnId="{6C7751D4-1294-EB42-9CAD-B69CD70ABD32}">
+      <dgm:prSet/>
+      <dgm:spPr/>
+      <dgm:t>
+        <a:bodyPr/>
+        <a:lstStyle/>
+        <a:p>
+          <a:endParaRPr lang="en-US"/>
+        </a:p>
+      </dgm:t>
+    </dgm:pt>
+    <dgm:pt modelId="{C77A4A92-8829-554D-A202-9E33F357FC68}">
+      <dgm:prSet phldrT="[Text]"/>
+      <dgm:spPr/>
+      <dgm:t>
+        <a:bodyPr/>
+        <a:lstStyle/>
+        <a:p>
+          <a:r>
+            <a:rPr lang="en-US" dirty="0"/>
+            <a:t>Ecological Drift</a:t>
+          </a:r>
+        </a:p>
+      </dgm:t>
+    </dgm:pt>
+    <dgm:pt modelId="{CD6B9D5D-8787-D348-92EC-DD8D371AAF2D}" type="parTrans" cxnId="{E16A4536-2D03-6141-932B-DB32ABF87EDF}">
+      <dgm:prSet/>
+      <dgm:spPr/>
+      <dgm:t>
+        <a:bodyPr/>
+        <a:lstStyle/>
+        <a:p>
+          <a:endParaRPr lang="en-US"/>
+        </a:p>
+      </dgm:t>
+    </dgm:pt>
+    <dgm:pt modelId="{DE11C94D-1CAD-B04E-8F8C-6BD6380124BA}" type="sibTrans" cxnId="{E16A4536-2D03-6141-932B-DB32ABF87EDF}">
+      <dgm:prSet/>
+      <dgm:spPr/>
+      <dgm:t>
+        <a:bodyPr/>
+        <a:lstStyle/>
+        <a:p>
+          <a:endParaRPr lang="en-US"/>
+        </a:p>
+      </dgm:t>
+    </dgm:pt>
+    <dgm:pt modelId="{99849F71-D68B-6349-82AD-85F23C18C551}" type="pres">
+      <dgm:prSet presAssocID="{8F4A8053-4923-A24E-AEC5-81BF6014CBC8}" presName="compositeShape" presStyleCnt="0">
+        <dgm:presLayoutVars>
+          <dgm:chMax val="7"/>
+          <dgm:dir/>
+          <dgm:resizeHandles val="exact"/>
+        </dgm:presLayoutVars>
+      </dgm:prSet>
+      <dgm:spPr/>
+    </dgm:pt>
+    <dgm:pt modelId="{25E2C31A-9C32-8244-A94C-1A921F1582B3}" type="pres">
+      <dgm:prSet presAssocID="{7F8359A3-B9CF-6D4B-8037-57FE1863EDF2}" presName="circ1" presStyleLbl="vennNode1" presStyleIdx="0" presStyleCnt="3"/>
+      <dgm:spPr/>
+    </dgm:pt>
+    <dgm:pt modelId="{12CDB55E-5DD0-DE4F-96C4-703F4165CACE}" type="pres">
+      <dgm:prSet presAssocID="{7F8359A3-B9CF-6D4B-8037-57FE1863EDF2}" presName="circ1Tx" presStyleLbl="revTx" presStyleIdx="0" presStyleCnt="0">
+        <dgm:presLayoutVars>
+          <dgm:chMax val="0"/>
+          <dgm:chPref val="0"/>
+          <dgm:bulletEnabled val="1"/>
+        </dgm:presLayoutVars>
+      </dgm:prSet>
+      <dgm:spPr/>
+    </dgm:pt>
+    <dgm:pt modelId="{7DAC2FF7-8C69-8544-B207-8AD8ED8CC18E}" type="pres">
+      <dgm:prSet presAssocID="{0475E55C-BC76-CC49-A6EA-4425DC97CB71}" presName="circ2" presStyleLbl="vennNode1" presStyleIdx="1" presStyleCnt="3"/>
+      <dgm:spPr/>
+    </dgm:pt>
+    <dgm:pt modelId="{76DE5FBD-4E39-D141-A1C7-AC8C1D7BAF55}" type="pres">
+      <dgm:prSet presAssocID="{0475E55C-BC76-CC49-A6EA-4425DC97CB71}" presName="circ2Tx" presStyleLbl="revTx" presStyleIdx="0" presStyleCnt="0">
+        <dgm:presLayoutVars>
+          <dgm:chMax val="0"/>
+          <dgm:chPref val="0"/>
+          <dgm:bulletEnabled val="1"/>
+        </dgm:presLayoutVars>
+      </dgm:prSet>
+      <dgm:spPr/>
+    </dgm:pt>
+    <dgm:pt modelId="{C13988BE-4667-2C42-B802-C07898FB496F}" type="pres">
+      <dgm:prSet presAssocID="{C77A4A92-8829-554D-A202-9E33F357FC68}" presName="circ3" presStyleLbl="vennNode1" presStyleIdx="2" presStyleCnt="3"/>
+      <dgm:spPr/>
+    </dgm:pt>
+    <dgm:pt modelId="{63B1BA92-5CBD-5D43-B807-32F00F93F4C2}" type="pres">
+      <dgm:prSet presAssocID="{C77A4A92-8829-554D-A202-9E33F357FC68}" presName="circ3Tx" presStyleLbl="revTx" presStyleIdx="0" presStyleCnt="0">
+        <dgm:presLayoutVars>
+          <dgm:chMax val="0"/>
+          <dgm:chPref val="0"/>
+          <dgm:bulletEnabled val="1"/>
+        </dgm:presLayoutVars>
+      </dgm:prSet>
+      <dgm:spPr/>
+    </dgm:pt>
+  </dgm:ptLst>
+  <dgm:cxnLst>
+    <dgm:cxn modelId="{22E0002F-3AB5-A944-A9A5-20F9CD6BC590}" srcId="{8F4A8053-4923-A24E-AEC5-81BF6014CBC8}" destId="{7F8359A3-B9CF-6D4B-8037-57FE1863EDF2}" srcOrd="0" destOrd="0" parTransId="{B0B7F09A-A873-7049-9697-5CF8A7964645}" sibTransId="{B699ECE7-0CE4-8B41-A16C-D2DA25295E5A}"/>
+    <dgm:cxn modelId="{E16A4536-2D03-6141-932B-DB32ABF87EDF}" srcId="{8F4A8053-4923-A24E-AEC5-81BF6014CBC8}" destId="{C77A4A92-8829-554D-A202-9E33F357FC68}" srcOrd="2" destOrd="0" parTransId="{CD6B9D5D-8787-D348-92EC-DD8D371AAF2D}" sibTransId="{DE11C94D-1CAD-B04E-8F8C-6BD6380124BA}"/>
+    <dgm:cxn modelId="{30926E4F-908A-2648-A053-9920F727B0EC}" type="presOf" srcId="{0475E55C-BC76-CC49-A6EA-4425DC97CB71}" destId="{76DE5FBD-4E39-D141-A1C7-AC8C1D7BAF55}" srcOrd="1" destOrd="0" presId="urn:microsoft.com/office/officeart/2005/8/layout/venn1"/>
+    <dgm:cxn modelId="{1CE78F51-CC2E-DD49-9AB8-215DB2E3873F}" type="presOf" srcId="{7F8359A3-B9CF-6D4B-8037-57FE1863EDF2}" destId="{25E2C31A-9C32-8244-A94C-1A921F1582B3}" srcOrd="0" destOrd="0" presId="urn:microsoft.com/office/officeart/2005/8/layout/venn1"/>
+    <dgm:cxn modelId="{77AD5456-ADF9-5144-901C-53774063F956}" type="presOf" srcId="{7F8359A3-B9CF-6D4B-8037-57FE1863EDF2}" destId="{12CDB55E-5DD0-DE4F-96C4-703F4165CACE}" srcOrd="1" destOrd="0" presId="urn:microsoft.com/office/officeart/2005/8/layout/venn1"/>
+    <dgm:cxn modelId="{43CD5461-142A-BC4E-90AB-21C84DA1623D}" type="presOf" srcId="{C77A4A92-8829-554D-A202-9E33F357FC68}" destId="{63B1BA92-5CBD-5D43-B807-32F00F93F4C2}" srcOrd="1" destOrd="0" presId="urn:microsoft.com/office/officeart/2005/8/layout/venn1"/>
+    <dgm:cxn modelId="{903EFF63-DF67-514E-8054-8C572B8FB92F}" type="presOf" srcId="{C77A4A92-8829-554D-A202-9E33F357FC68}" destId="{C13988BE-4667-2C42-B802-C07898FB496F}" srcOrd="0" destOrd="0" presId="urn:microsoft.com/office/officeart/2005/8/layout/venn1"/>
+    <dgm:cxn modelId="{01B8258E-F57E-024C-9034-8CCCDFC3C0BF}" type="presOf" srcId="{0475E55C-BC76-CC49-A6EA-4425DC97CB71}" destId="{7DAC2FF7-8C69-8544-B207-8AD8ED8CC18E}" srcOrd="0" destOrd="0" presId="urn:microsoft.com/office/officeart/2005/8/layout/venn1"/>
+    <dgm:cxn modelId="{E502D9AF-D72C-8E4E-B145-ADD72D368CFD}" type="presOf" srcId="{8F4A8053-4923-A24E-AEC5-81BF6014CBC8}" destId="{99849F71-D68B-6349-82AD-85F23C18C551}" srcOrd="0" destOrd="0" presId="urn:microsoft.com/office/officeart/2005/8/layout/venn1"/>
+    <dgm:cxn modelId="{6C7751D4-1294-EB42-9CAD-B69CD70ABD32}" srcId="{8F4A8053-4923-A24E-AEC5-81BF6014CBC8}" destId="{0475E55C-BC76-CC49-A6EA-4425DC97CB71}" srcOrd="1" destOrd="0" parTransId="{CAC93909-FC75-1A4A-AC6C-8A176D84B327}" sibTransId="{6589743F-27BF-6740-9E4C-996261639427}"/>
+    <dgm:cxn modelId="{D16D97F3-DFAD-144F-84C9-FD14C1B6A643}" type="presParOf" srcId="{99849F71-D68B-6349-82AD-85F23C18C551}" destId="{25E2C31A-9C32-8244-A94C-1A921F1582B3}" srcOrd="0" destOrd="0" presId="urn:microsoft.com/office/officeart/2005/8/layout/venn1"/>
+    <dgm:cxn modelId="{68F31C22-3EB3-7546-80D3-71255CEF552E}" type="presParOf" srcId="{99849F71-D68B-6349-82AD-85F23C18C551}" destId="{12CDB55E-5DD0-DE4F-96C4-703F4165CACE}" srcOrd="1" destOrd="0" presId="urn:microsoft.com/office/officeart/2005/8/layout/venn1"/>
+    <dgm:cxn modelId="{ED19B7B3-6FAE-BD49-9E19-A1C4E1D85B26}" type="presParOf" srcId="{99849F71-D68B-6349-82AD-85F23C18C551}" destId="{7DAC2FF7-8C69-8544-B207-8AD8ED8CC18E}" srcOrd="2" destOrd="0" presId="urn:microsoft.com/office/officeart/2005/8/layout/venn1"/>
+    <dgm:cxn modelId="{B964DD3B-9CC4-174F-A633-FBFB58832294}" type="presParOf" srcId="{99849F71-D68B-6349-82AD-85F23C18C551}" destId="{76DE5FBD-4E39-D141-A1C7-AC8C1D7BAF55}" srcOrd="3" destOrd="0" presId="urn:microsoft.com/office/officeart/2005/8/layout/venn1"/>
+    <dgm:cxn modelId="{720B36BF-859B-B64D-8DC5-26567BAA7DE8}" type="presParOf" srcId="{99849F71-D68B-6349-82AD-85F23C18C551}" destId="{C13988BE-4667-2C42-B802-C07898FB496F}" srcOrd="4" destOrd="0" presId="urn:microsoft.com/office/officeart/2005/8/layout/venn1"/>
+    <dgm:cxn modelId="{43A3809A-FA93-8346-91EF-D786EBA2C43D}" type="presParOf" srcId="{99849F71-D68B-6349-82AD-85F23C18C551}" destId="{63B1BA92-5CBD-5D43-B807-32F00F93F4C2}" srcOrd="5" destOrd="0" presId="urn:microsoft.com/office/officeart/2005/8/layout/venn1"/>
+  </dgm:cxnLst>
+  <dgm:bg/>
+  <dgm:whole/>
+  <dgm:extLst>
+    <a:ext uri="http://schemas.microsoft.com/office/drawing/2008/diagram">
+      <dsp:dataModelExt xmlns:dsp="http://schemas.microsoft.com/office/drawing/2008/diagram" relId="rId7" minVer="http://schemas.openxmlformats.org/drawingml/2006/diagram"/>
+    </a:ext>
+  </dgm:extLst>
+</dgm:dataModel>
+</file>
+
+<file path=ppt/diagrams/data2.xml><?xml version="1.0" encoding="utf-8"?>
 <dgm:dataModel xmlns:dgm="http://schemas.openxmlformats.org/drawingml/2006/diagram" xmlns:a="http://schemas.openxmlformats.org/drawingml/2006/main">
   <dgm:ptLst>
     <dgm:pt modelId="{CB88F0E7-4140-1B4D-A33B-6563FB2E1C23}" type="doc">
@@ -1411,6 +2389,255 @@
 </file>
 
 <file path=ppt/diagrams/drawing1.xml><?xml version="1.0" encoding="utf-8"?>
+<dsp:drawing xmlns:dgm="http://schemas.openxmlformats.org/drawingml/2006/diagram" xmlns:dsp="http://schemas.microsoft.com/office/drawing/2008/diagram" xmlns:a="http://schemas.openxmlformats.org/drawingml/2006/main">
+  <dsp:spTree>
+    <dsp:nvGrpSpPr>
+      <dsp:cNvPr id="0" name=""/>
+      <dsp:cNvGrpSpPr/>
+    </dsp:nvGrpSpPr>
+    <dsp:grpSpPr/>
+    <dsp:sp modelId="{25E2C31A-9C32-8244-A94C-1A921F1582B3}">
+      <dsp:nvSpPr>
+        <dsp:cNvPr id="0" name=""/>
+        <dsp:cNvSpPr/>
+      </dsp:nvSpPr>
+      <dsp:spPr>
+        <a:xfrm>
+          <a:off x="2163603" y="60100"/>
+          <a:ext cx="2884805" cy="2884805"/>
+        </a:xfrm>
+        <a:prstGeom prst="ellipse">
+          <a:avLst/>
+        </a:prstGeom>
+        <a:solidFill>
+          <a:schemeClr val="accent4">
+            <a:alpha val="50000"/>
+            <a:hueOff val="0"/>
+            <a:satOff val="0"/>
+            <a:lumOff val="0"/>
+            <a:alphaOff val="0"/>
+          </a:schemeClr>
+        </a:solidFill>
+        <a:ln w="12700" cap="flat" cmpd="sng" algn="ctr">
+          <a:solidFill>
+            <a:schemeClr val="lt1">
+              <a:hueOff val="0"/>
+              <a:satOff val="0"/>
+              <a:lumOff val="0"/>
+              <a:alphaOff val="0"/>
+            </a:schemeClr>
+          </a:solidFill>
+          <a:prstDash val="solid"/>
+          <a:miter lim="800000"/>
+        </a:ln>
+        <a:effectLst/>
+      </dsp:spPr>
+      <dsp:style>
+        <a:lnRef idx="2">
+          <a:scrgbClr r="0" g="0" b="0"/>
+        </a:lnRef>
+        <a:fillRef idx="1">
+          <a:scrgbClr r="0" g="0" b="0"/>
+        </a:fillRef>
+        <a:effectRef idx="0">
+          <a:scrgbClr r="0" g="0" b="0"/>
+        </a:effectRef>
+        <a:fontRef idx="minor">
+          <a:schemeClr val="tx1"/>
+        </a:fontRef>
+      </dsp:style>
+      <dsp:txBody>
+        <a:bodyPr spcFirstLastPara="0" vert="horz" wrap="square" lIns="0" tIns="0" rIns="0" bIns="0" numCol="1" spcCol="1270" anchor="ctr" anchorCtr="0">
+          <a:noAutofit/>
+        </a:bodyPr>
+        <a:lstStyle/>
+        <a:p>
+          <a:pPr marL="0" lvl="0" indent="0" algn="ctr" defTabSz="1511300">
+            <a:lnSpc>
+              <a:spcPct val="90000"/>
+            </a:lnSpc>
+            <a:spcBef>
+              <a:spcPct val="0"/>
+            </a:spcBef>
+            <a:spcAft>
+              <a:spcPct val="35000"/>
+            </a:spcAft>
+            <a:buNone/>
+          </a:pPr>
+          <a:r>
+            <a:rPr lang="en-US" sz="3400" kern="1200" dirty="0"/>
+            <a:t>Selection</a:t>
+          </a:r>
+        </a:p>
+      </dsp:txBody>
+      <dsp:txXfrm>
+        <a:off x="2548244" y="564941"/>
+        <a:ext cx="2115523" cy="1298162"/>
+      </dsp:txXfrm>
+    </dsp:sp>
+    <dsp:sp modelId="{7DAC2FF7-8C69-8544-B207-8AD8ED8CC18E}">
+      <dsp:nvSpPr>
+        <dsp:cNvPr id="0" name=""/>
+        <dsp:cNvSpPr/>
+      </dsp:nvSpPr>
+      <dsp:spPr>
+        <a:xfrm>
+          <a:off x="3204537" y="1863103"/>
+          <a:ext cx="2884805" cy="2884805"/>
+        </a:xfrm>
+        <a:prstGeom prst="ellipse">
+          <a:avLst/>
+        </a:prstGeom>
+        <a:solidFill>
+          <a:schemeClr val="accent4">
+            <a:alpha val="50000"/>
+            <a:hueOff val="4900445"/>
+            <a:satOff val="-20388"/>
+            <a:lumOff val="4804"/>
+            <a:alphaOff val="0"/>
+          </a:schemeClr>
+        </a:solidFill>
+        <a:ln w="12700" cap="flat" cmpd="sng" algn="ctr">
+          <a:solidFill>
+            <a:schemeClr val="lt1">
+              <a:hueOff val="0"/>
+              <a:satOff val="0"/>
+              <a:lumOff val="0"/>
+              <a:alphaOff val="0"/>
+            </a:schemeClr>
+          </a:solidFill>
+          <a:prstDash val="solid"/>
+          <a:miter lim="800000"/>
+        </a:ln>
+        <a:effectLst/>
+      </dsp:spPr>
+      <dsp:style>
+        <a:lnRef idx="2">
+          <a:scrgbClr r="0" g="0" b="0"/>
+        </a:lnRef>
+        <a:fillRef idx="1">
+          <a:scrgbClr r="0" g="0" b="0"/>
+        </a:fillRef>
+        <a:effectRef idx="0">
+          <a:scrgbClr r="0" g="0" b="0"/>
+        </a:effectRef>
+        <a:fontRef idx="minor">
+          <a:schemeClr val="tx1"/>
+        </a:fontRef>
+      </dsp:style>
+      <dsp:txBody>
+        <a:bodyPr spcFirstLastPara="0" vert="horz" wrap="square" lIns="0" tIns="0" rIns="0" bIns="0" numCol="1" spcCol="1270" anchor="ctr" anchorCtr="0">
+          <a:noAutofit/>
+        </a:bodyPr>
+        <a:lstStyle/>
+        <a:p>
+          <a:pPr marL="0" lvl="0" indent="0" algn="ctr" defTabSz="1511300">
+            <a:lnSpc>
+              <a:spcPct val="90000"/>
+            </a:lnSpc>
+            <a:spcBef>
+              <a:spcPct val="0"/>
+            </a:spcBef>
+            <a:spcAft>
+              <a:spcPct val="35000"/>
+            </a:spcAft>
+            <a:buNone/>
+          </a:pPr>
+          <a:r>
+            <a:rPr lang="en-US" sz="3400" kern="1200" dirty="0"/>
+            <a:t>Dispersal</a:t>
+          </a:r>
+        </a:p>
+      </dsp:txBody>
+      <dsp:txXfrm>
+        <a:off x="4086807" y="2608344"/>
+        <a:ext cx="1730883" cy="1586642"/>
+      </dsp:txXfrm>
+    </dsp:sp>
+    <dsp:sp modelId="{C13988BE-4667-2C42-B802-C07898FB496F}">
+      <dsp:nvSpPr>
+        <dsp:cNvPr id="0" name=""/>
+        <dsp:cNvSpPr/>
+      </dsp:nvSpPr>
+      <dsp:spPr>
+        <a:xfrm>
+          <a:off x="1122669" y="1863103"/>
+          <a:ext cx="2884805" cy="2884805"/>
+        </a:xfrm>
+        <a:prstGeom prst="ellipse">
+          <a:avLst/>
+        </a:prstGeom>
+        <a:solidFill>
+          <a:schemeClr val="accent4">
+            <a:alpha val="50000"/>
+            <a:hueOff val="9800891"/>
+            <a:satOff val="-40777"/>
+            <a:lumOff val="9608"/>
+            <a:alphaOff val="0"/>
+          </a:schemeClr>
+        </a:solidFill>
+        <a:ln w="12700" cap="flat" cmpd="sng" algn="ctr">
+          <a:solidFill>
+            <a:schemeClr val="lt1">
+              <a:hueOff val="0"/>
+              <a:satOff val="0"/>
+              <a:lumOff val="0"/>
+              <a:alphaOff val="0"/>
+            </a:schemeClr>
+          </a:solidFill>
+          <a:prstDash val="solid"/>
+          <a:miter lim="800000"/>
+        </a:ln>
+        <a:effectLst/>
+      </dsp:spPr>
+      <dsp:style>
+        <a:lnRef idx="2">
+          <a:scrgbClr r="0" g="0" b="0"/>
+        </a:lnRef>
+        <a:fillRef idx="1">
+          <a:scrgbClr r="0" g="0" b="0"/>
+        </a:fillRef>
+        <a:effectRef idx="0">
+          <a:scrgbClr r="0" g="0" b="0"/>
+        </a:effectRef>
+        <a:fontRef idx="minor">
+          <a:schemeClr val="tx1"/>
+        </a:fontRef>
+      </dsp:style>
+      <dsp:txBody>
+        <a:bodyPr spcFirstLastPara="0" vert="horz" wrap="square" lIns="0" tIns="0" rIns="0" bIns="0" numCol="1" spcCol="1270" anchor="ctr" anchorCtr="0">
+          <a:noAutofit/>
+        </a:bodyPr>
+        <a:lstStyle/>
+        <a:p>
+          <a:pPr marL="0" lvl="0" indent="0" algn="ctr" defTabSz="1511300">
+            <a:lnSpc>
+              <a:spcPct val="90000"/>
+            </a:lnSpc>
+            <a:spcBef>
+              <a:spcPct val="0"/>
+            </a:spcBef>
+            <a:spcAft>
+              <a:spcPct val="35000"/>
+            </a:spcAft>
+            <a:buNone/>
+          </a:pPr>
+          <a:r>
+            <a:rPr lang="en-US" sz="3400" kern="1200" dirty="0"/>
+            <a:t>Ecological Drift</a:t>
+          </a:r>
+        </a:p>
+      </dsp:txBody>
+      <dsp:txXfrm>
+        <a:off x="1394322" y="2608344"/>
+        <a:ext cx="1730883" cy="1586642"/>
+      </dsp:txXfrm>
+    </dsp:sp>
+  </dsp:spTree>
+</dsp:drawing>
+</file>
+
+<file path=ppt/diagrams/drawing2.xml><?xml version="1.0" encoding="utf-8"?>
 <dsp:drawing xmlns:dgm="http://schemas.openxmlformats.org/drawingml/2006/diagram" xmlns:dsp="http://schemas.microsoft.com/office/drawing/2008/diagram" xmlns:a="http://schemas.openxmlformats.org/drawingml/2006/main">
   <dsp:spTree>
     <dsp:nvGrpSpPr>
@@ -2143,6 +3370,881 @@
 </file>
 
 <file path=ppt/diagrams/layout1.xml><?xml version="1.0" encoding="utf-8"?>
+<dgm:layoutDef xmlns:dgm="http://schemas.openxmlformats.org/drawingml/2006/diagram" xmlns:a="http://schemas.openxmlformats.org/drawingml/2006/main" uniqueId="urn:microsoft.com/office/officeart/2005/8/layout/venn1">
+  <dgm:title val=""/>
+  <dgm:desc val=""/>
+  <dgm:catLst>
+    <dgm:cat type="relationship" pri="28000"/>
+    <dgm:cat type="convert" pri="19000"/>
+  </dgm:catLst>
+  <dgm:sampData useDef="1">
+    <dgm:dataModel>
+      <dgm:ptLst/>
+      <dgm:bg/>
+      <dgm:whole/>
+    </dgm:dataModel>
+  </dgm:sampData>
+  <dgm:styleData useDef="1">
+    <dgm:dataModel>
+      <dgm:ptLst/>
+      <dgm:bg/>
+      <dgm:whole/>
+    </dgm:dataModel>
+  </dgm:styleData>
+  <dgm:clrData>
+    <dgm:dataModel>
+      <dgm:ptLst>
+        <dgm:pt modelId="0" type="doc"/>
+        <dgm:pt modelId="1"/>
+        <dgm:pt modelId="2"/>
+        <dgm:pt modelId="3"/>
+        <dgm:pt modelId="4"/>
+      </dgm:ptLst>
+      <dgm:cxnLst>
+        <dgm:cxn modelId="7" srcId="0" destId="1" srcOrd="0" destOrd="0"/>
+        <dgm:cxn modelId="8" srcId="0" destId="2" srcOrd="1" destOrd="0"/>
+        <dgm:cxn modelId="9" srcId="0" destId="3" srcOrd="2" destOrd="0"/>
+        <dgm:cxn modelId="10" srcId="0" destId="4" srcOrd="3" destOrd="0"/>
+      </dgm:cxnLst>
+      <dgm:bg/>
+      <dgm:whole/>
+    </dgm:dataModel>
+  </dgm:clrData>
+  <dgm:layoutNode name="compositeShape">
+    <dgm:varLst>
+      <dgm:chMax val="7"/>
+      <dgm:dir/>
+      <dgm:resizeHandles val="exact"/>
+    </dgm:varLst>
+    <dgm:choose name="Name0">
+      <dgm:if name="Name1" axis="ch" ptType="node" func="cnt" op="equ" val="1">
+        <dgm:alg type="composite">
+          <dgm:param type="ar" val="1"/>
+        </dgm:alg>
+      </dgm:if>
+      <dgm:if name="Name2" axis="ch" ptType="node" func="cnt" op="equ" val="2">
+        <dgm:alg type="composite">
+          <dgm:param type="ar" val="1.792"/>
+        </dgm:alg>
+      </dgm:if>
+      <dgm:if name="Name3" axis="ch" ptType="node" func="cnt" op="equ" val="3">
+        <dgm:alg type="composite">
+          <dgm:param type="ar" val="1"/>
+        </dgm:alg>
+      </dgm:if>
+      <dgm:if name="Name4" axis="ch" ptType="node" func="cnt" op="equ" val="4">
+        <dgm:alg type="composite">
+          <dgm:param type="ar" val="1"/>
+        </dgm:alg>
+      </dgm:if>
+      <dgm:if name="Name5" axis="ch" ptType="node" func="cnt" op="equ" val="5">
+        <dgm:alg type="composite">
+          <dgm:param type="ar" val="1.4"/>
+        </dgm:alg>
+      </dgm:if>
+      <dgm:if name="Name6" axis="ch" ptType="node" func="cnt" op="equ" val="6">
+        <dgm:alg type="composite">
+          <dgm:param type="ar" val="1.285"/>
+        </dgm:alg>
+      </dgm:if>
+      <dgm:if name="Name7" axis="ch" ptType="node" func="cnt" op="equ" val="7">
+        <dgm:alg type="composite">
+          <dgm:param type="ar" val="1.359"/>
+        </dgm:alg>
+      </dgm:if>
+      <dgm:else name="Name8">
+        <dgm:alg type="composite">
+          <dgm:param type="ar" val="1.359"/>
+        </dgm:alg>
+      </dgm:else>
+    </dgm:choose>
+    <dgm:shape xmlns:r="http://schemas.openxmlformats.org/officeDocument/2006/relationships" r:blip="">
+      <dgm:adjLst/>
+    </dgm:shape>
+    <dgm:presOf/>
+    <dgm:choose name="Name9">
+      <dgm:if name="Name10" axis="ch" ptType="node" func="cnt" op="equ" val="1">
+        <dgm:constrLst>
+          <dgm:constr type="ctrX" for="ch" forName="circ1TxSh" refType="w" fact="0.5"/>
+          <dgm:constr type="ctrY" for="ch" forName="circ1TxSh" refType="h" fact="0.5"/>
+          <dgm:constr type="w" for="ch" forName="circ1TxSh" refType="w"/>
+          <dgm:constr type="h" for="ch" forName="circ1TxSh" refType="h"/>
+          <dgm:constr type="primFontSz" for="ch" ptType="node" op="equ"/>
+        </dgm:constrLst>
+      </dgm:if>
+      <dgm:if name="Name11" axis="ch" ptType="node" func="cnt" op="equ" val="2">
+        <dgm:constrLst>
+          <dgm:constr type="ctrX" for="ch" forName="circ1" refType="w" fact="0.3"/>
+          <dgm:constr type="ctrY" for="ch" forName="circ1" refType="h" fact="0.5"/>
+          <dgm:constr type="w" for="ch" forName="circ1" refType="w" fact="0.555"/>
+          <dgm:constr type="h" for="ch" forName="circ1" refType="h" fact="0.99456"/>
+          <dgm:constr type="l" for="ch" forName="circ1Tx" refType="w" fact="0.1"/>
+          <dgm:constr type="t" for="ch" forName="circ1Tx" refType="h" fact="0.12"/>
+          <dgm:constr type="w" for="ch" forName="circ1Tx" refType="w" fact="0.32"/>
+          <dgm:constr type="h" for="ch" forName="circ1Tx" refType="h" fact="0.76"/>
+          <dgm:constr type="ctrX" for="ch" forName="circ2" refType="w" fact="0.7"/>
+          <dgm:constr type="ctrY" for="ch" forName="circ2" refType="h" fact="0.5"/>
+          <dgm:constr type="w" for="ch" forName="circ2" refType="w" fact="0.555"/>
+          <dgm:constr type="h" for="ch" forName="circ2" refType="h" fact="0.99456"/>
+          <dgm:constr type="l" for="ch" forName="circ2Tx" refType="w" fact="0.58"/>
+          <dgm:constr type="t" for="ch" forName="circ2Tx" refType="h" fact="0.12"/>
+          <dgm:constr type="w" for="ch" forName="circ2Tx" refType="w" fact="0.32"/>
+          <dgm:constr type="h" for="ch" forName="circ2Tx" refType="h" fact="0.76"/>
+          <dgm:constr type="primFontSz" for="ch" ptType="node" op="equ"/>
+        </dgm:constrLst>
+      </dgm:if>
+      <dgm:if name="Name12" axis="ch" ptType="node" func="cnt" op="equ" val="3">
+        <dgm:constrLst>
+          <dgm:constr type="ctrX" for="ch" forName="circ1" refType="w" fact="0.5"/>
+          <dgm:constr type="ctrY" for="ch" forName="circ1" refType="w" fact="0.25"/>
+          <dgm:constr type="w" for="ch" forName="circ1" refType="w" fact="0.6"/>
+          <dgm:constr type="h" for="ch" forName="circ1" refType="h" fact="0.6"/>
+          <dgm:constr type="l" for="ch" forName="circ1Tx" refType="w" fact="0.28"/>
+          <dgm:constr type="t" for="ch" forName="circ1Tx" refType="h" fact="0.055"/>
+          <dgm:constr type="w" for="ch" forName="circ1Tx" refType="w" fact="0.44"/>
+          <dgm:constr type="h" for="ch" forName="circ1Tx" refType="h" fact="0.27"/>
+          <dgm:constr type="ctrX" for="ch" forName="circ2" refType="w" fact="0.7165"/>
+          <dgm:constr type="ctrY" for="ch" forName="circ2" refType="w" fact="0.625"/>
+          <dgm:constr type="w" for="ch" forName="circ2" refType="w" fact="0.6"/>
+          <dgm:constr type="h" for="ch" forName="circ2" refType="h" fact="0.6"/>
+          <dgm:constr type="l" for="ch" forName="circ2Tx" refType="w" fact="0.6"/>
+          <dgm:constr type="t" for="ch" forName="circ2Tx" refType="h" fact="0.48"/>
+          <dgm:constr type="w" for="ch" forName="circ2Tx" refType="w" fact="0.36"/>
+          <dgm:constr type="h" for="ch" forName="circ2Tx" refType="h" fact="0.33"/>
+          <dgm:constr type="ctrX" for="ch" forName="circ3" refType="w" fact="0.2835"/>
+          <dgm:constr type="ctrY" for="ch" forName="circ3" refType="w" fact="0.625"/>
+          <dgm:constr type="w" for="ch" forName="circ3" refType="w" fact="0.6"/>
+          <dgm:constr type="h" for="ch" forName="circ3" refType="h" fact="0.6"/>
+          <dgm:constr type="l" for="ch" forName="circ3Tx" refType="w" fact="0.04"/>
+          <dgm:constr type="t" for="ch" forName="circ3Tx" refType="h" fact="0.48"/>
+          <dgm:constr type="w" for="ch" forName="circ3Tx" refType="w" fact="0.36"/>
+          <dgm:constr type="h" for="ch" forName="circ3Tx" refType="h" fact="0.33"/>
+          <dgm:constr type="primFontSz" for="ch" ptType="node" op="equ"/>
+        </dgm:constrLst>
+      </dgm:if>
+      <dgm:if name="Name13" axis="ch" ptType="node" func="cnt" op="equ" val="4">
+        <dgm:constrLst>
+          <dgm:constr type="ctrX" for="ch" forName="circ1" refType="w" fact="0.5"/>
+          <dgm:constr type="ctrY" for="ch" forName="circ1" refType="w" fact="0.27"/>
+          <dgm:constr type="w" for="ch" forName="circ1" refType="w" fact="0.52"/>
+          <dgm:constr type="h" for="ch" forName="circ1" refType="h" fact="0.52"/>
+          <dgm:constr type="l" for="ch" forName="circ1Tx" refType="w" fact="0.3"/>
+          <dgm:constr type="t" for="ch" forName="circ1Tx" refType="h" fact="0.08"/>
+          <dgm:constr type="w" for="ch" forName="circ1Tx" refType="w" fact="0.4"/>
+          <dgm:constr type="h" for="ch" forName="circ1Tx" refType="h" fact="0.165"/>
+          <dgm:constr type="ctrX" for="ch" forName="circ2" refType="w" fact="0.73"/>
+          <dgm:constr type="ctrY" for="ch" forName="circ2" refType="w" fact="0.5"/>
+          <dgm:constr type="w" for="ch" forName="circ2" refType="w" fact="0.52"/>
+          <dgm:constr type="h" for="ch" forName="circ2" refType="h" fact="0.52"/>
+          <dgm:constr type="r" for="ch" forName="circ2Tx" refType="w" fact="0.95"/>
+          <dgm:constr type="t" for="ch" forName="circ2Tx" refType="h" fact="0.3"/>
+          <dgm:constr type="w" for="ch" forName="circ2Tx" refType="w" fact="0.2"/>
+          <dgm:constr type="h" for="ch" forName="circ2Tx" refType="h" fact="0.4"/>
+          <dgm:constr type="ctrX" for="ch" forName="circ3" refType="w" fact="0.5"/>
+          <dgm:constr type="ctrY" for="ch" forName="circ3" refType="w" fact="0.73"/>
+          <dgm:constr type="w" for="ch" forName="circ3" refType="w" fact="0.52"/>
+          <dgm:constr type="h" for="ch" forName="circ3" refType="h" fact="0.52"/>
+          <dgm:constr type="l" for="ch" forName="circ3Tx" refType="w" fact="0.3"/>
+          <dgm:constr type="b" for="ch" forName="circ3Tx" refType="h" fact="0.92"/>
+          <dgm:constr type="w" for="ch" forName="circ3Tx" refType="w" fact="0.4"/>
+          <dgm:constr type="h" for="ch" forName="circ3Tx" refType="h" fact="0.165"/>
+          <dgm:constr type="ctrX" for="ch" forName="circ4" refType="w" fact="0.27"/>
+          <dgm:constr type="ctrY" for="ch" forName="circ4" refType="h" fact="0.5"/>
+          <dgm:constr type="w" for="ch" forName="circ4" refType="w" fact="0.52"/>
+          <dgm:constr type="h" for="ch" forName="circ4" refType="h" fact="0.52"/>
+          <dgm:constr type="l" for="ch" forName="circ4Tx" refType="w" fact="0.05"/>
+          <dgm:constr type="t" for="ch" forName="circ4Tx" refType="h" fact="0.3"/>
+          <dgm:constr type="w" for="ch" forName="circ4Tx" refType="w" fact="0.2"/>
+          <dgm:constr type="h" for="ch" forName="circ4Tx" refType="h" fact="0.4"/>
+          <dgm:constr type="primFontSz" for="ch" ptType="node" op="equ"/>
+        </dgm:constrLst>
+      </dgm:if>
+      <dgm:if name="Name14" axis="ch" ptType="node" func="cnt" op="equ" val="5">
+        <dgm:constrLst>
+          <dgm:constr type="ctrX" for="ch" forName="circ1" refType="w" fact="0.5"/>
+          <dgm:constr type="ctrY" for="ch" forName="circ1" refType="h" fact="0.46"/>
+          <dgm:constr type="w" for="ch" forName="circ1" refType="w" fact="0.25"/>
+          <dgm:constr type="h" for="ch" forName="circ1" refType="h" fact="0.35"/>
+          <dgm:constr type="l" for="ch" forName="circ1Tx" refType="w" fact="0.355"/>
+          <dgm:constr type="t" for="ch" forName="circ1Tx"/>
+          <dgm:constr type="w" for="ch" forName="circ1Tx" refType="w" fact="0.29"/>
+          <dgm:constr type="h" for="ch" forName="circ1Tx" refType="h" fact="0.235"/>
+          <dgm:constr type="ctrX" for="ch" forName="circ2" refType="w" fact="0.5951"/>
+          <dgm:constr type="ctrY" for="ch" forName="circ2" refType="h" fact="0.5567"/>
+          <dgm:constr type="w" for="ch" forName="circ2" refType="w" fact="0.25"/>
+          <dgm:constr type="h" for="ch" forName="circ2" refType="h" fact="0.35"/>
+          <dgm:constr type="l" for="ch" forName="circ2Tx" refType="w" fact="0.74"/>
+          <dgm:constr type="t" for="ch" forName="circ2Tx" refType="h" fact="0.31"/>
+          <dgm:constr type="w" for="ch" forName="circ2Tx" refType="w" fact="0.26"/>
+          <dgm:constr type="h" for="ch" forName="circ2Tx" refType="h" fact="0.255"/>
+          <dgm:constr type="ctrX" for="ch" forName="circ3" refType="w" fact="0.5588"/>
+          <dgm:constr type="ctrY" for="ch" forName="circ3" refType="h" fact="0.7133"/>
+          <dgm:constr type="w" for="ch" forName="circ3" refType="w" fact="0.25"/>
+          <dgm:constr type="h" for="ch" forName="circ3" refType="h" fact="0.35"/>
+          <dgm:constr type="l" for="ch" forName="circ3Tx" refType="w" fact="0.7"/>
+          <dgm:constr type="t" for="ch" forName="circ3Tx" refType="h" fact="0.745"/>
+          <dgm:constr type="w" for="ch" forName="circ3Tx" refType="w" fact="0.26"/>
+          <dgm:constr type="h" for="ch" forName="circ3Tx" refType="h" fact="0.255"/>
+          <dgm:constr type="ctrX" for="ch" forName="circ4" refType="w" fact="0.4412"/>
+          <dgm:constr type="ctrY" for="ch" forName="circ4" refType="h" fact="0.7133"/>
+          <dgm:constr type="w" for="ch" forName="circ4" refType="w" fact="0.25"/>
+          <dgm:constr type="h" for="ch" forName="circ4" refType="h" fact="0.35"/>
+          <dgm:constr type="l" for="ch" forName="circ4Tx" refType="w" fact="0.04"/>
+          <dgm:constr type="t" for="ch" forName="circ4Tx" refType="h" fact="0.745"/>
+          <dgm:constr type="w" for="ch" forName="circ4Tx" refType="w" fact="0.26"/>
+          <dgm:constr type="h" for="ch" forName="circ4Tx" refType="h" fact="0.255"/>
+          <dgm:constr type="ctrX" for="ch" forName="circ5" refType="w" fact="0.4049"/>
+          <dgm:constr type="ctrY" for="ch" forName="circ5" refType="h" fact="0.5567"/>
+          <dgm:constr type="w" for="ch" forName="circ5" refType="w" fact="0.25"/>
+          <dgm:constr type="h" for="ch" forName="circ5" refType="h" fact="0.35"/>
+          <dgm:constr type="l" for="ch" forName="circ5Tx"/>
+          <dgm:constr type="t" for="ch" forName="circ5Tx" refType="h" fact="0.31"/>
+          <dgm:constr type="w" for="ch" forName="circ5Tx" refType="w" fact="0.26"/>
+          <dgm:constr type="h" for="ch" forName="circ5Tx" refType="h" fact="0.255"/>
+          <dgm:constr type="primFontSz" for="ch" ptType="node" op="equ"/>
+        </dgm:constrLst>
+      </dgm:if>
+      <dgm:if name="Name15" axis="ch" ptType="node" func="cnt" op="equ" val="6">
+        <dgm:constrLst>
+          <dgm:constr type="ctrX" for="ch" forName="circ1" refType="w" fact="0.5"/>
+          <dgm:constr type="ctrY" for="ch" forName="circ1" refType="h" fact="0.3844"/>
+          <dgm:constr type="w" for="ch" forName="circ1" refType="w" fact="0.24"/>
+          <dgm:constr type="h" for="ch" forName="circ1" refType="h" fact="0.3084"/>
+          <dgm:constr type="l" for="ch" forName="circ1Tx" refType="w" fact="0.35"/>
+          <dgm:constr type="t" for="ch" forName="circ1Tx"/>
+          <dgm:constr type="w" for="ch" forName="circ1Tx" refType="w" fact="0.3"/>
+          <dgm:constr type="h" for="ch" forName="circ1Tx" refType="h" fact="0.21"/>
+          <dgm:constr type="ctrX" for="ch" forName="circ2" refType="w" fact="0.5779"/>
+          <dgm:constr type="ctrY" for="ch" forName="circ2" refType="h" fact="0.4422"/>
+          <dgm:constr type="w" for="ch" forName="circ2" refType="w" fact="0.24"/>
+          <dgm:constr type="h" for="ch" forName="circ2" refType="h" fact="0.3084"/>
+          <dgm:constr type="l" for="ch" forName="circ2Tx" refType="w" fact="0.7157"/>
+          <dgm:constr type="t" for="ch" forName="circ2Tx" refType="h" fact="0.2"/>
+          <dgm:constr type="w" for="ch" forName="circ2Tx" refType="w" fact="0.2843"/>
+          <dgm:constr type="h" for="ch" forName="circ2Tx" refType="h" fact="0.23"/>
+          <dgm:constr type="ctrX" for="ch" forName="circ3" refType="w" fact="0.5779"/>
+          <dgm:constr type="ctrY" for="ch" forName="circ3" refType="h" fact="0.5578"/>
+          <dgm:constr type="w" for="ch" forName="circ3" refType="w" fact="0.24"/>
+          <dgm:constr type="h" for="ch" forName="circ3" refType="h" fact="0.3084"/>
+          <dgm:constr type="l" for="ch" forName="circ3Tx" refType="w" fact="0.7157"/>
+          <dgm:constr type="t" for="ch" forName="circ3Tx" refType="h" fact="0.543"/>
+          <dgm:constr type="w" for="ch" forName="circ3Tx" refType="w" fact="0.2843"/>
+          <dgm:constr type="h" for="ch" forName="circ3Tx" refType="h" fact="0.257"/>
+          <dgm:constr type="ctrX" for="ch" forName="circ4" refType="w" fact="0.5"/>
+          <dgm:constr type="ctrY" for="ch" forName="circ4" refType="h" fact="0.6157"/>
+          <dgm:constr type="w" for="ch" forName="circ4" refType="w" fact="0.24"/>
+          <dgm:constr type="h" for="ch" forName="circ4" refType="h" fact="0.3084"/>
+          <dgm:constr type="l" for="ch" forName="circ4Tx" refType="w" fact="0.35"/>
+          <dgm:constr type="t" for="ch" forName="circ4Tx" refType="h" fact="0.79"/>
+          <dgm:constr type="w" for="ch" forName="circ4Tx" refType="w" fact="0.3"/>
+          <dgm:constr type="h" for="ch" forName="circ4Tx" refType="h" fact="0.21"/>
+          <dgm:constr type="ctrX" for="ch" forName="circ5" refType="w" fact="0.4221"/>
+          <dgm:constr type="ctrY" for="ch" forName="circ5" refType="h" fact="0.5578"/>
+          <dgm:constr type="w" for="ch" forName="circ5" refType="w" fact="0.24"/>
+          <dgm:constr type="h" for="ch" forName="circ5" refType="h" fact="0.3084"/>
+          <dgm:constr type="l" for="ch" forName="circ5Tx" refType="w" fact="0"/>
+          <dgm:constr type="t" for="ch" forName="circ5Tx" refType="h" fact="0.543"/>
+          <dgm:constr type="w" for="ch" forName="circ5Tx" refType="w" fact="0.2843"/>
+          <dgm:constr type="h" for="ch" forName="circ5Tx" refType="h" fact="0.257"/>
+          <dgm:constr type="ctrX" for="ch" forName="circ6" refType="w" fact="0.4221"/>
+          <dgm:constr type="ctrY" for="ch" forName="circ6" refType="h" fact="0.4422"/>
+          <dgm:constr type="w" for="ch" forName="circ6" refType="w" fact="0.24"/>
+          <dgm:constr type="h" for="ch" forName="circ6" refType="h" fact="0.3084"/>
+          <dgm:constr type="l" for="ch" forName="circ6Tx" refType="w" fact="0"/>
+          <dgm:constr type="t" for="ch" forName="circ6Tx" refType="h" fact="0.2"/>
+          <dgm:constr type="w" for="ch" forName="circ6Tx" refType="w" fact="0.2843"/>
+          <dgm:constr type="h" for="ch" forName="circ6Tx" refType="h" fact="0.257"/>
+          <dgm:constr type="primFontSz" for="ch" ptType="node" op="equ"/>
+        </dgm:constrLst>
+      </dgm:if>
+      <dgm:else name="Name16">
+        <dgm:constrLst>
+          <dgm:constr type="ctrX" for="ch" forName="circ1" refType="w" fact="0.5"/>
+          <dgm:constr type="ctrY" for="ch" forName="circ1" refType="h" fact="0.4177"/>
+          <dgm:constr type="w" for="ch" forName="circ1" refType="w" fact="0.24"/>
+          <dgm:constr type="h" for="ch" forName="circ1" refType="h" fact="0.3262"/>
+          <dgm:constr type="l" for="ch" forName="circ1Tx" refType="w" fact="0.3625"/>
+          <dgm:constr type="t" for="ch" forName="circ1Tx"/>
+          <dgm:constr type="w" for="ch" forName="circ1Tx" refType="w" fact="0.275"/>
+          <dgm:constr type="h" for="ch" forName="circ1Tx" refType="h" fact="0.2"/>
+          <dgm:constr type="ctrX" for="ch" forName="circ2" refType="w" fact="0.5704"/>
+          <dgm:constr type="ctrY" for="ch" forName="circ2" refType="h" fact="0.4637"/>
+          <dgm:constr type="w" for="ch" forName="circ2" refType="w" fact="0.24"/>
+          <dgm:constr type="h" for="ch" forName="circ2" refType="h" fact="0.3262"/>
+          <dgm:constr type="l" for="ch" forName="circ2Tx" refType="w" fact="0.72"/>
+          <dgm:constr type="t" for="ch" forName="circ2Tx" refType="h" fact="0.19"/>
+          <dgm:constr type="w" for="ch" forName="circ2Tx" refType="w" fact="0.26"/>
+          <dgm:constr type="h" for="ch" forName="circ2Tx" refType="h" fact="0.22"/>
+          <dgm:constr type="ctrX" for="ch" forName="circ3" refType="w" fact="0.5877"/>
+          <dgm:constr type="ctrY" for="ch" forName="circ3" refType="h" fact="0.5672"/>
+          <dgm:constr type="w" for="ch" forName="circ3" refType="w" fact="0.24"/>
+          <dgm:constr type="h" for="ch" forName="circ3" refType="h" fact="0.3262"/>
+          <dgm:constr type="l" for="ch" forName="circ3Tx" refType="w" fact="0.745"/>
+          <dgm:constr type="t" for="ch" forName="circ3Tx" refType="h" fact="0.47"/>
+          <dgm:constr type="w" for="ch" forName="circ3Tx" refType="w" fact="0.255"/>
+          <dgm:constr type="h" for="ch" forName="circ3Tx" refType="h" fact="0.235"/>
+          <dgm:constr type="ctrX" for="ch" forName="circ4" refType="w" fact="0.539"/>
+          <dgm:constr type="ctrY" for="ch" forName="circ4" refType="h" fact="0.6502"/>
+          <dgm:constr type="w" for="ch" forName="circ4" refType="w" fact="0.24"/>
+          <dgm:constr type="h" for="ch" forName="circ4" refType="h" fact="0.3262"/>
+          <dgm:constr type="l" for="ch" forName="circ4Tx" refType="w" fact="0.635"/>
+          <dgm:constr type="t" for="ch" forName="circ4Tx" refType="h" fact="0.785"/>
+          <dgm:constr type="w" for="ch" forName="circ4Tx" refType="w" fact="0.275"/>
+          <dgm:constr type="h" for="ch" forName="circ4Tx" refType="h" fact="0.215"/>
+          <dgm:constr type="ctrX" for="ch" forName="circ5" refType="w" fact="0.461"/>
+          <dgm:constr type="ctrY" for="ch" forName="circ5" refType="h" fact="0.6502"/>
+          <dgm:constr type="w" for="ch" forName="circ5" refType="w" fact="0.24"/>
+          <dgm:constr type="h" for="ch" forName="circ5" refType="h" fact="0.3262"/>
+          <dgm:constr type="l" for="ch" forName="circ5Tx" refType="w" fact="0.09"/>
+          <dgm:constr type="t" for="ch" forName="circ5Tx" refType="h" fact="0.785"/>
+          <dgm:constr type="w" for="ch" forName="circ5Tx" refType="w" fact="0.275"/>
+          <dgm:constr type="h" for="ch" forName="circ5Tx" refType="h" fact="0.215"/>
+          <dgm:constr type="ctrX" for="ch" forName="circ6" refType="w" fact="0.4123"/>
+          <dgm:constr type="ctrY" for="ch" forName="circ6" refType="h" fact="0.5672"/>
+          <dgm:constr type="w" for="ch" forName="circ6" refType="w" fact="0.24"/>
+          <dgm:constr type="h" for="ch" forName="circ6" refType="h" fact="0.3262"/>
+          <dgm:constr type="l" for="ch" forName="circ6Tx"/>
+          <dgm:constr type="t" for="ch" forName="circ6Tx" refType="h" fact="0.47"/>
+          <dgm:constr type="w" for="ch" forName="circ6Tx" refType="w" fact="0.255"/>
+          <dgm:constr type="h" for="ch" forName="circ6Tx" refType="h" fact="0.235"/>
+          <dgm:constr type="ctrX" for="ch" forName="circ7" refType="w" fact="0.4296"/>
+          <dgm:constr type="ctrY" for="ch" forName="circ7" refType="h" fact="0.4637"/>
+          <dgm:constr type="w" for="ch" forName="circ7" refType="w" fact="0.24"/>
+          <dgm:constr type="h" for="ch" forName="circ7" refType="h" fact="0.3262"/>
+          <dgm:constr type="l" for="ch" forName="circ7Tx" refType="w" fact="0.02"/>
+          <dgm:constr type="t" for="ch" forName="circ7Tx" refType="h" fact="0.19"/>
+          <dgm:constr type="w" for="ch" forName="circ7Tx" refType="w" fact="0.26"/>
+          <dgm:constr type="h" for="ch" forName="circ7Tx" refType="h" fact="0.22"/>
+          <dgm:constr type="primFontSz" for="ch" ptType="node" op="equ"/>
+        </dgm:constrLst>
+      </dgm:else>
+    </dgm:choose>
+    <dgm:ruleLst/>
+    <dgm:forEach name="Name17" axis="ch" ptType="node" cnt="1">
+      <dgm:choose name="Name18">
+        <dgm:if name="Name19" axis="root ch" ptType="all node" func="cnt" op="equ" val="1">
+          <dgm:layoutNode name="circ1TxSh" styleLbl="vennNode1">
+            <dgm:alg type="tx">
+              <dgm:param type="txAnchorHorzCh" val="ctr"/>
+              <dgm:param type="txAnchorVertCh" val="mid"/>
+            </dgm:alg>
+            <dgm:shape xmlns:r="http://schemas.openxmlformats.org/officeDocument/2006/relationships" type="ellipse" r:blip="">
+              <dgm:adjLst/>
+            </dgm:shape>
+            <dgm:choose name="Name20">
+              <dgm:if name="Name21" func="var" arg="dir" op="equ" val="norm">
+                <dgm:choose name="Name22">
+                  <dgm:if name="Name23" axis="root ch" ptType="all node" func="cnt" op="lte" val="4">
+                    <dgm:presOf axis="desOrSelf" ptType="node"/>
+                  </dgm:if>
+                  <dgm:else name="Name24">
+                    <dgm:presOf/>
+                  </dgm:else>
+                </dgm:choose>
+              </dgm:if>
+              <dgm:else name="Name25">
+                <dgm:choose name="Name26">
+                  <dgm:if name="Name27" axis="root ch" ptType="all node" func="cnt" op="equ" val="2">
+                    <dgm:presOf axis="root ch desOrSelf" ptType="all node node" st="1 2 1" cnt="1 1 0"/>
+                  </dgm:if>
+                  <dgm:else name="Name28">
+                    <dgm:presOf axis="desOrSelf" ptType="node"/>
+                  </dgm:else>
+                </dgm:choose>
+              </dgm:else>
+            </dgm:choose>
+            <dgm:constrLst>
+              <dgm:constr type="tMarg"/>
+              <dgm:constr type="bMarg"/>
+              <dgm:constr type="lMarg"/>
+              <dgm:constr type="rMarg"/>
+              <dgm:constr type="primFontSz" val="65"/>
+            </dgm:constrLst>
+            <dgm:ruleLst>
+              <dgm:rule type="primFontSz" val="5" fact="NaN" max="NaN"/>
+            </dgm:ruleLst>
+          </dgm:layoutNode>
+        </dgm:if>
+        <dgm:else name="Name29">
+          <dgm:layoutNode name="circ1" styleLbl="vennNode1">
+            <dgm:alg type="sp"/>
+            <dgm:shape xmlns:r="http://schemas.openxmlformats.org/officeDocument/2006/relationships" type="ellipse" r:blip="">
+              <dgm:adjLst/>
+            </dgm:shape>
+            <dgm:choose name="Name30">
+              <dgm:if name="Name31" func="var" arg="dir" op="equ" val="norm">
+                <dgm:choose name="Name32">
+                  <dgm:if name="Name33" axis="root ch" ptType="all node" func="cnt" op="lte" val="4">
+                    <dgm:presOf axis="desOrSelf" ptType="node"/>
+                  </dgm:if>
+                  <dgm:else name="Name34">
+                    <dgm:presOf/>
+                  </dgm:else>
+                </dgm:choose>
+              </dgm:if>
+              <dgm:else name="Name35">
+                <dgm:choose name="Name36">
+                  <dgm:if name="Name37" axis="root ch" ptType="all node" func="cnt" op="equ" val="2">
+                    <dgm:presOf axis="root ch desOrSelf" ptType="all node node" st="1 2 1" cnt="1 1 0"/>
+                  </dgm:if>
+                  <dgm:else name="Name38">
+                    <dgm:choose name="Name39">
+                      <dgm:if name="Name40" axis="root ch" ptType="all node" func="cnt" op="lte" val="4">
+                        <dgm:presOf axis="desOrSelf" ptType="node"/>
+                      </dgm:if>
+                      <dgm:else name="Name41">
+                        <dgm:presOf/>
+                      </dgm:else>
+                    </dgm:choose>
+                  </dgm:else>
+                </dgm:choose>
+              </dgm:else>
+            </dgm:choose>
+            <dgm:constrLst/>
+            <dgm:ruleLst/>
+          </dgm:layoutNode>
+          <dgm:layoutNode name="circ1Tx" styleLbl="revTx">
+            <dgm:varLst>
+              <dgm:chMax val="0"/>
+              <dgm:chPref val="0"/>
+              <dgm:bulletEnabled val="1"/>
+            </dgm:varLst>
+            <dgm:alg type="tx">
+              <dgm:param type="txAnchorHorzCh" val="ctr"/>
+              <dgm:param type="txAnchorVertCh" val="mid"/>
+            </dgm:alg>
+            <dgm:shape xmlns:r="http://schemas.openxmlformats.org/officeDocument/2006/relationships" type="rect" r:blip="" hideGeom="1">
+              <dgm:adjLst/>
+            </dgm:shape>
+            <dgm:choose name="Name42">
+              <dgm:if name="Name43" func="var" arg="dir" op="equ" val="norm">
+                <dgm:presOf axis="desOrSelf" ptType="node"/>
+              </dgm:if>
+              <dgm:else name="Name44">
+                <dgm:choose name="Name45">
+                  <dgm:if name="Name46" axis="root ch" ptType="all node" func="cnt" op="equ" val="2">
+                    <dgm:presOf axis="root ch desOrSelf" ptType="all node node" st="1 2 1" cnt="1 1 0"/>
+                  </dgm:if>
+                  <dgm:else name="Name47">
+                    <dgm:presOf axis="desOrSelf" ptType="node"/>
+                  </dgm:else>
+                </dgm:choose>
+              </dgm:else>
+            </dgm:choose>
+            <dgm:constrLst>
+              <dgm:constr type="tMarg"/>
+              <dgm:constr type="bMarg"/>
+              <dgm:constr type="lMarg"/>
+              <dgm:constr type="rMarg"/>
+              <dgm:constr type="primFontSz" val="65"/>
+            </dgm:constrLst>
+            <dgm:ruleLst>
+              <dgm:rule type="primFontSz" val="5" fact="NaN" max="NaN"/>
+            </dgm:ruleLst>
+          </dgm:layoutNode>
+        </dgm:else>
+      </dgm:choose>
+    </dgm:forEach>
+    <dgm:forEach name="Name48" axis="ch" ptType="node" st="2" cnt="1">
+      <dgm:layoutNode name="circ2" styleLbl="vennNode1">
+        <dgm:alg type="sp"/>
+        <dgm:shape xmlns:r="http://schemas.openxmlformats.org/officeDocument/2006/relationships" type="ellipse" r:blip="">
+          <dgm:adjLst/>
+        </dgm:shape>
+        <dgm:choose name="Name49">
+          <dgm:if name="Name50" func="var" arg="dir" op="equ" val="norm">
+            <dgm:choose name="Name51">
+              <dgm:if name="Name52" axis="root ch" ptType="all node" func="cnt" op="lte" val="4">
+                <dgm:presOf axis="desOrSelf" ptType="node"/>
+              </dgm:if>
+              <dgm:else name="Name53">
+                <dgm:presOf/>
+              </dgm:else>
+            </dgm:choose>
+          </dgm:if>
+          <dgm:else name="Name54">
+            <dgm:choose name="Name55">
+              <dgm:if name="Name56" axis="root ch" ptType="all node" func="cnt" op="equ" val="2">
+                <dgm:presOf axis="root ch desOrSelf" ptType="all node node" st="1 1 1" cnt="1 1 0"/>
+              </dgm:if>
+              <dgm:if name="Name57" axis="root ch" ptType="all node" func="cnt" op="equ" val="3">
+                <dgm:presOf axis="root ch desOrSelf" ptType="all node node" st="1 3 1" cnt="1 1 0"/>
+              </dgm:if>
+              <dgm:if name="Name58" axis="root ch" ptType="all node" func="cnt" op="equ" val="4">
+                <dgm:presOf axis="root ch desOrSelf" ptType="all node node" st="1 4 1" cnt="1 1 0"/>
+              </dgm:if>
+              <dgm:else name="Name59">
+                <dgm:presOf/>
+              </dgm:else>
+            </dgm:choose>
+          </dgm:else>
+        </dgm:choose>
+        <dgm:constrLst/>
+        <dgm:ruleLst/>
+      </dgm:layoutNode>
+      <dgm:layoutNode name="circ2Tx" styleLbl="revTx">
+        <dgm:varLst>
+          <dgm:chMax val="0"/>
+          <dgm:chPref val="0"/>
+          <dgm:bulletEnabled val="1"/>
+        </dgm:varLst>
+        <dgm:alg type="tx">
+          <dgm:param type="txAnchorHorzCh" val="ctr"/>
+          <dgm:param type="txAnchorVertCh" val="mid"/>
+        </dgm:alg>
+        <dgm:shape xmlns:r="http://schemas.openxmlformats.org/officeDocument/2006/relationships" type="rect" r:blip="" hideGeom="1">
+          <dgm:adjLst/>
+        </dgm:shape>
+        <dgm:choose name="Name60">
+          <dgm:if name="Name61" func="var" arg="dir" op="equ" val="norm">
+            <dgm:presOf axis="desOrSelf" ptType="node"/>
+          </dgm:if>
+          <dgm:else name="Name62">
+            <dgm:choose name="Name63">
+              <dgm:if name="Name64" axis="root ch" ptType="all node" func="cnt" op="equ" val="2">
+                <dgm:presOf axis="root ch desOrSelf" ptType="all node node" st="1 1 1" cnt="1 1 0"/>
+              </dgm:if>
+              <dgm:if name="Name65" axis="root ch" ptType="all node" func="cnt" op="equ" val="3">
+                <dgm:presOf axis="root ch desOrSelf" ptType="all node node" st="1 3 1" cnt="1 1 0"/>
+              </dgm:if>
+              <dgm:if name="Name66" axis="root ch" ptType="all node" func="cnt" op="equ" val="4">
+                <dgm:presOf axis="root ch desOrSelf" ptType="all node node" st="1 4 1" cnt="1 1 0"/>
+              </dgm:if>
+              <dgm:if name="Name67" axis="root ch" ptType="all node" func="cnt" op="equ" val="5">
+                <dgm:presOf axis="root ch desOrSelf" ptType="all node node" st="1 5 1" cnt="1 1 0"/>
+              </dgm:if>
+              <dgm:if name="Name68" axis="root ch" ptType="all node" func="cnt" op="equ" val="6">
+                <dgm:presOf axis="root ch desOrSelf" ptType="all node node" st="1 6 1" cnt="1 1 0"/>
+              </dgm:if>
+              <dgm:else name="Name69">
+                <dgm:presOf axis="root ch desOrSelf" ptType="all node node" st="1 7 1" cnt="1 1 0"/>
+              </dgm:else>
+            </dgm:choose>
+          </dgm:else>
+        </dgm:choose>
+        <dgm:constrLst>
+          <dgm:constr type="tMarg"/>
+          <dgm:constr type="bMarg"/>
+          <dgm:constr type="lMarg"/>
+          <dgm:constr type="rMarg"/>
+          <dgm:constr type="primFontSz" val="65"/>
+        </dgm:constrLst>
+        <dgm:ruleLst>
+          <dgm:rule type="primFontSz" val="5" fact="NaN" max="NaN"/>
+        </dgm:ruleLst>
+      </dgm:layoutNode>
+    </dgm:forEach>
+    <dgm:forEach name="Name70" axis="ch" ptType="node" st="3" cnt="1">
+      <dgm:layoutNode name="circ3" styleLbl="vennNode1">
+        <dgm:alg type="sp"/>
+        <dgm:shape xmlns:r="http://schemas.openxmlformats.org/officeDocument/2006/relationships" type="ellipse" r:blip="">
+          <dgm:adjLst/>
+        </dgm:shape>
+        <dgm:choose name="Name71">
+          <dgm:if name="Name72" func="var" arg="dir" op="equ" val="norm">
+            <dgm:choose name="Name73">
+              <dgm:if name="Name74" axis="root ch" ptType="all node" func="cnt" op="lte" val="4">
+                <dgm:presOf axis="desOrSelf" ptType="node"/>
+              </dgm:if>
+              <dgm:else name="Name75">
+                <dgm:presOf/>
+              </dgm:else>
+            </dgm:choose>
+          </dgm:if>
+          <dgm:else name="Name76">
+            <dgm:choose name="Name77">
+              <dgm:if name="Name78" axis="root ch" ptType="all node" func="cnt" op="equ" val="3">
+                <dgm:presOf axis="root ch desOrSelf" ptType="all node node" st="1 2 1" cnt="1 1 0"/>
+              </dgm:if>
+              <dgm:if name="Name79" axis="root ch" ptType="all node" func="cnt" op="equ" val="4">
+                <dgm:presOf axis="root ch desOrSelf" ptType="all node node" st="1 3 1" cnt="1 1 0"/>
+              </dgm:if>
+              <dgm:else name="Name80">
+                <dgm:presOf/>
+              </dgm:else>
+            </dgm:choose>
+          </dgm:else>
+        </dgm:choose>
+        <dgm:constrLst/>
+        <dgm:ruleLst/>
+      </dgm:layoutNode>
+      <dgm:layoutNode name="circ3Tx" styleLbl="revTx">
+        <dgm:varLst>
+          <dgm:chMax val="0"/>
+          <dgm:chPref val="0"/>
+          <dgm:bulletEnabled val="1"/>
+        </dgm:varLst>
+        <dgm:alg type="tx">
+          <dgm:param type="txAnchorHorzCh" val="ctr"/>
+          <dgm:param type="txAnchorVertCh" val="mid"/>
+        </dgm:alg>
+        <dgm:shape xmlns:r="http://schemas.openxmlformats.org/officeDocument/2006/relationships" type="rect" r:blip="" hideGeom="1">
+          <dgm:adjLst/>
+        </dgm:shape>
+        <dgm:choose name="Name81">
+          <dgm:if name="Name82" func="var" arg="dir" op="equ" val="norm">
+            <dgm:presOf axis="desOrSelf" ptType="node"/>
+          </dgm:if>
+          <dgm:else name="Name83">
+            <dgm:choose name="Name84">
+              <dgm:if name="Name85" axis="root ch" ptType="all node" func="cnt" op="equ" val="3">
+                <dgm:presOf axis="root ch desOrSelf" ptType="all node node" st="1 2 1" cnt="1 1 0"/>
+              </dgm:if>
+              <dgm:if name="Name86" axis="root ch" ptType="all node" func="cnt" op="equ" val="4">
+                <dgm:presOf axis="root ch desOrSelf" ptType="all node node" st="1 3 1" cnt="1 1 0"/>
+              </dgm:if>
+              <dgm:if name="Name87" axis="root ch" ptType="all node" func="cnt" op="equ" val="5">
+                <dgm:presOf axis="root ch desOrSelf" ptType="all node node" st="1 4 1" cnt="1 1 0"/>
+              </dgm:if>
+              <dgm:if name="Name88" axis="root ch" ptType="all node" func="cnt" op="equ" val="6">
+                <dgm:presOf axis="root ch desOrSelf" ptType="all node node" st="1 5 1" cnt="1 1 0"/>
+              </dgm:if>
+              <dgm:else name="Name89">
+                <dgm:presOf axis="root ch desOrSelf" ptType="all node node" st="1 6 1" cnt="1 1 0"/>
+              </dgm:else>
+            </dgm:choose>
+          </dgm:else>
+        </dgm:choose>
+        <dgm:constrLst>
+          <dgm:constr type="tMarg"/>
+          <dgm:constr type="bMarg"/>
+          <dgm:constr type="lMarg"/>
+          <dgm:constr type="rMarg"/>
+          <dgm:constr type="primFontSz" val="65"/>
+        </dgm:constrLst>
+        <dgm:ruleLst>
+          <dgm:rule type="primFontSz" val="5" fact="NaN" max="NaN"/>
+        </dgm:ruleLst>
+      </dgm:layoutNode>
+    </dgm:forEach>
+    <dgm:forEach name="Name90" axis="ch" ptType="node" st="4" cnt="1">
+      <dgm:layoutNode name="circ4" styleLbl="vennNode1">
+        <dgm:alg type="sp"/>
+        <dgm:shape xmlns:r="http://schemas.openxmlformats.org/officeDocument/2006/relationships" type="ellipse" r:blip="">
+          <dgm:adjLst/>
+        </dgm:shape>
+        <dgm:choose name="Name91">
+          <dgm:if name="Name92" func="var" arg="dir" op="equ" val="norm">
+            <dgm:choose name="Name93">
+              <dgm:if name="Name94" axis="root ch" ptType="all node" func="cnt" op="lte" val="4">
+                <dgm:presOf axis="desOrSelf" ptType="node"/>
+              </dgm:if>
+              <dgm:else name="Name95">
+                <dgm:presOf/>
+              </dgm:else>
+            </dgm:choose>
+          </dgm:if>
+          <dgm:else name="Name96">
+            <dgm:choose name="Name97">
+              <dgm:if name="Name98" axis="root ch" ptType="all node" func="cnt" op="equ" val="4">
+                <dgm:presOf axis="root ch desOrSelf" ptType="all node node" st="1 2 1" cnt="1 1 0"/>
+              </dgm:if>
+              <dgm:else name="Name99">
+                <dgm:presOf/>
+              </dgm:else>
+            </dgm:choose>
+          </dgm:else>
+        </dgm:choose>
+        <dgm:constrLst/>
+        <dgm:ruleLst/>
+      </dgm:layoutNode>
+      <dgm:layoutNode name="circ4Tx" styleLbl="revTx">
+        <dgm:varLst>
+          <dgm:chMax val="0"/>
+          <dgm:chPref val="0"/>
+          <dgm:bulletEnabled val="1"/>
+        </dgm:varLst>
+        <dgm:alg type="tx">
+          <dgm:param type="txAnchorHorzCh" val="ctr"/>
+          <dgm:param type="txAnchorVertCh" val="mid"/>
+        </dgm:alg>
+        <dgm:shape xmlns:r="http://schemas.openxmlformats.org/officeDocument/2006/relationships" type="rect" r:blip="" hideGeom="1">
+          <dgm:adjLst/>
+        </dgm:shape>
+        <dgm:choose name="Name100">
+          <dgm:if name="Name101" func="var" arg="dir" op="equ" val="norm">
+            <dgm:presOf axis="desOrSelf" ptType="node"/>
+          </dgm:if>
+          <dgm:else name="Name102">
+            <dgm:choose name="Name103">
+              <dgm:if name="Name104" axis="root ch" ptType="all node" func="cnt" op="equ" val="4">
+                <dgm:presOf axis="root ch desOrSelf" ptType="all node node" st="1 2 1" cnt="1 1 0"/>
+              </dgm:if>
+              <dgm:if name="Name105" axis="root ch" ptType="all node" func="cnt" op="equ" val="5">
+                <dgm:presOf axis="root ch desOrSelf" ptType="all node node" st="1 3 1" cnt="1 1 0"/>
+              </dgm:if>
+              <dgm:if name="Name106" axis="root ch" ptType="all node" func="cnt" op="equ" val="6">
+                <dgm:presOf axis="root ch desOrSelf" ptType="all node node" st="1 4 1" cnt="1 1 0"/>
+              </dgm:if>
+              <dgm:else name="Name107">
+                <dgm:presOf axis="root ch desOrSelf" ptType="all node node" st="1 5 1" cnt="1 1 0"/>
+              </dgm:else>
+            </dgm:choose>
+          </dgm:else>
+        </dgm:choose>
+        <dgm:constrLst>
+          <dgm:constr type="tMarg"/>
+          <dgm:constr type="bMarg"/>
+          <dgm:constr type="lMarg"/>
+          <dgm:constr type="rMarg"/>
+          <dgm:constr type="primFontSz" val="65"/>
+        </dgm:constrLst>
+        <dgm:ruleLst>
+          <dgm:rule type="primFontSz" val="5" fact="NaN" max="NaN"/>
+        </dgm:ruleLst>
+      </dgm:layoutNode>
+    </dgm:forEach>
+    <dgm:forEach name="Name108" axis="ch" ptType="node" st="5" cnt="1">
+      <dgm:layoutNode name="circ5" styleLbl="vennNode1">
+        <dgm:alg type="sp"/>
+        <dgm:shape xmlns:r="http://schemas.openxmlformats.org/officeDocument/2006/relationships" type="ellipse" r:blip="">
+          <dgm:adjLst/>
+        </dgm:shape>
+        <dgm:presOf/>
+        <dgm:constrLst/>
+        <dgm:ruleLst/>
+      </dgm:layoutNode>
+      <dgm:layoutNode name="circ5Tx" styleLbl="revTx">
+        <dgm:varLst>
+          <dgm:chMax val="0"/>
+          <dgm:chPref val="0"/>
+          <dgm:bulletEnabled val="1"/>
+        </dgm:varLst>
+        <dgm:alg type="tx">
+          <dgm:param type="txAnchorHorzCh" val="ctr"/>
+          <dgm:param type="txAnchorVertCh" val="mid"/>
+        </dgm:alg>
+        <dgm:shape xmlns:r="http://schemas.openxmlformats.org/officeDocument/2006/relationships" type="rect" r:blip="" hideGeom="1">
+          <dgm:adjLst/>
+        </dgm:shape>
+        <dgm:choose name="Name109">
+          <dgm:if name="Name110" func="var" arg="dir" op="equ" val="norm">
+            <dgm:presOf axis="desOrSelf" ptType="node"/>
+          </dgm:if>
+          <dgm:else name="Name111">
+            <dgm:choose name="Name112">
+              <dgm:if name="Name113" axis="root ch" ptType="all node" func="cnt" op="equ" val="5">
+                <dgm:presOf axis="root ch desOrSelf" ptType="all node node" st="1 2 1" cnt="1 1 0"/>
+              </dgm:if>
+              <dgm:if name="Name114" axis="root ch" ptType="all node" func="cnt" op="equ" val="6">
+                <dgm:presOf axis="root ch desOrSelf" ptType="all node node" st="1 3 1" cnt="1 1 0"/>
+              </dgm:if>
+              <dgm:else name="Name115">
+                <dgm:presOf axis="root ch desOrSelf" ptType="all node node" st="1 4 1" cnt="1 1 0"/>
+              </dgm:else>
+            </dgm:choose>
+          </dgm:else>
+        </dgm:choose>
+        <dgm:constrLst>
+          <dgm:constr type="tMarg"/>
+          <dgm:constr type="bMarg"/>
+          <dgm:constr type="lMarg"/>
+          <dgm:constr type="rMarg"/>
+          <dgm:constr type="primFontSz" val="65"/>
+        </dgm:constrLst>
+        <dgm:ruleLst>
+          <dgm:rule type="primFontSz" val="5" fact="NaN" max="NaN"/>
+        </dgm:ruleLst>
+      </dgm:layoutNode>
+    </dgm:forEach>
+    <dgm:forEach name="Name116" axis="ch" ptType="node" st="6" cnt="1">
+      <dgm:layoutNode name="circ6" styleLbl="vennNode1">
+        <dgm:alg type="sp"/>
+        <dgm:shape xmlns:r="http://schemas.openxmlformats.org/officeDocument/2006/relationships" type="ellipse" r:blip="">
+          <dgm:adjLst/>
+        </dgm:shape>
+        <dgm:presOf/>
+        <dgm:constrLst/>
+        <dgm:ruleLst/>
+      </dgm:layoutNode>
+      <dgm:layoutNode name="circ6Tx" styleLbl="revTx">
+        <dgm:varLst>
+          <dgm:chMax val="0"/>
+          <dgm:chPref val="0"/>
+          <dgm:bulletEnabled val="1"/>
+        </dgm:varLst>
+        <dgm:alg type="tx">
+          <dgm:param type="txAnchorHorzCh" val="ctr"/>
+          <dgm:param type="txAnchorVertCh" val="mid"/>
+        </dgm:alg>
+        <dgm:shape xmlns:r="http://schemas.openxmlformats.org/officeDocument/2006/relationships" type="rect" r:blip="" hideGeom="1">
+          <dgm:adjLst/>
+        </dgm:shape>
+        <dgm:choose name="Name117">
+          <dgm:if name="Name118" func="var" arg="dir" op="equ" val="norm">
+            <dgm:presOf axis="desOrSelf" ptType="node"/>
+          </dgm:if>
+          <dgm:else name="Name119">
+            <dgm:choose name="Name120">
+              <dgm:if name="Name121" axis="root ch" ptType="all node" func="cnt" op="equ" val="6">
+                <dgm:presOf axis="root ch desOrSelf" ptType="all node node" st="1 2 1" cnt="1 1 0"/>
+              </dgm:if>
+              <dgm:else name="Name122">
+                <dgm:presOf axis="root ch desOrSelf" ptType="all node node" st="1 3 1" cnt="1 1 0"/>
+              </dgm:else>
+            </dgm:choose>
+          </dgm:else>
+        </dgm:choose>
+        <dgm:constrLst>
+          <dgm:constr type="tMarg"/>
+          <dgm:constr type="bMarg"/>
+          <dgm:constr type="lMarg"/>
+          <dgm:constr type="rMarg"/>
+          <dgm:constr type="primFontSz" val="65"/>
+        </dgm:constrLst>
+        <dgm:ruleLst>
+          <dgm:rule type="primFontSz" val="5" fact="NaN" max="NaN"/>
+        </dgm:ruleLst>
+      </dgm:layoutNode>
+    </dgm:forEach>
+    <dgm:forEach name="Name123" axis="ch" ptType="node" st="7" cnt="1">
+      <dgm:layoutNode name="circ7" styleLbl="vennNode1">
+        <dgm:alg type="sp"/>
+        <dgm:shape xmlns:r="http://schemas.openxmlformats.org/officeDocument/2006/relationships" type="ellipse" r:blip="">
+          <dgm:adjLst/>
+        </dgm:shape>
+        <dgm:presOf/>
+        <dgm:constrLst/>
+        <dgm:ruleLst/>
+      </dgm:layoutNode>
+      <dgm:layoutNode name="circ7Tx" styleLbl="revTx">
+        <dgm:varLst>
+          <dgm:chMax val="0"/>
+          <dgm:chPref val="0"/>
+          <dgm:bulletEnabled val="1"/>
+        </dgm:varLst>
+        <dgm:alg type="tx">
+          <dgm:param type="txAnchorHorzCh" val="ctr"/>
+          <dgm:param type="txAnchorVertCh" val="mid"/>
+        </dgm:alg>
+        <dgm:shape xmlns:r="http://schemas.openxmlformats.org/officeDocument/2006/relationships" type="rect" r:blip="" hideGeom="1">
+          <dgm:adjLst/>
+        </dgm:shape>
+        <dgm:choose name="Name124">
+          <dgm:if name="Name125" func="var" arg="dir" op="equ" val="norm">
+            <dgm:presOf axis="desOrSelf" ptType="node"/>
+          </dgm:if>
+          <dgm:else name="Name126">
+            <dgm:presOf axis="root ch desOrSelf" ptType="all node node" st="1 2 1" cnt="1 1 0"/>
+          </dgm:else>
+        </dgm:choose>
+        <dgm:constrLst>
+          <dgm:constr type="tMarg"/>
+          <dgm:constr type="bMarg"/>
+          <dgm:constr type="lMarg"/>
+          <dgm:constr type="rMarg"/>
+          <dgm:constr type="primFontSz" val="65"/>
+        </dgm:constrLst>
+        <dgm:ruleLst>
+          <dgm:rule type="primFontSz" val="5" fact="NaN" max="NaN"/>
+        </dgm:ruleLst>
+      </dgm:layoutNode>
+    </dgm:forEach>
+  </dgm:layoutNode>
+</dgm:layoutDef>
+</file>
+
+<file path=ppt/diagrams/layout2.xml><?xml version="1.0" encoding="utf-8"?>
 <dgm:layoutDef xmlns:dgm="http://schemas.openxmlformats.org/drawingml/2006/diagram" xmlns:a="http://schemas.openxmlformats.org/drawingml/2006/main" uniqueId="urn:microsoft.com/office/officeart/2005/8/layout/process2">
   <dgm:title val=""/>
   <dgm:desc val=""/>
@@ -3325,6 +5427,1040 @@
 </dgm:styleDef>
 </file>
 
+<file path=ppt/diagrams/quickStyle2.xml><?xml version="1.0" encoding="utf-8"?>
+<dgm:styleDef xmlns:dgm="http://schemas.openxmlformats.org/drawingml/2006/diagram" xmlns:a="http://schemas.openxmlformats.org/drawingml/2006/main" uniqueId="urn:microsoft.com/office/officeart/2005/8/quickstyle/simple1">
+  <dgm:title val=""/>
+  <dgm:desc val=""/>
+  <dgm:catLst>
+    <dgm:cat type="simple" pri="10100"/>
+  </dgm:catLst>
+  <dgm:scene3d>
+    <a:camera prst="orthographicFront"/>
+    <a:lightRig rig="threePt" dir="t"/>
+  </dgm:scene3d>
+  <dgm:styleLbl name="node0">
+    <dgm:scene3d>
+      <a:camera prst="orthographicFront"/>
+      <a:lightRig rig="threePt" dir="t"/>
+    </dgm:scene3d>
+    <dgm:sp3d/>
+    <dgm:txPr/>
+    <dgm:style>
+      <a:lnRef idx="2">
+        <a:scrgbClr r="0" g="0" b="0"/>
+      </a:lnRef>
+      <a:fillRef idx="1">
+        <a:scrgbClr r="0" g="0" b="0"/>
+      </a:fillRef>
+      <a:effectRef idx="0">
+        <a:scrgbClr r="0" g="0" b="0"/>
+      </a:effectRef>
+      <a:fontRef idx="minor">
+        <a:schemeClr val="lt1"/>
+      </a:fontRef>
+    </dgm:style>
+  </dgm:styleLbl>
+  <dgm:styleLbl name="lnNode1">
+    <dgm:scene3d>
+      <a:camera prst="orthographicFront"/>
+      <a:lightRig rig="threePt" dir="t"/>
+    </dgm:scene3d>
+    <dgm:sp3d/>
+    <dgm:txPr/>
+    <dgm:style>
+      <a:lnRef idx="2">
+        <a:scrgbClr r="0" g="0" b="0"/>
+      </a:lnRef>
+      <a:fillRef idx="1">
+        <a:scrgbClr r="0" g="0" b="0"/>
+      </a:fillRef>
+      <a:effectRef idx="0">
+        <a:scrgbClr r="0" g="0" b="0"/>
+      </a:effectRef>
+      <a:fontRef idx="minor">
+        <a:schemeClr val="lt1"/>
+      </a:fontRef>
+    </dgm:style>
+  </dgm:styleLbl>
+  <dgm:styleLbl name="vennNode1">
+    <dgm:scene3d>
+      <a:camera prst="orthographicFront"/>
+      <a:lightRig rig="threePt" dir="t"/>
+    </dgm:scene3d>
+    <dgm:sp3d/>
+    <dgm:txPr/>
+    <dgm:style>
+      <a:lnRef idx="2">
+        <a:scrgbClr r="0" g="0" b="0"/>
+      </a:lnRef>
+      <a:fillRef idx="1">
+        <a:scrgbClr r="0" g="0" b="0"/>
+      </a:fillRef>
+      <a:effectRef idx="0">
+        <a:scrgbClr r="0" g="0" b="0"/>
+      </a:effectRef>
+      <a:fontRef idx="minor">
+        <a:schemeClr val="tx1"/>
+      </a:fontRef>
+    </dgm:style>
+  </dgm:styleLbl>
+  <dgm:styleLbl name="alignNode1">
+    <dgm:scene3d>
+      <a:camera prst="orthographicFront"/>
+      <a:lightRig rig="threePt" dir="t"/>
+    </dgm:scene3d>
+    <dgm:sp3d/>
+    <dgm:txPr/>
+    <dgm:style>
+      <a:lnRef idx="2">
+        <a:scrgbClr r="0" g="0" b="0"/>
+      </a:lnRef>
+      <a:fillRef idx="1">
+        <a:scrgbClr r="0" g="0" b="0"/>
+      </a:fillRef>
+      <a:effectRef idx="0">
+        <a:scrgbClr r="0" g="0" b="0"/>
+      </a:effectRef>
+      <a:fontRef idx="minor">
+        <a:schemeClr val="lt1"/>
+      </a:fontRef>
+    </dgm:style>
+  </dgm:styleLbl>
+  <dgm:styleLbl name="node1">
+    <dgm:scene3d>
+      <a:camera prst="orthographicFront"/>
+      <a:lightRig rig="threePt" dir="t"/>
+    </dgm:scene3d>
+    <dgm:sp3d/>
+    <dgm:txPr/>
+    <dgm:style>
+      <a:lnRef idx="2">
+        <a:scrgbClr r="0" g="0" b="0"/>
+      </a:lnRef>
+      <a:fillRef idx="1">
+        <a:scrgbClr r="0" g="0" b="0"/>
+      </a:fillRef>
+      <a:effectRef idx="0">
+        <a:scrgbClr r="0" g="0" b="0"/>
+      </a:effectRef>
+      <a:fontRef idx="minor">
+        <a:schemeClr val="lt1"/>
+      </a:fontRef>
+    </dgm:style>
+  </dgm:styleLbl>
+  <dgm:styleLbl name="node2">
+    <dgm:scene3d>
+      <a:camera prst="orthographicFront"/>
+      <a:lightRig rig="threePt" dir="t"/>
+    </dgm:scene3d>
+    <dgm:sp3d/>
+    <dgm:txPr/>
+    <dgm:style>
+      <a:lnRef idx="2">
+        <a:scrgbClr r="0" g="0" b="0"/>
+      </a:lnRef>
+      <a:fillRef idx="1">
+        <a:scrgbClr r="0" g="0" b="0"/>
+      </a:fillRef>
+      <a:effectRef idx="0">
+        <a:scrgbClr r="0" g="0" b="0"/>
+      </a:effectRef>
+      <a:fontRef idx="minor">
+        <a:schemeClr val="lt1"/>
+      </a:fontRef>
+    </dgm:style>
+  </dgm:styleLbl>
+  <dgm:styleLbl name="node3">
+    <dgm:scene3d>
+      <a:camera prst="orthographicFront"/>
+      <a:lightRig rig="threePt" dir="t"/>
+    </dgm:scene3d>
+    <dgm:sp3d/>
+    <dgm:txPr/>
+    <dgm:style>
+      <a:lnRef idx="2">
+        <a:scrgbClr r="0" g="0" b="0"/>
+      </a:lnRef>
+      <a:fillRef idx="1">
+        <a:scrgbClr r="0" g="0" b="0"/>
+      </a:fillRef>
+      <a:effectRef idx="0">
+        <a:scrgbClr r="0" g="0" b="0"/>
+      </a:effectRef>
+      <a:fontRef idx="minor">
+        <a:schemeClr val="lt1"/>
+      </a:fontRef>
+    </dgm:style>
+  </dgm:styleLbl>
+  <dgm:styleLbl name="node4">
+    <dgm:scene3d>
+      <a:camera prst="orthographicFront"/>
+      <a:lightRig rig="threePt" dir="t"/>
+    </dgm:scene3d>
+    <dgm:sp3d/>
+    <dgm:txPr/>
+    <dgm:style>
+      <a:lnRef idx="2">
+        <a:scrgbClr r="0" g="0" b="0"/>
+      </a:lnRef>
+      <a:fillRef idx="1">
+        <a:scrgbClr r="0" g="0" b="0"/>
+      </a:fillRef>
+      <a:effectRef idx="0">
+        <a:scrgbClr r="0" g="0" b="0"/>
+      </a:effectRef>
+      <a:fontRef idx="minor">
+        <a:schemeClr val="lt1"/>
+      </a:fontRef>
+    </dgm:style>
+  </dgm:styleLbl>
+  <dgm:styleLbl name="fgImgPlace1">
+    <dgm:scene3d>
+      <a:camera prst="orthographicFront"/>
+      <a:lightRig rig="threePt" dir="t"/>
+    </dgm:scene3d>
+    <dgm:sp3d/>
+    <dgm:txPr/>
+    <dgm:style>
+      <a:lnRef idx="2">
+        <a:scrgbClr r="0" g="0" b="0"/>
+      </a:lnRef>
+      <a:fillRef idx="1">
+        <a:scrgbClr r="0" g="0" b="0"/>
+      </a:fillRef>
+      <a:effectRef idx="0">
+        <a:scrgbClr r="0" g="0" b="0"/>
+      </a:effectRef>
+      <a:fontRef idx="minor"/>
+    </dgm:style>
+  </dgm:styleLbl>
+  <dgm:styleLbl name="alignImgPlace1">
+    <dgm:scene3d>
+      <a:camera prst="orthographicFront"/>
+      <a:lightRig rig="threePt" dir="t"/>
+    </dgm:scene3d>
+    <dgm:sp3d/>
+    <dgm:txPr/>
+    <dgm:style>
+      <a:lnRef idx="2">
+        <a:scrgbClr r="0" g="0" b="0"/>
+      </a:lnRef>
+      <a:fillRef idx="1">
+        <a:scrgbClr r="0" g="0" b="0"/>
+      </a:fillRef>
+      <a:effectRef idx="0">
+        <a:scrgbClr r="0" g="0" b="0"/>
+      </a:effectRef>
+      <a:fontRef idx="minor"/>
+    </dgm:style>
+  </dgm:styleLbl>
+  <dgm:styleLbl name="bgImgPlace1">
+    <dgm:scene3d>
+      <a:camera prst="orthographicFront"/>
+      <a:lightRig rig="threePt" dir="t"/>
+    </dgm:scene3d>
+    <dgm:sp3d/>
+    <dgm:txPr/>
+    <dgm:style>
+      <a:lnRef idx="2">
+        <a:scrgbClr r="0" g="0" b="0"/>
+      </a:lnRef>
+      <a:fillRef idx="1">
+        <a:scrgbClr r="0" g="0" b="0"/>
+      </a:fillRef>
+      <a:effectRef idx="0">
+        <a:scrgbClr r="0" g="0" b="0"/>
+      </a:effectRef>
+      <a:fontRef idx="minor"/>
+    </dgm:style>
+  </dgm:styleLbl>
+  <dgm:styleLbl name="sibTrans2D1">
+    <dgm:scene3d>
+      <a:camera prst="orthographicFront"/>
+      <a:lightRig rig="threePt" dir="t"/>
+    </dgm:scene3d>
+    <dgm:sp3d/>
+    <dgm:txPr/>
+    <dgm:style>
+      <a:lnRef idx="0">
+        <a:scrgbClr r="0" g="0" b="0"/>
+      </a:lnRef>
+      <a:fillRef idx="1">
+        <a:scrgbClr r="0" g="0" b="0"/>
+      </a:fillRef>
+      <a:effectRef idx="0">
+        <a:scrgbClr r="0" g="0" b="0"/>
+      </a:effectRef>
+      <a:fontRef idx="minor">
+        <a:schemeClr val="lt1"/>
+      </a:fontRef>
+    </dgm:style>
+  </dgm:styleLbl>
+  <dgm:styleLbl name="fgSibTrans2D1">
+    <dgm:scene3d>
+      <a:camera prst="orthographicFront"/>
+      <a:lightRig rig="threePt" dir="t"/>
+    </dgm:scene3d>
+    <dgm:sp3d/>
+    <dgm:txPr/>
+    <dgm:style>
+      <a:lnRef idx="0">
+        <a:scrgbClr r="0" g="0" b="0"/>
+      </a:lnRef>
+      <a:fillRef idx="1">
+        <a:scrgbClr r="0" g="0" b="0"/>
+      </a:fillRef>
+      <a:effectRef idx="0">
+        <a:scrgbClr r="0" g="0" b="0"/>
+      </a:effectRef>
+      <a:fontRef idx="minor">
+        <a:schemeClr val="lt1"/>
+      </a:fontRef>
+    </dgm:style>
+  </dgm:styleLbl>
+  <dgm:styleLbl name="bgSibTrans2D1">
+    <dgm:scene3d>
+      <a:camera prst="orthographicFront"/>
+      <a:lightRig rig="threePt" dir="t"/>
+    </dgm:scene3d>
+    <dgm:sp3d/>
+    <dgm:txPr/>
+    <dgm:style>
+      <a:lnRef idx="0">
+        <a:scrgbClr r="0" g="0" b="0"/>
+      </a:lnRef>
+      <a:fillRef idx="1">
+        <a:scrgbClr r="0" g="0" b="0"/>
+      </a:fillRef>
+      <a:effectRef idx="0">
+        <a:scrgbClr r="0" g="0" b="0"/>
+      </a:effectRef>
+      <a:fontRef idx="minor">
+        <a:schemeClr val="lt1"/>
+      </a:fontRef>
+    </dgm:style>
+  </dgm:styleLbl>
+  <dgm:styleLbl name="sibTrans1D1">
+    <dgm:scene3d>
+      <a:camera prst="orthographicFront"/>
+      <a:lightRig rig="threePt" dir="t"/>
+    </dgm:scene3d>
+    <dgm:sp3d/>
+    <dgm:txPr/>
+    <dgm:style>
+      <a:lnRef idx="1">
+        <a:scrgbClr r="0" g="0" b="0"/>
+      </a:lnRef>
+      <a:fillRef idx="0">
+        <a:scrgbClr r="0" g="0" b="0"/>
+      </a:fillRef>
+      <a:effectRef idx="0">
+        <a:scrgbClr r="0" g="0" b="0"/>
+      </a:effectRef>
+      <a:fontRef idx="minor"/>
+    </dgm:style>
+  </dgm:styleLbl>
+  <dgm:styleLbl name="callout">
+    <dgm:scene3d>
+      <a:camera prst="orthographicFront"/>
+      <a:lightRig rig="threePt" dir="t"/>
+    </dgm:scene3d>
+    <dgm:sp3d/>
+    <dgm:txPr/>
+    <dgm:style>
+      <a:lnRef idx="2">
+        <a:scrgbClr r="0" g="0" b="0"/>
+      </a:lnRef>
+      <a:fillRef idx="1">
+        <a:scrgbClr r="0" g="0" b="0"/>
+      </a:fillRef>
+      <a:effectRef idx="0">
+        <a:scrgbClr r="0" g="0" b="0"/>
+      </a:effectRef>
+      <a:fontRef idx="minor"/>
+    </dgm:style>
+  </dgm:styleLbl>
+  <dgm:styleLbl name="asst0">
+    <dgm:scene3d>
+      <a:camera prst="orthographicFront"/>
+      <a:lightRig rig="threePt" dir="t"/>
+    </dgm:scene3d>
+    <dgm:sp3d/>
+    <dgm:txPr/>
+    <dgm:style>
+      <a:lnRef idx="2">
+        <a:scrgbClr r="0" g="0" b="0"/>
+      </a:lnRef>
+      <a:fillRef idx="1">
+        <a:scrgbClr r="0" g="0" b="0"/>
+      </a:fillRef>
+      <a:effectRef idx="0">
+        <a:scrgbClr r="0" g="0" b="0"/>
+      </a:effectRef>
+      <a:fontRef idx="minor">
+        <a:schemeClr val="lt1"/>
+      </a:fontRef>
+    </dgm:style>
+  </dgm:styleLbl>
+  <dgm:styleLbl name="asst1">
+    <dgm:scene3d>
+      <a:camera prst="orthographicFront"/>
+      <a:lightRig rig="threePt" dir="t"/>
+    </dgm:scene3d>
+    <dgm:sp3d/>
+    <dgm:txPr/>
+    <dgm:style>
+      <a:lnRef idx="2">
+        <a:scrgbClr r="0" g="0" b="0"/>
+      </a:lnRef>
+      <a:fillRef idx="1">
+        <a:scrgbClr r="0" g="0" b="0"/>
+      </a:fillRef>
+      <a:effectRef idx="0">
+        <a:scrgbClr r="0" g="0" b="0"/>
+      </a:effectRef>
+      <a:fontRef idx="minor">
+        <a:schemeClr val="lt1"/>
+      </a:fontRef>
+    </dgm:style>
+  </dgm:styleLbl>
+  <dgm:styleLbl name="asst2">
+    <dgm:scene3d>
+      <a:camera prst="orthographicFront"/>
+      <a:lightRig rig="threePt" dir="t"/>
+    </dgm:scene3d>
+    <dgm:sp3d/>
+    <dgm:txPr/>
+    <dgm:style>
+      <a:lnRef idx="2">
+        <a:scrgbClr r="0" g="0" b="0"/>
+      </a:lnRef>
+      <a:fillRef idx="1">
+        <a:scrgbClr r="0" g="0" b="0"/>
+      </a:fillRef>
+      <a:effectRef idx="0">
+        <a:scrgbClr r="0" g="0" b="0"/>
+      </a:effectRef>
+      <a:fontRef idx="minor">
+        <a:schemeClr val="lt1"/>
+      </a:fontRef>
+    </dgm:style>
+  </dgm:styleLbl>
+  <dgm:styleLbl name="asst3">
+    <dgm:scene3d>
+      <a:camera prst="orthographicFront"/>
+      <a:lightRig rig="threePt" dir="t"/>
+    </dgm:scene3d>
+    <dgm:sp3d/>
+    <dgm:txPr/>
+    <dgm:style>
+      <a:lnRef idx="2">
+        <a:scrgbClr r="0" g="0" b="0"/>
+      </a:lnRef>
+      <a:fillRef idx="1">
+        <a:scrgbClr r="0" g="0" b="0"/>
+      </a:fillRef>
+      <a:effectRef idx="0">
+        <a:scrgbClr r="0" g="0" b="0"/>
+      </a:effectRef>
+      <a:fontRef idx="minor">
+        <a:schemeClr val="lt1"/>
+      </a:fontRef>
+    </dgm:style>
+  </dgm:styleLbl>
+  <dgm:styleLbl name="asst4">
+    <dgm:scene3d>
+      <a:camera prst="orthographicFront"/>
+      <a:lightRig rig="threePt" dir="t"/>
+    </dgm:scene3d>
+    <dgm:sp3d/>
+    <dgm:txPr/>
+    <dgm:style>
+      <a:lnRef idx="2">
+        <a:scrgbClr r="0" g="0" b="0"/>
+      </a:lnRef>
+      <a:fillRef idx="1">
+        <a:scrgbClr r="0" g="0" b="0"/>
+      </a:fillRef>
+      <a:effectRef idx="0">
+        <a:scrgbClr r="0" g="0" b="0"/>
+      </a:effectRef>
+      <a:fontRef idx="minor">
+        <a:schemeClr val="lt1"/>
+      </a:fontRef>
+    </dgm:style>
+  </dgm:styleLbl>
+  <dgm:styleLbl name="parChTrans2D1">
+    <dgm:scene3d>
+      <a:camera prst="orthographicFront"/>
+      <a:lightRig rig="threePt" dir="t"/>
+    </dgm:scene3d>
+    <dgm:sp3d/>
+    <dgm:txPr/>
+    <dgm:style>
+      <a:lnRef idx="2">
+        <a:scrgbClr r="0" g="0" b="0"/>
+      </a:lnRef>
+      <a:fillRef idx="1">
+        <a:scrgbClr r="0" g="0" b="0"/>
+      </a:fillRef>
+      <a:effectRef idx="0">
+        <a:scrgbClr r="0" g="0" b="0"/>
+      </a:effectRef>
+      <a:fontRef idx="minor">
+        <a:schemeClr val="lt1"/>
+      </a:fontRef>
+    </dgm:style>
+  </dgm:styleLbl>
+  <dgm:styleLbl name="parChTrans2D2">
+    <dgm:scene3d>
+      <a:camera prst="orthographicFront"/>
+      <a:lightRig rig="threePt" dir="t"/>
+    </dgm:scene3d>
+    <dgm:sp3d/>
+    <dgm:txPr/>
+    <dgm:style>
+      <a:lnRef idx="2">
+        <a:scrgbClr r="0" g="0" b="0"/>
+      </a:lnRef>
+      <a:fillRef idx="1">
+        <a:scrgbClr r="0" g="0" b="0"/>
+      </a:fillRef>
+      <a:effectRef idx="0">
+        <a:scrgbClr r="0" g="0" b="0"/>
+      </a:effectRef>
+      <a:fontRef idx="minor">
+        <a:schemeClr val="lt1"/>
+      </a:fontRef>
+    </dgm:style>
+  </dgm:styleLbl>
+  <dgm:styleLbl name="parChTrans2D3">
+    <dgm:scene3d>
+      <a:camera prst="orthographicFront"/>
+      <a:lightRig rig="threePt" dir="t"/>
+    </dgm:scene3d>
+    <dgm:sp3d/>
+    <dgm:txPr/>
+    <dgm:style>
+      <a:lnRef idx="2">
+        <a:scrgbClr r="0" g="0" b="0"/>
+      </a:lnRef>
+      <a:fillRef idx="1">
+        <a:scrgbClr r="0" g="0" b="0"/>
+      </a:fillRef>
+      <a:effectRef idx="0">
+        <a:scrgbClr r="0" g="0" b="0"/>
+      </a:effectRef>
+      <a:fontRef idx="minor">
+        <a:schemeClr val="lt1"/>
+      </a:fontRef>
+    </dgm:style>
+  </dgm:styleLbl>
+  <dgm:styleLbl name="parChTrans2D4">
+    <dgm:scene3d>
+      <a:camera prst="orthographicFront"/>
+      <a:lightRig rig="threePt" dir="t"/>
+    </dgm:scene3d>
+    <dgm:sp3d/>
+    <dgm:txPr/>
+    <dgm:style>
+      <a:lnRef idx="2">
+        <a:scrgbClr r="0" g="0" b="0"/>
+      </a:lnRef>
+      <a:fillRef idx="1">
+        <a:scrgbClr r="0" g="0" b="0"/>
+      </a:fillRef>
+      <a:effectRef idx="0">
+        <a:scrgbClr r="0" g="0" b="0"/>
+      </a:effectRef>
+      <a:fontRef idx="minor">
+        <a:schemeClr val="lt1"/>
+      </a:fontRef>
+    </dgm:style>
+  </dgm:styleLbl>
+  <dgm:styleLbl name="parChTrans1D1">
+    <dgm:scene3d>
+      <a:camera prst="orthographicFront"/>
+      <a:lightRig rig="threePt" dir="t"/>
+    </dgm:scene3d>
+    <dgm:sp3d/>
+    <dgm:txPr/>
+    <dgm:style>
+      <a:lnRef idx="2">
+        <a:scrgbClr r="0" g="0" b="0"/>
+      </a:lnRef>
+      <a:fillRef idx="0">
+        <a:scrgbClr r="0" g="0" b="0"/>
+      </a:fillRef>
+      <a:effectRef idx="0">
+        <a:scrgbClr r="0" g="0" b="0"/>
+      </a:effectRef>
+      <a:fontRef idx="minor"/>
+    </dgm:style>
+  </dgm:styleLbl>
+  <dgm:styleLbl name="parChTrans1D2">
+    <dgm:scene3d>
+      <a:camera prst="orthographicFront"/>
+      <a:lightRig rig="threePt" dir="t"/>
+    </dgm:scene3d>
+    <dgm:sp3d/>
+    <dgm:txPr/>
+    <dgm:style>
+      <a:lnRef idx="2">
+        <a:scrgbClr r="0" g="0" b="0"/>
+      </a:lnRef>
+      <a:fillRef idx="0">
+        <a:scrgbClr r="0" g="0" b="0"/>
+      </a:fillRef>
+      <a:effectRef idx="0">
+        <a:scrgbClr r="0" g="0" b="0"/>
+      </a:effectRef>
+      <a:fontRef idx="minor"/>
+    </dgm:style>
+  </dgm:styleLbl>
+  <dgm:styleLbl name="parChTrans1D3">
+    <dgm:scene3d>
+      <a:camera prst="orthographicFront"/>
+      <a:lightRig rig="threePt" dir="t"/>
+    </dgm:scene3d>
+    <dgm:sp3d/>
+    <dgm:txPr/>
+    <dgm:style>
+      <a:lnRef idx="2">
+        <a:scrgbClr r="0" g="0" b="0"/>
+      </a:lnRef>
+      <a:fillRef idx="0">
+        <a:scrgbClr r="0" g="0" b="0"/>
+      </a:fillRef>
+      <a:effectRef idx="0">
+        <a:scrgbClr r="0" g="0" b="0"/>
+      </a:effectRef>
+      <a:fontRef idx="minor"/>
+    </dgm:style>
+  </dgm:styleLbl>
+  <dgm:styleLbl name="parChTrans1D4">
+    <dgm:scene3d>
+      <a:camera prst="orthographicFront"/>
+      <a:lightRig rig="threePt" dir="t"/>
+    </dgm:scene3d>
+    <dgm:sp3d/>
+    <dgm:txPr/>
+    <dgm:style>
+      <a:lnRef idx="2">
+        <a:scrgbClr r="0" g="0" b="0"/>
+      </a:lnRef>
+      <a:fillRef idx="0">
+        <a:scrgbClr r="0" g="0" b="0"/>
+      </a:fillRef>
+      <a:effectRef idx="0">
+        <a:scrgbClr r="0" g="0" b="0"/>
+      </a:effectRef>
+      <a:fontRef idx="minor"/>
+    </dgm:style>
+  </dgm:styleLbl>
+  <dgm:styleLbl name="fgAcc1">
+    <dgm:scene3d>
+      <a:camera prst="orthographicFront"/>
+      <a:lightRig rig="threePt" dir="t"/>
+    </dgm:scene3d>
+    <dgm:sp3d/>
+    <dgm:txPr/>
+    <dgm:style>
+      <a:lnRef idx="2">
+        <a:scrgbClr r="0" g="0" b="0"/>
+      </a:lnRef>
+      <a:fillRef idx="1">
+        <a:scrgbClr r="0" g="0" b="0"/>
+      </a:fillRef>
+      <a:effectRef idx="0">
+        <a:scrgbClr r="0" g="0" b="0"/>
+      </a:effectRef>
+      <a:fontRef idx="minor"/>
+    </dgm:style>
+  </dgm:styleLbl>
+  <dgm:styleLbl name="conFgAcc1">
+    <dgm:scene3d>
+      <a:camera prst="orthographicFront"/>
+      <a:lightRig rig="threePt" dir="t"/>
+    </dgm:scene3d>
+    <dgm:sp3d/>
+    <dgm:txPr/>
+    <dgm:style>
+      <a:lnRef idx="2">
+        <a:scrgbClr r="0" g="0" b="0"/>
+      </a:lnRef>
+      <a:fillRef idx="1">
+        <a:scrgbClr r="0" g="0" b="0"/>
+      </a:fillRef>
+      <a:effectRef idx="0">
+        <a:scrgbClr r="0" g="0" b="0"/>
+      </a:effectRef>
+      <a:fontRef idx="minor"/>
+    </dgm:style>
+  </dgm:styleLbl>
+  <dgm:styleLbl name="alignAcc1">
+    <dgm:scene3d>
+      <a:camera prst="orthographicFront"/>
+      <a:lightRig rig="threePt" dir="t"/>
+    </dgm:scene3d>
+    <dgm:sp3d/>
+    <dgm:txPr/>
+    <dgm:style>
+      <a:lnRef idx="2">
+        <a:scrgbClr r="0" g="0" b="0"/>
+      </a:lnRef>
+      <a:fillRef idx="1">
+        <a:scrgbClr r="0" g="0" b="0"/>
+      </a:fillRef>
+      <a:effectRef idx="0">
+        <a:scrgbClr r="0" g="0" b="0"/>
+      </a:effectRef>
+      <a:fontRef idx="minor"/>
+    </dgm:style>
+  </dgm:styleLbl>
+  <dgm:styleLbl name="trAlignAcc1">
+    <dgm:scene3d>
+      <a:camera prst="orthographicFront"/>
+      <a:lightRig rig="threePt" dir="t"/>
+    </dgm:scene3d>
+    <dgm:sp3d/>
+    <dgm:txPr/>
+    <dgm:style>
+      <a:lnRef idx="1">
+        <a:scrgbClr r="0" g="0" b="0"/>
+      </a:lnRef>
+      <a:fillRef idx="1">
+        <a:scrgbClr r="0" g="0" b="0"/>
+      </a:fillRef>
+      <a:effectRef idx="0">
+        <a:scrgbClr r="0" g="0" b="0"/>
+      </a:effectRef>
+      <a:fontRef idx="minor"/>
+    </dgm:style>
+  </dgm:styleLbl>
+  <dgm:styleLbl name="bgAcc1">
+    <dgm:scene3d>
+      <a:camera prst="orthographicFront"/>
+      <a:lightRig rig="threePt" dir="t"/>
+    </dgm:scene3d>
+    <dgm:sp3d/>
+    <dgm:txPr/>
+    <dgm:style>
+      <a:lnRef idx="2">
+        <a:scrgbClr r="0" g="0" b="0"/>
+      </a:lnRef>
+      <a:fillRef idx="1">
+        <a:scrgbClr r="0" g="0" b="0"/>
+      </a:fillRef>
+      <a:effectRef idx="0">
+        <a:scrgbClr r="0" g="0" b="0"/>
+      </a:effectRef>
+      <a:fontRef idx="minor"/>
+    </dgm:style>
+  </dgm:styleLbl>
+  <dgm:styleLbl name="solidFgAcc1">
+    <dgm:scene3d>
+      <a:camera prst="orthographicFront"/>
+      <a:lightRig rig="threePt" dir="t"/>
+    </dgm:scene3d>
+    <dgm:sp3d/>
+    <dgm:txPr/>
+    <dgm:style>
+      <a:lnRef idx="2">
+        <a:scrgbClr r="0" g="0" b="0"/>
+      </a:lnRef>
+      <a:fillRef idx="1">
+        <a:scrgbClr r="0" g="0" b="0"/>
+      </a:fillRef>
+      <a:effectRef idx="0">
+        <a:scrgbClr r="0" g="0" b="0"/>
+      </a:effectRef>
+      <a:fontRef idx="minor"/>
+    </dgm:style>
+  </dgm:styleLbl>
+  <dgm:styleLbl name="solidAlignAcc1">
+    <dgm:scene3d>
+      <a:camera prst="orthographicFront"/>
+      <a:lightRig rig="threePt" dir="t"/>
+    </dgm:scene3d>
+    <dgm:sp3d/>
+    <dgm:txPr/>
+    <dgm:style>
+      <a:lnRef idx="2">
+        <a:scrgbClr r="0" g="0" b="0"/>
+      </a:lnRef>
+      <a:fillRef idx="1">
+        <a:scrgbClr r="0" g="0" b="0"/>
+      </a:fillRef>
+      <a:effectRef idx="0">
+        <a:scrgbClr r="0" g="0" b="0"/>
+      </a:effectRef>
+      <a:fontRef idx="minor"/>
+    </dgm:style>
+  </dgm:styleLbl>
+  <dgm:styleLbl name="solidBgAcc1">
+    <dgm:scene3d>
+      <a:camera prst="orthographicFront"/>
+      <a:lightRig rig="threePt" dir="t"/>
+    </dgm:scene3d>
+    <dgm:sp3d/>
+    <dgm:txPr/>
+    <dgm:style>
+      <a:lnRef idx="2">
+        <a:scrgbClr r="0" g="0" b="0"/>
+      </a:lnRef>
+      <a:fillRef idx="1">
+        <a:scrgbClr r="0" g="0" b="0"/>
+      </a:fillRef>
+      <a:effectRef idx="0">
+        <a:scrgbClr r="0" g="0" b="0"/>
+      </a:effectRef>
+      <a:fontRef idx="minor"/>
+    </dgm:style>
+  </dgm:styleLbl>
+  <dgm:styleLbl name="fgAccFollowNode1">
+    <dgm:scene3d>
+      <a:camera prst="orthographicFront"/>
+      <a:lightRig rig="threePt" dir="t"/>
+    </dgm:scene3d>
+    <dgm:sp3d/>
+    <dgm:txPr/>
+    <dgm:style>
+      <a:lnRef idx="2">
+        <a:scrgbClr r="0" g="0" b="0"/>
+      </a:lnRef>
+      <a:fillRef idx="1">
+        <a:scrgbClr r="0" g="0" b="0"/>
+      </a:fillRef>
+      <a:effectRef idx="0">
+        <a:scrgbClr r="0" g="0" b="0"/>
+      </a:effectRef>
+      <a:fontRef idx="minor"/>
+    </dgm:style>
+  </dgm:styleLbl>
+  <dgm:styleLbl name="alignAccFollowNode1">
+    <dgm:scene3d>
+      <a:camera prst="orthographicFront"/>
+      <a:lightRig rig="threePt" dir="t"/>
+    </dgm:scene3d>
+    <dgm:sp3d/>
+    <dgm:txPr/>
+    <dgm:style>
+      <a:lnRef idx="2">
+        <a:scrgbClr r="0" g="0" b="0"/>
+      </a:lnRef>
+      <a:fillRef idx="1">
+        <a:scrgbClr r="0" g="0" b="0"/>
+      </a:fillRef>
+      <a:effectRef idx="0">
+        <a:scrgbClr r="0" g="0" b="0"/>
+      </a:effectRef>
+      <a:fontRef idx="minor"/>
+    </dgm:style>
+  </dgm:styleLbl>
+  <dgm:styleLbl name="bgAccFollowNode1">
+    <dgm:scene3d>
+      <a:camera prst="orthographicFront"/>
+      <a:lightRig rig="threePt" dir="t"/>
+    </dgm:scene3d>
+    <dgm:sp3d/>
+    <dgm:txPr/>
+    <dgm:style>
+      <a:lnRef idx="2">
+        <a:scrgbClr r="0" g="0" b="0"/>
+      </a:lnRef>
+      <a:fillRef idx="1">
+        <a:scrgbClr r="0" g="0" b="0"/>
+      </a:fillRef>
+      <a:effectRef idx="0">
+        <a:scrgbClr r="0" g="0" b="0"/>
+      </a:effectRef>
+      <a:fontRef idx="minor"/>
+    </dgm:style>
+  </dgm:styleLbl>
+  <dgm:styleLbl name="fgAcc0">
+    <dgm:scene3d>
+      <a:camera prst="orthographicFront"/>
+      <a:lightRig rig="threePt" dir="t"/>
+    </dgm:scene3d>
+    <dgm:sp3d/>
+    <dgm:txPr/>
+    <dgm:style>
+      <a:lnRef idx="2">
+        <a:scrgbClr r="0" g="0" b="0"/>
+      </a:lnRef>
+      <a:fillRef idx="1">
+        <a:scrgbClr r="0" g="0" b="0"/>
+      </a:fillRef>
+      <a:effectRef idx="0">
+        <a:scrgbClr r="0" g="0" b="0"/>
+      </a:effectRef>
+      <a:fontRef idx="minor"/>
+    </dgm:style>
+  </dgm:styleLbl>
+  <dgm:styleLbl name="fgAcc2">
+    <dgm:scene3d>
+      <a:camera prst="orthographicFront"/>
+      <a:lightRig rig="threePt" dir="t"/>
+    </dgm:scene3d>
+    <dgm:sp3d/>
+    <dgm:txPr/>
+    <dgm:style>
+      <a:lnRef idx="2">
+        <a:scrgbClr r="0" g="0" b="0"/>
+      </a:lnRef>
+      <a:fillRef idx="1">
+        <a:scrgbClr r="0" g="0" b="0"/>
+      </a:fillRef>
+      <a:effectRef idx="0">
+        <a:scrgbClr r="0" g="0" b="0"/>
+      </a:effectRef>
+      <a:fontRef idx="minor"/>
+    </dgm:style>
+  </dgm:styleLbl>
+  <dgm:styleLbl name="fgAcc3">
+    <dgm:scene3d>
+      <a:camera prst="orthographicFront"/>
+      <a:lightRig rig="threePt" dir="t"/>
+    </dgm:scene3d>
+    <dgm:sp3d/>
+    <dgm:txPr/>
+    <dgm:style>
+      <a:lnRef idx="2">
+        <a:scrgbClr r="0" g="0" b="0"/>
+      </a:lnRef>
+      <a:fillRef idx="1">
+        <a:scrgbClr r="0" g="0" b="0"/>
+      </a:fillRef>
+      <a:effectRef idx="0">
+        <a:scrgbClr r="0" g="0" b="0"/>
+      </a:effectRef>
+      <a:fontRef idx="minor"/>
+    </dgm:style>
+  </dgm:styleLbl>
+  <dgm:styleLbl name="fgAcc4">
+    <dgm:scene3d>
+      <a:camera prst="orthographicFront"/>
+      <a:lightRig rig="threePt" dir="t"/>
+    </dgm:scene3d>
+    <dgm:sp3d/>
+    <dgm:txPr/>
+    <dgm:style>
+      <a:lnRef idx="2">
+        <a:scrgbClr r="0" g="0" b="0"/>
+      </a:lnRef>
+      <a:fillRef idx="1">
+        <a:scrgbClr r="0" g="0" b="0"/>
+      </a:fillRef>
+      <a:effectRef idx="0">
+        <a:scrgbClr r="0" g="0" b="0"/>
+      </a:effectRef>
+      <a:fontRef idx="minor"/>
+    </dgm:style>
+  </dgm:styleLbl>
+  <dgm:styleLbl name="bgShp">
+    <dgm:scene3d>
+      <a:camera prst="orthographicFront"/>
+      <a:lightRig rig="threePt" dir="t"/>
+    </dgm:scene3d>
+    <dgm:sp3d/>
+    <dgm:txPr/>
+    <dgm:style>
+      <a:lnRef idx="0">
+        <a:scrgbClr r="0" g="0" b="0"/>
+      </a:lnRef>
+      <a:fillRef idx="1">
+        <a:scrgbClr r="0" g="0" b="0"/>
+      </a:fillRef>
+      <a:effectRef idx="0">
+        <a:scrgbClr r="0" g="0" b="0"/>
+      </a:effectRef>
+      <a:fontRef idx="minor"/>
+    </dgm:style>
+  </dgm:styleLbl>
+  <dgm:styleLbl name="dkBgShp">
+    <dgm:scene3d>
+      <a:camera prst="orthographicFront"/>
+      <a:lightRig rig="threePt" dir="t"/>
+    </dgm:scene3d>
+    <dgm:sp3d/>
+    <dgm:txPr/>
+    <dgm:style>
+      <a:lnRef idx="0">
+        <a:scrgbClr r="0" g="0" b="0"/>
+      </a:lnRef>
+      <a:fillRef idx="1">
+        <a:scrgbClr r="0" g="0" b="0"/>
+      </a:fillRef>
+      <a:effectRef idx="0">
+        <a:scrgbClr r="0" g="0" b="0"/>
+      </a:effectRef>
+      <a:fontRef idx="minor"/>
+    </dgm:style>
+  </dgm:styleLbl>
+  <dgm:styleLbl name="trBgShp">
+    <dgm:scene3d>
+      <a:camera prst="orthographicFront"/>
+      <a:lightRig rig="threePt" dir="t"/>
+    </dgm:scene3d>
+    <dgm:sp3d/>
+    <dgm:txPr/>
+    <dgm:style>
+      <a:lnRef idx="0">
+        <a:scrgbClr r="0" g="0" b="0"/>
+      </a:lnRef>
+      <a:fillRef idx="1">
+        <a:scrgbClr r="0" g="0" b="0"/>
+      </a:fillRef>
+      <a:effectRef idx="0">
+        <a:scrgbClr r="0" g="0" b="0"/>
+      </a:effectRef>
+      <a:fontRef idx="minor"/>
+    </dgm:style>
+  </dgm:styleLbl>
+  <dgm:styleLbl name="fgShp">
+    <dgm:scene3d>
+      <a:camera prst="orthographicFront"/>
+      <a:lightRig rig="threePt" dir="t"/>
+    </dgm:scene3d>
+    <dgm:sp3d/>
+    <dgm:txPr/>
+    <dgm:style>
+      <a:lnRef idx="2">
+        <a:scrgbClr r="0" g="0" b="0"/>
+      </a:lnRef>
+      <a:fillRef idx="1">
+        <a:scrgbClr r="0" g="0" b="0"/>
+      </a:fillRef>
+      <a:effectRef idx="0">
+        <a:scrgbClr r="0" g="0" b="0"/>
+      </a:effectRef>
+      <a:fontRef idx="minor"/>
+    </dgm:style>
+  </dgm:styleLbl>
+  <dgm:styleLbl name="revTx">
+    <dgm:scene3d>
+      <a:camera prst="orthographicFront"/>
+      <a:lightRig rig="threePt" dir="t"/>
+    </dgm:scene3d>
+    <dgm:sp3d/>
+    <dgm:txPr/>
+    <dgm:style>
+      <a:lnRef idx="0">
+        <a:scrgbClr r="0" g="0" b="0"/>
+      </a:lnRef>
+      <a:fillRef idx="0">
+        <a:scrgbClr r="0" g="0" b="0"/>
+      </a:fillRef>
+      <a:effectRef idx="0">
+        <a:scrgbClr r="0" g="0" b="0"/>
+      </a:effectRef>
+      <a:fontRef idx="minor"/>
+    </dgm:style>
+  </dgm:styleLbl>
+</dgm:styleDef>
+</file>
+
 <file path=ppt/notesMasters/notesMaster1.xml><?xml version="1.0" encoding="utf-8"?>
 <p:notesMaster xmlns:a="http://schemas.openxmlformats.org/drawingml/2006/main" xmlns:r="http://schemas.openxmlformats.org/officeDocument/2006/relationships" xmlns:p="http://schemas.openxmlformats.org/presentationml/2006/main">
   <p:cSld>
@@ -3843,6 +6979,15 @@
           <a:p>
             <a:r>
               <a:rPr lang="en-US" dirty="0"/>
+              <a:t>Spatial turnover in community composition (that is, the difference in abundance and diversity of biological communities between locations) is shaped by ecological drift, selection and dispersal</a:t>
+            </a:r>
+          </a:p>
+          <a:p>
+            <a:endParaRPr lang="en-US" dirty="0"/>
+          </a:p>
+          <a:p>
+            <a:r>
+              <a:rPr lang="en-US" dirty="0"/>
               <a:t>Community assembly processes can be stochastic or deterministic.</a:t>
             </a:r>
           </a:p>
@@ -4390,49 +7535,7 @@
           <a:p>
             <a:r>
               <a:rPr lang="en-US" dirty="0"/>
-              <a:t>Sloan’s Neutral Model states that the probability of species </a:t>
-            </a:r>
-            <a:r>
-              <a:rPr lang="en-US" i="1" dirty="0" err="1"/>
-              <a:t>i</a:t>
-            </a:r>
-            <a:r>
-              <a:rPr lang="en-US" dirty="0"/>
-              <a:t> occurring within a sample at abundance (x</a:t>
-            </a:r>
-            <a:r>
-              <a:rPr lang="en-US" i="0" baseline="-25000" dirty="0"/>
-              <a:t>i</a:t>
-            </a:r>
-            <a:r>
-              <a:rPr lang="en-US" dirty="0"/>
-              <a:t>) above a detection threshold (d) </a:t>
-            </a:r>
-          </a:p>
-          <a:p>
-            <a:endParaRPr lang="en-US" dirty="0"/>
-          </a:p>
-          <a:p>
-            <a:r>
-              <a:rPr lang="en-US" dirty="0"/>
-              <a:t>Model results are compared to the observed data. Deviation of observed data from model results is assumed to be evidence of deterministic community assembly.</a:t>
-            </a:r>
-          </a:p>
-          <a:p>
-            <a:endParaRPr lang="en-US" dirty="0"/>
-          </a:p>
-          <a:p>
-            <a:r>
-              <a:rPr lang="en-US" dirty="0"/>
-              <a:t>The abundance of each ASV in the metacommunity (p</a:t>
-            </a:r>
-            <a:r>
-              <a:rPr lang="en-US" i="1" dirty="0"/>
-              <a:t>i</a:t>
-            </a:r>
-            <a:r>
-              <a:rPr lang="en-US" dirty="0"/>
-              <a:t>) is estimated by averaging it’s relative abundance across all samples.</a:t>
+              <a:t>As the phylogenetic null model approach is dependent on phylogenetic signal </a:t>
             </a:r>
           </a:p>
         </p:txBody>
@@ -4454,7 +7557,7 @@
           <a:p>
             <a:fld id="{91AE2140-D502-214A-B76B-E0784B2C949B}" type="slidenum">
               <a:rPr lang="en-US" smtClean="0"/>
-              <a:t>18</a:t>
+              <a:t>16</a:t>
             </a:fld>
             <a:endParaRPr lang="en-US"/>
           </a:p>
@@ -4463,7 +7566,7 @@
     </p:spTree>
     <p:extLst>
       <p:ext uri="{BB962C8B-B14F-4D97-AF65-F5344CB8AC3E}">
-        <p14:creationId xmlns:p14="http://schemas.microsoft.com/office/powerpoint/2010/main" val="1811139538"/>
+        <p14:creationId xmlns:p14="http://schemas.microsoft.com/office/powerpoint/2010/main" val="1424753429"/>
       </p:ext>
     </p:extLst>
   </p:cSld>
@@ -4519,23 +7622,49 @@
           <a:p>
             <a:r>
               <a:rPr lang="en-US" dirty="0"/>
-              <a:t>Code developed from Barnett et al., (2020) Soil characteristics and land-use drive bacterial community assembly patterns (https://</a:t>
-            </a:r>
-            <a:r>
-              <a:rPr lang="en-US" dirty="0" err="1"/>
-              <a:t>github.com</a:t>
+              <a:t>Sloan’s Neutral Model states that the probability of species </a:t>
+            </a:r>
+            <a:r>
+              <a:rPr lang="en-US" i="1" dirty="0" err="1"/>
+              <a:t>i</a:t>
             </a:r>
             <a:r>
               <a:rPr lang="en-US" dirty="0"/>
-              <a:t>/seb369/</a:t>
-            </a:r>
-            <a:r>
-              <a:rPr lang="en-US" dirty="0" err="1"/>
-              <a:t>landuse_comm_assembly</a:t>
+              <a:t> occurring within a sample at abundance (x</a:t>
+            </a:r>
+            <a:r>
+              <a:rPr lang="en-US" i="0" baseline="-25000" dirty="0"/>
+              <a:t>i</a:t>
             </a:r>
             <a:r>
               <a:rPr lang="en-US" dirty="0"/>
-              <a:t>)</a:t>
+              <a:t>) above a detection threshold (d) </a:t>
+            </a:r>
+          </a:p>
+          <a:p>
+            <a:endParaRPr lang="en-US" dirty="0"/>
+          </a:p>
+          <a:p>
+            <a:r>
+              <a:rPr lang="en-US" dirty="0"/>
+              <a:t>Model results are compared to the observed data. Deviation of observed data from model results is assumed to be evidence of deterministic community assembly.</a:t>
+            </a:r>
+          </a:p>
+          <a:p>
+            <a:endParaRPr lang="en-US" dirty="0"/>
+          </a:p>
+          <a:p>
+            <a:r>
+              <a:rPr lang="en-US" dirty="0"/>
+              <a:t>The abundance of each ASV in the metacommunity (p</a:t>
+            </a:r>
+            <a:r>
+              <a:rPr lang="en-US" i="1" dirty="0"/>
+              <a:t>i</a:t>
+            </a:r>
+            <a:r>
+              <a:rPr lang="en-US" dirty="0"/>
+              <a:t>) is estimated by averaging it’s relative abundance across all samples.</a:t>
             </a:r>
           </a:p>
         </p:txBody>
@@ -4557,7 +7686,7 @@
           <a:p>
             <a:fld id="{91AE2140-D502-214A-B76B-E0784B2C949B}" type="slidenum">
               <a:rPr lang="en-US" smtClean="0"/>
-              <a:t>19</a:t>
+              <a:t>18</a:t>
             </a:fld>
             <a:endParaRPr lang="en-US"/>
           </a:p>
@@ -4566,7 +7695,7 @@
     </p:spTree>
     <p:extLst>
       <p:ext uri="{BB962C8B-B14F-4D97-AF65-F5344CB8AC3E}">
-        <p14:creationId xmlns:p14="http://schemas.microsoft.com/office/powerpoint/2010/main" val="2263901205"/>
+        <p14:creationId xmlns:p14="http://schemas.microsoft.com/office/powerpoint/2010/main" val="1811139538"/>
       </p:ext>
     </p:extLst>
   </p:cSld>
@@ -4622,6 +7751,109 @@
           <a:p>
             <a:r>
               <a:rPr lang="en-US" dirty="0"/>
+              <a:t>Code developed from Barnett et al., (2020) Soil characteristics and land-use drive bacterial community assembly patterns (https://</a:t>
+            </a:r>
+            <a:r>
+              <a:rPr lang="en-US" dirty="0" err="1"/>
+              <a:t>github.com</a:t>
+            </a:r>
+            <a:r>
+              <a:rPr lang="en-US" dirty="0"/>
+              <a:t>/seb369/</a:t>
+            </a:r>
+            <a:r>
+              <a:rPr lang="en-US" dirty="0" err="1"/>
+              <a:t>landuse_comm_assembly</a:t>
+            </a:r>
+            <a:r>
+              <a:rPr lang="en-US" dirty="0"/>
+              <a:t>)</a:t>
+            </a:r>
+          </a:p>
+        </p:txBody>
+      </p:sp>
+      <p:sp>
+        <p:nvSpPr>
+          <p:cNvPr id="4" name="Slide Number Placeholder 3"/>
+          <p:cNvSpPr>
+            <a:spLocks noGrp="1"/>
+          </p:cNvSpPr>
+          <p:nvPr>
+            <p:ph type="sldNum" sz="quarter" idx="5"/>
+          </p:nvPr>
+        </p:nvSpPr>
+        <p:spPr/>
+        <p:txBody>
+          <a:bodyPr/>
+          <a:lstStyle/>
+          <a:p>
+            <a:fld id="{91AE2140-D502-214A-B76B-E0784B2C949B}" type="slidenum">
+              <a:rPr lang="en-US" smtClean="0"/>
+              <a:t>19</a:t>
+            </a:fld>
+            <a:endParaRPr lang="en-US"/>
+          </a:p>
+        </p:txBody>
+      </p:sp>
+    </p:spTree>
+    <p:extLst>
+      <p:ext uri="{BB962C8B-B14F-4D97-AF65-F5344CB8AC3E}">
+        <p14:creationId xmlns:p14="http://schemas.microsoft.com/office/powerpoint/2010/main" val="2263901205"/>
+      </p:ext>
+    </p:extLst>
+  </p:cSld>
+  <p:clrMapOvr>
+    <a:masterClrMapping/>
+  </p:clrMapOvr>
+</p:notes>
+</file>
+
+<file path=ppt/notesSlides/notesSlide9.xml><?xml version="1.0" encoding="utf-8"?>
+<p:notes xmlns:a="http://schemas.openxmlformats.org/drawingml/2006/main" xmlns:r="http://schemas.openxmlformats.org/officeDocument/2006/relationships" xmlns:p="http://schemas.openxmlformats.org/presentationml/2006/main">
+  <p:cSld>
+    <p:spTree>
+      <p:nvGrpSpPr>
+        <p:cNvPr id="1" name=""/>
+        <p:cNvGrpSpPr/>
+        <p:nvPr/>
+      </p:nvGrpSpPr>
+      <p:grpSpPr>
+        <a:xfrm>
+          <a:off x="0" y="0"/>
+          <a:ext cx="0" cy="0"/>
+          <a:chOff x="0" y="0"/>
+          <a:chExt cx="0" cy="0"/>
+        </a:xfrm>
+      </p:grpSpPr>
+      <p:sp>
+        <p:nvSpPr>
+          <p:cNvPr id="2" name="Slide Image Placeholder 1"/>
+          <p:cNvSpPr>
+            <a:spLocks noGrp="1" noRot="1" noChangeAspect="1"/>
+          </p:cNvSpPr>
+          <p:nvPr>
+            <p:ph type="sldImg"/>
+          </p:nvPr>
+        </p:nvSpPr>
+        <p:spPr/>
+      </p:sp>
+      <p:sp>
+        <p:nvSpPr>
+          <p:cNvPr id="3" name="Notes Placeholder 2"/>
+          <p:cNvSpPr>
+            <a:spLocks noGrp="1"/>
+          </p:cNvSpPr>
+          <p:nvPr>
+            <p:ph type="body" idx="1"/>
+          </p:nvPr>
+        </p:nvSpPr>
+        <p:spPr/>
+        <p:txBody>
+          <a:bodyPr/>
+          <a:lstStyle/>
+          <a:p>
+            <a:r>
+              <a:rPr lang="en-US" dirty="0"/>
               <a:t>This is the result of the model fitting with the Sommers dataset (not reduced).</a:t>
             </a:r>
           </a:p>
@@ -4685,7 +7917,17 @@
           <a:p>
             <a:r>
               <a:rPr lang="en-US" dirty="0"/>
-              <a:t>These results suggest that </a:t>
+              <a:t>These results suggest that neutral assembly processes can explain the pattern of observed ASV occurrence frequencies </a:t>
+            </a:r>
+            <a:r>
+              <a:rPr lang="en-US" strike="sngStrike" dirty="0"/>
+              <a:t>and that the the regional species pool is a driving factor in the community composition of these samples. </a:t>
+            </a:r>
+          </a:p>
+          <a:p>
+            <a:r>
+              <a:rPr lang="en-US" strike="noStrike" dirty="0"/>
+              <a:t>The deviation of predicted occurrence frequencies from observed occurrence frequencies suggests that there are also deterministic processes driving community composition.</a:t>
             </a:r>
           </a:p>
           <a:p>
@@ -8634,7 +11876,7 @@
           </p:nvPr>
         </p:nvPicPr>
         <p:blipFill>
-          <a:blip r:embed="rId2"/>
+          <a:blip r:embed="rId3"/>
           <a:stretch>
             <a:fillRect/>
           </a:stretch>
@@ -10189,7 +13431,7 @@
           <p:cNvPr id="2" name="Title 1">
             <a:extLst>
               <a:ext uri="{FF2B5EF4-FFF2-40B4-BE49-F238E27FC236}">
-                <a16:creationId xmlns:a16="http://schemas.microsoft.com/office/drawing/2014/main" id="{6C0AE8A7-46CF-6A41-9356-95AD74775928}"/>
+                <a16:creationId xmlns:a16="http://schemas.microsoft.com/office/drawing/2014/main" id="{122A31DA-B431-C54A-874F-C1236B9B36B8}"/>
               </a:ext>
             </a:extLst>
           </p:cNvPr>
@@ -10207,70 +13449,1245 @@
           <a:p>
             <a:r>
               <a:rPr lang="en-US" dirty="0"/>
-              <a:t>Analysis</a:t>
+              <a:t>Why are they different? Why should we care?</a:t>
             </a:r>
           </a:p>
         </p:txBody>
       </p:sp>
       <p:sp>
         <p:nvSpPr>
-          <p:cNvPr id="3" name="Content Placeholder 2">
+          <p:cNvPr id="4" name="Oval 3">
             <a:extLst>
               <a:ext uri="{FF2B5EF4-FFF2-40B4-BE49-F238E27FC236}">
-                <a16:creationId xmlns:a16="http://schemas.microsoft.com/office/drawing/2014/main" id="{3F3B803F-4C3A-CD47-9287-492C0BABB02D}"/>
+                <a16:creationId xmlns:a16="http://schemas.microsoft.com/office/drawing/2014/main" id="{4075A81A-7D11-9448-BF36-6D732E7F151C}"/>
               </a:ext>
             </a:extLst>
           </p:cNvPr>
-          <p:cNvSpPr>
-            <a:spLocks noGrp="1"/>
-          </p:cNvSpPr>
-          <p:nvPr>
-            <p:ph idx="1"/>
-          </p:nvPr>
-        </p:nvSpPr>
-        <p:spPr/>
+          <p:cNvSpPr/>
+          <p:nvPr/>
+        </p:nvSpPr>
+        <p:spPr>
+          <a:xfrm>
+            <a:off x="2600326" y="3014662"/>
+            <a:ext cx="314325" cy="314325"/>
+          </a:xfrm>
+          <a:prstGeom prst="ellipse">
+            <a:avLst/>
+          </a:prstGeom>
+        </p:spPr>
+        <p:style>
+          <a:lnRef idx="2">
+            <a:schemeClr val="accent1">
+              <a:shade val="50000"/>
+            </a:schemeClr>
+          </a:lnRef>
+          <a:fillRef idx="1">
+            <a:schemeClr val="accent1"/>
+          </a:fillRef>
+          <a:effectRef idx="0">
+            <a:schemeClr val="accent1"/>
+          </a:effectRef>
+          <a:fontRef idx="minor">
+            <a:schemeClr val="lt1"/>
+          </a:fontRef>
+        </p:style>
         <p:txBody>
-          <a:bodyPr/>
+          <a:bodyPr rtlCol="0" anchor="ctr"/>
           <a:lstStyle/>
           <a:p>
-            <a:r>
-              <a:rPr lang="en-US" dirty="0"/>
-              <a:t>ISAR and DDR</a:t>
-            </a:r>
-          </a:p>
-          <a:p>
-            <a:r>
-              <a:rPr lang="en-US" dirty="0"/>
-              <a:t>Multivariate Analysis</a:t>
-            </a:r>
-          </a:p>
-          <a:p>
-            <a:r>
-              <a:rPr lang="en-US" dirty="0"/>
-              <a:t>Null Model</a:t>
-            </a:r>
-          </a:p>
-          <a:p>
-            <a:r>
-              <a:rPr lang="en-US" dirty="0"/>
-              <a:t>Neutral Model</a:t>
-            </a:r>
-          </a:p>
-          <a:p>
-            <a:r>
-              <a:rPr lang="en-US" dirty="0"/>
-              <a:t>Network Analysis</a:t>
-            </a:r>
-          </a:p>
-          <a:p>
-            <a:endParaRPr lang="en-US" dirty="0"/>
+            <a:pPr algn="ctr"/>
+            <a:endParaRPr lang="en-US"/>
+          </a:p>
+        </p:txBody>
+      </p:sp>
+      <p:sp>
+        <p:nvSpPr>
+          <p:cNvPr id="5" name="Oval 4">
+            <a:extLst>
+              <a:ext uri="{FF2B5EF4-FFF2-40B4-BE49-F238E27FC236}">
+                <a16:creationId xmlns:a16="http://schemas.microsoft.com/office/drawing/2014/main" id="{E4516562-A1F7-4A44-B228-68531F4F81E8}"/>
+              </a:ext>
+            </a:extLst>
+          </p:cNvPr>
+          <p:cNvSpPr/>
+          <p:nvPr/>
+        </p:nvSpPr>
+        <p:spPr>
+          <a:xfrm>
+            <a:off x="3467101" y="3752849"/>
+            <a:ext cx="314325" cy="314325"/>
+          </a:xfrm>
+          <a:prstGeom prst="ellipse">
+            <a:avLst/>
+          </a:prstGeom>
+        </p:spPr>
+        <p:style>
+          <a:lnRef idx="2">
+            <a:schemeClr val="accent1">
+              <a:shade val="50000"/>
+            </a:schemeClr>
+          </a:lnRef>
+          <a:fillRef idx="1">
+            <a:schemeClr val="accent1"/>
+          </a:fillRef>
+          <a:effectRef idx="0">
+            <a:schemeClr val="accent1"/>
+          </a:effectRef>
+          <a:fontRef idx="minor">
+            <a:schemeClr val="lt1"/>
+          </a:fontRef>
+        </p:style>
+        <p:txBody>
+          <a:bodyPr rtlCol="0" anchor="ctr"/>
+          <a:lstStyle/>
+          <a:p>
+            <a:pPr algn="ctr"/>
+            <a:endParaRPr lang="en-US"/>
+          </a:p>
+        </p:txBody>
+      </p:sp>
+      <p:sp>
+        <p:nvSpPr>
+          <p:cNvPr id="6" name="Oval 5">
+            <a:extLst>
+              <a:ext uri="{FF2B5EF4-FFF2-40B4-BE49-F238E27FC236}">
+                <a16:creationId xmlns:a16="http://schemas.microsoft.com/office/drawing/2014/main" id="{1ABEA4FE-AD89-454B-989F-A777676B2DAB}"/>
+              </a:ext>
+            </a:extLst>
+          </p:cNvPr>
+          <p:cNvSpPr/>
+          <p:nvPr/>
+        </p:nvSpPr>
+        <p:spPr>
+          <a:xfrm>
+            <a:off x="2586038" y="4410075"/>
+            <a:ext cx="314325" cy="314325"/>
+          </a:xfrm>
+          <a:prstGeom prst="ellipse">
+            <a:avLst/>
+          </a:prstGeom>
+          <a:solidFill>
+            <a:srgbClr val="92D050"/>
+          </a:solidFill>
+        </p:spPr>
+        <p:style>
+          <a:lnRef idx="2">
+            <a:schemeClr val="accent1">
+              <a:shade val="50000"/>
+            </a:schemeClr>
+          </a:lnRef>
+          <a:fillRef idx="1">
+            <a:schemeClr val="accent1"/>
+          </a:fillRef>
+          <a:effectRef idx="0">
+            <a:schemeClr val="accent1"/>
+          </a:effectRef>
+          <a:fontRef idx="minor">
+            <a:schemeClr val="lt1"/>
+          </a:fontRef>
+        </p:style>
+        <p:txBody>
+          <a:bodyPr rtlCol="0" anchor="ctr"/>
+          <a:lstStyle/>
+          <a:p>
+            <a:pPr algn="ctr"/>
+            <a:endParaRPr lang="en-US"/>
+          </a:p>
+        </p:txBody>
+      </p:sp>
+      <p:sp>
+        <p:nvSpPr>
+          <p:cNvPr id="7" name="Oval 6">
+            <a:extLst>
+              <a:ext uri="{FF2B5EF4-FFF2-40B4-BE49-F238E27FC236}">
+                <a16:creationId xmlns:a16="http://schemas.microsoft.com/office/drawing/2014/main" id="{4E83A67A-C00A-B342-BE75-24729CD2D02F}"/>
+              </a:ext>
+            </a:extLst>
+          </p:cNvPr>
+          <p:cNvSpPr/>
+          <p:nvPr/>
+        </p:nvSpPr>
+        <p:spPr>
+          <a:xfrm>
+            <a:off x="4724401" y="4567237"/>
+            <a:ext cx="314325" cy="314325"/>
+          </a:xfrm>
+          <a:prstGeom prst="ellipse">
+            <a:avLst/>
+          </a:prstGeom>
+        </p:spPr>
+        <p:style>
+          <a:lnRef idx="2">
+            <a:schemeClr val="accent1">
+              <a:shade val="50000"/>
+            </a:schemeClr>
+          </a:lnRef>
+          <a:fillRef idx="1">
+            <a:schemeClr val="accent1"/>
+          </a:fillRef>
+          <a:effectRef idx="0">
+            <a:schemeClr val="accent1"/>
+          </a:effectRef>
+          <a:fontRef idx="minor">
+            <a:schemeClr val="lt1"/>
+          </a:fontRef>
+        </p:style>
+        <p:txBody>
+          <a:bodyPr rtlCol="0" anchor="ctr"/>
+          <a:lstStyle/>
+          <a:p>
+            <a:pPr algn="ctr"/>
+            <a:endParaRPr lang="en-US"/>
+          </a:p>
+        </p:txBody>
+      </p:sp>
+      <p:sp>
+        <p:nvSpPr>
+          <p:cNvPr id="8" name="Oval 7">
+            <a:extLst>
+              <a:ext uri="{FF2B5EF4-FFF2-40B4-BE49-F238E27FC236}">
+                <a16:creationId xmlns:a16="http://schemas.microsoft.com/office/drawing/2014/main" id="{6F55F405-3566-B348-BF65-58C69A1A867A}"/>
+              </a:ext>
+            </a:extLst>
+          </p:cNvPr>
+          <p:cNvSpPr/>
+          <p:nvPr/>
+        </p:nvSpPr>
+        <p:spPr>
+          <a:xfrm>
+            <a:off x="3467101" y="5186360"/>
+            <a:ext cx="314325" cy="314325"/>
+          </a:xfrm>
+          <a:prstGeom prst="ellipse">
+            <a:avLst/>
+          </a:prstGeom>
+          <a:solidFill>
+            <a:srgbClr val="FFC000"/>
+          </a:solidFill>
+        </p:spPr>
+        <p:style>
+          <a:lnRef idx="2">
+            <a:schemeClr val="accent1">
+              <a:shade val="50000"/>
+            </a:schemeClr>
+          </a:lnRef>
+          <a:fillRef idx="1">
+            <a:schemeClr val="accent1"/>
+          </a:fillRef>
+          <a:effectRef idx="0">
+            <a:schemeClr val="accent1"/>
+          </a:effectRef>
+          <a:fontRef idx="minor">
+            <a:schemeClr val="lt1"/>
+          </a:fontRef>
+        </p:style>
+        <p:txBody>
+          <a:bodyPr rtlCol="0" anchor="ctr"/>
+          <a:lstStyle/>
+          <a:p>
+            <a:pPr algn="ctr"/>
+            <a:endParaRPr lang="en-US"/>
+          </a:p>
+        </p:txBody>
+      </p:sp>
+      <p:sp>
+        <p:nvSpPr>
+          <p:cNvPr id="9" name="Oval 8">
+            <a:extLst>
+              <a:ext uri="{FF2B5EF4-FFF2-40B4-BE49-F238E27FC236}">
+                <a16:creationId xmlns:a16="http://schemas.microsoft.com/office/drawing/2014/main" id="{EDD5ABE0-00B9-DD40-8C3A-A0CB5719BCBA}"/>
+              </a:ext>
+            </a:extLst>
+          </p:cNvPr>
+          <p:cNvSpPr/>
+          <p:nvPr/>
+        </p:nvSpPr>
+        <p:spPr>
+          <a:xfrm>
+            <a:off x="4410075" y="2800349"/>
+            <a:ext cx="314325" cy="314325"/>
+          </a:xfrm>
+          <a:prstGeom prst="ellipse">
+            <a:avLst/>
+          </a:prstGeom>
+          <a:solidFill>
+            <a:srgbClr val="FF0000"/>
+          </a:solidFill>
+        </p:spPr>
+        <p:style>
+          <a:lnRef idx="2">
+            <a:schemeClr val="accent1">
+              <a:shade val="50000"/>
+            </a:schemeClr>
+          </a:lnRef>
+          <a:fillRef idx="1">
+            <a:schemeClr val="accent1"/>
+          </a:fillRef>
+          <a:effectRef idx="0">
+            <a:schemeClr val="accent1"/>
+          </a:effectRef>
+          <a:fontRef idx="minor">
+            <a:schemeClr val="lt1"/>
+          </a:fontRef>
+        </p:style>
+        <p:txBody>
+          <a:bodyPr rtlCol="0" anchor="ctr"/>
+          <a:lstStyle/>
+          <a:p>
+            <a:pPr algn="ctr"/>
+            <a:endParaRPr lang="en-US"/>
+          </a:p>
+        </p:txBody>
+      </p:sp>
+      <p:sp>
+        <p:nvSpPr>
+          <p:cNvPr id="10" name="Oval 9">
+            <a:extLst>
+              <a:ext uri="{FF2B5EF4-FFF2-40B4-BE49-F238E27FC236}">
+                <a16:creationId xmlns:a16="http://schemas.microsoft.com/office/drawing/2014/main" id="{B26DB84F-E78D-2A48-A3F2-63B628D47B3F}"/>
+              </a:ext>
+            </a:extLst>
+          </p:cNvPr>
+          <p:cNvSpPr/>
+          <p:nvPr/>
+        </p:nvSpPr>
+        <p:spPr>
+          <a:xfrm>
+            <a:off x="3467100" y="3050382"/>
+            <a:ext cx="314325" cy="314325"/>
+          </a:xfrm>
+          <a:prstGeom prst="ellipse">
+            <a:avLst/>
+          </a:prstGeom>
+          <a:solidFill>
+            <a:srgbClr val="92D050"/>
+          </a:solidFill>
+          <a:ln>
+            <a:solidFill>
+              <a:schemeClr val="accent1"/>
+            </a:solidFill>
+          </a:ln>
+        </p:spPr>
+        <p:style>
+          <a:lnRef idx="2">
+            <a:schemeClr val="accent1">
+              <a:shade val="50000"/>
+            </a:schemeClr>
+          </a:lnRef>
+          <a:fillRef idx="1">
+            <a:schemeClr val="accent1"/>
+          </a:fillRef>
+          <a:effectRef idx="0">
+            <a:schemeClr val="accent1"/>
+          </a:effectRef>
+          <a:fontRef idx="minor">
+            <a:schemeClr val="lt1"/>
+          </a:fontRef>
+        </p:style>
+        <p:txBody>
+          <a:bodyPr rtlCol="0" anchor="ctr"/>
+          <a:lstStyle/>
+          <a:p>
+            <a:pPr algn="ctr"/>
+            <a:endParaRPr lang="en-US"/>
+          </a:p>
+        </p:txBody>
+      </p:sp>
+      <p:sp>
+        <p:nvSpPr>
+          <p:cNvPr id="11" name="Oval 10">
+            <a:extLst>
+              <a:ext uri="{FF2B5EF4-FFF2-40B4-BE49-F238E27FC236}">
+                <a16:creationId xmlns:a16="http://schemas.microsoft.com/office/drawing/2014/main" id="{DC502950-677E-3049-990E-AEC7AF21DD01}"/>
+              </a:ext>
+            </a:extLst>
+          </p:cNvPr>
+          <p:cNvSpPr/>
+          <p:nvPr/>
+        </p:nvSpPr>
+        <p:spPr>
+          <a:xfrm>
+            <a:off x="3967164" y="4410074"/>
+            <a:ext cx="314325" cy="314325"/>
+          </a:xfrm>
+          <a:prstGeom prst="ellipse">
+            <a:avLst/>
+          </a:prstGeom>
+          <a:solidFill>
+            <a:srgbClr val="92D050"/>
+          </a:solidFill>
+        </p:spPr>
+        <p:style>
+          <a:lnRef idx="2">
+            <a:schemeClr val="accent1">
+              <a:shade val="50000"/>
+            </a:schemeClr>
+          </a:lnRef>
+          <a:fillRef idx="1">
+            <a:schemeClr val="accent1"/>
+          </a:fillRef>
+          <a:effectRef idx="0">
+            <a:schemeClr val="accent1"/>
+          </a:effectRef>
+          <a:fontRef idx="minor">
+            <a:schemeClr val="lt1"/>
+          </a:fontRef>
+        </p:style>
+        <p:txBody>
+          <a:bodyPr rtlCol="0" anchor="ctr"/>
+          <a:lstStyle/>
+          <a:p>
+            <a:pPr algn="ctr"/>
+            <a:endParaRPr lang="en-US"/>
+          </a:p>
+        </p:txBody>
+      </p:sp>
+      <p:sp>
+        <p:nvSpPr>
+          <p:cNvPr id="12" name="Oval 11">
+            <a:extLst>
+              <a:ext uri="{FF2B5EF4-FFF2-40B4-BE49-F238E27FC236}">
+                <a16:creationId xmlns:a16="http://schemas.microsoft.com/office/drawing/2014/main" id="{45A94771-F505-D14F-B441-07C73CD0D66B}"/>
+              </a:ext>
+            </a:extLst>
+          </p:cNvPr>
+          <p:cNvSpPr/>
+          <p:nvPr/>
+        </p:nvSpPr>
+        <p:spPr>
+          <a:xfrm>
+            <a:off x="4567238" y="3752848"/>
+            <a:ext cx="314325" cy="314325"/>
+          </a:xfrm>
+          <a:prstGeom prst="ellipse">
+            <a:avLst/>
+          </a:prstGeom>
+        </p:spPr>
+        <p:style>
+          <a:lnRef idx="2">
+            <a:schemeClr val="accent1">
+              <a:shade val="50000"/>
+            </a:schemeClr>
+          </a:lnRef>
+          <a:fillRef idx="1">
+            <a:schemeClr val="accent1"/>
+          </a:fillRef>
+          <a:effectRef idx="0">
+            <a:schemeClr val="accent1"/>
+          </a:effectRef>
+          <a:fontRef idx="minor">
+            <a:schemeClr val="lt1"/>
+          </a:fontRef>
+        </p:style>
+        <p:txBody>
+          <a:bodyPr rtlCol="0" anchor="ctr"/>
+          <a:lstStyle/>
+          <a:p>
+            <a:pPr algn="ctr"/>
+            <a:endParaRPr lang="en-US"/>
+          </a:p>
+        </p:txBody>
+      </p:sp>
+      <p:sp>
+        <p:nvSpPr>
+          <p:cNvPr id="13" name="Oval 12">
+            <a:extLst>
+              <a:ext uri="{FF2B5EF4-FFF2-40B4-BE49-F238E27FC236}">
+                <a16:creationId xmlns:a16="http://schemas.microsoft.com/office/drawing/2014/main" id="{A3A575E6-7D11-6844-B659-F1F931279368}"/>
+              </a:ext>
+            </a:extLst>
+          </p:cNvPr>
+          <p:cNvSpPr/>
+          <p:nvPr/>
+        </p:nvSpPr>
+        <p:spPr>
+          <a:xfrm>
+            <a:off x="3119438" y="4710111"/>
+            <a:ext cx="314325" cy="314325"/>
+          </a:xfrm>
+          <a:prstGeom prst="ellipse">
+            <a:avLst/>
+          </a:prstGeom>
+        </p:spPr>
+        <p:style>
+          <a:lnRef idx="2">
+            <a:schemeClr val="accent1">
+              <a:shade val="50000"/>
+            </a:schemeClr>
+          </a:lnRef>
+          <a:fillRef idx="1">
+            <a:schemeClr val="accent1"/>
+          </a:fillRef>
+          <a:effectRef idx="0">
+            <a:schemeClr val="accent1"/>
+          </a:effectRef>
+          <a:fontRef idx="minor">
+            <a:schemeClr val="lt1"/>
+          </a:fontRef>
+        </p:style>
+        <p:txBody>
+          <a:bodyPr rtlCol="0" anchor="ctr"/>
+          <a:lstStyle/>
+          <a:p>
+            <a:pPr algn="ctr"/>
+            <a:endParaRPr lang="en-US"/>
+          </a:p>
+        </p:txBody>
+      </p:sp>
+      <p:sp>
+        <p:nvSpPr>
+          <p:cNvPr id="14" name="Oval 13">
+            <a:extLst>
+              <a:ext uri="{FF2B5EF4-FFF2-40B4-BE49-F238E27FC236}">
+                <a16:creationId xmlns:a16="http://schemas.microsoft.com/office/drawing/2014/main" id="{1D5E120C-A984-764E-B4EF-AA70BC53CD10}"/>
+              </a:ext>
+            </a:extLst>
+          </p:cNvPr>
+          <p:cNvSpPr/>
+          <p:nvPr/>
+        </p:nvSpPr>
+        <p:spPr>
+          <a:xfrm>
+            <a:off x="2728912" y="3867149"/>
+            <a:ext cx="314325" cy="314325"/>
+          </a:xfrm>
+          <a:prstGeom prst="ellipse">
+            <a:avLst/>
+          </a:prstGeom>
+        </p:spPr>
+        <p:style>
+          <a:lnRef idx="2">
+            <a:schemeClr val="accent1">
+              <a:shade val="50000"/>
+            </a:schemeClr>
+          </a:lnRef>
+          <a:fillRef idx="1">
+            <a:schemeClr val="accent1"/>
+          </a:fillRef>
+          <a:effectRef idx="0">
+            <a:schemeClr val="accent1"/>
+          </a:effectRef>
+          <a:fontRef idx="minor">
+            <a:schemeClr val="lt1"/>
+          </a:fontRef>
+        </p:style>
+        <p:txBody>
+          <a:bodyPr rtlCol="0" anchor="ctr"/>
+          <a:lstStyle/>
+          <a:p>
+            <a:pPr algn="ctr"/>
+            <a:endParaRPr lang="en-US"/>
+          </a:p>
+        </p:txBody>
+      </p:sp>
+      <p:sp>
+        <p:nvSpPr>
+          <p:cNvPr id="15" name="Oval 14">
+            <a:extLst>
+              <a:ext uri="{FF2B5EF4-FFF2-40B4-BE49-F238E27FC236}">
+                <a16:creationId xmlns:a16="http://schemas.microsoft.com/office/drawing/2014/main" id="{F4679495-EAA4-F64B-8588-1E9DEA49D4C8}"/>
+              </a:ext>
+            </a:extLst>
+          </p:cNvPr>
+          <p:cNvSpPr/>
+          <p:nvPr/>
+        </p:nvSpPr>
+        <p:spPr>
+          <a:xfrm>
+            <a:off x="3967163" y="3378993"/>
+            <a:ext cx="314325" cy="314325"/>
+          </a:xfrm>
+          <a:prstGeom prst="ellipse">
+            <a:avLst/>
+          </a:prstGeom>
+        </p:spPr>
+        <p:style>
+          <a:lnRef idx="2">
+            <a:schemeClr val="accent1">
+              <a:shade val="50000"/>
+            </a:schemeClr>
+          </a:lnRef>
+          <a:fillRef idx="1">
+            <a:schemeClr val="accent1"/>
+          </a:fillRef>
+          <a:effectRef idx="0">
+            <a:schemeClr val="accent1"/>
+          </a:effectRef>
+          <a:fontRef idx="minor">
+            <a:schemeClr val="lt1"/>
+          </a:fontRef>
+        </p:style>
+        <p:txBody>
+          <a:bodyPr rtlCol="0" anchor="ctr"/>
+          <a:lstStyle/>
+          <a:p>
+            <a:pPr algn="ctr"/>
+            <a:endParaRPr lang="en-US"/>
+          </a:p>
+        </p:txBody>
+      </p:sp>
+      <p:sp>
+        <p:nvSpPr>
+          <p:cNvPr id="16" name="Oval 15">
+            <a:extLst>
+              <a:ext uri="{FF2B5EF4-FFF2-40B4-BE49-F238E27FC236}">
+                <a16:creationId xmlns:a16="http://schemas.microsoft.com/office/drawing/2014/main" id="{BF75227F-3BDA-534D-AC82-AA532C3B808A}"/>
+              </a:ext>
+            </a:extLst>
+          </p:cNvPr>
+          <p:cNvSpPr/>
+          <p:nvPr/>
+        </p:nvSpPr>
+        <p:spPr>
+          <a:xfrm>
+            <a:off x="6524626" y="3014662"/>
+            <a:ext cx="314325" cy="314325"/>
+          </a:xfrm>
+          <a:prstGeom prst="ellipse">
+            <a:avLst/>
+          </a:prstGeom>
+          <a:solidFill>
+            <a:srgbClr val="FF00E5"/>
+          </a:solidFill>
+        </p:spPr>
+        <p:style>
+          <a:lnRef idx="2">
+            <a:schemeClr val="accent1">
+              <a:shade val="50000"/>
+            </a:schemeClr>
+          </a:lnRef>
+          <a:fillRef idx="1">
+            <a:schemeClr val="accent1"/>
+          </a:fillRef>
+          <a:effectRef idx="0">
+            <a:schemeClr val="accent1"/>
+          </a:effectRef>
+          <a:fontRef idx="minor">
+            <a:schemeClr val="lt1"/>
+          </a:fontRef>
+        </p:style>
+        <p:txBody>
+          <a:bodyPr rtlCol="0" anchor="ctr"/>
+          <a:lstStyle/>
+          <a:p>
+            <a:pPr algn="ctr"/>
+            <a:endParaRPr lang="en-US"/>
+          </a:p>
+        </p:txBody>
+      </p:sp>
+      <p:sp>
+        <p:nvSpPr>
+          <p:cNvPr id="17" name="Oval 16">
+            <a:extLst>
+              <a:ext uri="{FF2B5EF4-FFF2-40B4-BE49-F238E27FC236}">
+                <a16:creationId xmlns:a16="http://schemas.microsoft.com/office/drawing/2014/main" id="{AC9855B0-6DB2-1749-A1D4-4B1B81587D5F}"/>
+              </a:ext>
+            </a:extLst>
+          </p:cNvPr>
+          <p:cNvSpPr/>
+          <p:nvPr/>
+        </p:nvSpPr>
+        <p:spPr>
+          <a:xfrm>
+            <a:off x="7391401" y="3752849"/>
+            <a:ext cx="314325" cy="314325"/>
+          </a:xfrm>
+          <a:prstGeom prst="ellipse">
+            <a:avLst/>
+          </a:prstGeom>
+          <a:solidFill>
+            <a:srgbClr val="7030A0"/>
+          </a:solidFill>
+        </p:spPr>
+        <p:style>
+          <a:lnRef idx="2">
+            <a:schemeClr val="accent1">
+              <a:shade val="50000"/>
+            </a:schemeClr>
+          </a:lnRef>
+          <a:fillRef idx="1">
+            <a:schemeClr val="accent1"/>
+          </a:fillRef>
+          <a:effectRef idx="0">
+            <a:schemeClr val="accent1"/>
+          </a:effectRef>
+          <a:fontRef idx="minor">
+            <a:schemeClr val="lt1"/>
+          </a:fontRef>
+        </p:style>
+        <p:txBody>
+          <a:bodyPr rtlCol="0" anchor="ctr"/>
+          <a:lstStyle/>
+          <a:p>
+            <a:pPr algn="ctr"/>
+            <a:endParaRPr lang="en-US"/>
+          </a:p>
+        </p:txBody>
+      </p:sp>
+      <p:sp>
+        <p:nvSpPr>
+          <p:cNvPr id="18" name="Oval 17">
+            <a:extLst>
+              <a:ext uri="{FF2B5EF4-FFF2-40B4-BE49-F238E27FC236}">
+                <a16:creationId xmlns:a16="http://schemas.microsoft.com/office/drawing/2014/main" id="{19F5CB4E-153D-EF40-9DD1-4986310BA056}"/>
+              </a:ext>
+            </a:extLst>
+          </p:cNvPr>
+          <p:cNvSpPr/>
+          <p:nvPr/>
+        </p:nvSpPr>
+        <p:spPr>
+          <a:xfrm>
+            <a:off x="6510338" y="4410075"/>
+            <a:ext cx="314325" cy="314325"/>
+          </a:xfrm>
+          <a:prstGeom prst="ellipse">
+            <a:avLst/>
+          </a:prstGeom>
+          <a:solidFill>
+            <a:srgbClr val="FF0000"/>
+          </a:solidFill>
+        </p:spPr>
+        <p:style>
+          <a:lnRef idx="2">
+            <a:schemeClr val="accent1">
+              <a:shade val="50000"/>
+            </a:schemeClr>
+          </a:lnRef>
+          <a:fillRef idx="1">
+            <a:schemeClr val="accent1"/>
+          </a:fillRef>
+          <a:effectRef idx="0">
+            <a:schemeClr val="accent1"/>
+          </a:effectRef>
+          <a:fontRef idx="minor">
+            <a:schemeClr val="lt1"/>
+          </a:fontRef>
+        </p:style>
+        <p:txBody>
+          <a:bodyPr rtlCol="0" anchor="ctr"/>
+          <a:lstStyle/>
+          <a:p>
+            <a:pPr algn="ctr"/>
+            <a:endParaRPr lang="en-US"/>
+          </a:p>
+        </p:txBody>
+      </p:sp>
+      <p:sp>
+        <p:nvSpPr>
+          <p:cNvPr id="19" name="Oval 18">
+            <a:extLst>
+              <a:ext uri="{FF2B5EF4-FFF2-40B4-BE49-F238E27FC236}">
+                <a16:creationId xmlns:a16="http://schemas.microsoft.com/office/drawing/2014/main" id="{304877B3-DB5A-2E40-9762-5B3784FF014E}"/>
+              </a:ext>
+            </a:extLst>
+          </p:cNvPr>
+          <p:cNvSpPr/>
+          <p:nvPr/>
+        </p:nvSpPr>
+        <p:spPr>
+          <a:xfrm>
+            <a:off x="8648701" y="4567237"/>
+            <a:ext cx="314325" cy="314325"/>
+          </a:xfrm>
+          <a:prstGeom prst="ellipse">
+            <a:avLst/>
+          </a:prstGeom>
+          <a:solidFill>
+            <a:srgbClr val="FFFF00"/>
+          </a:solidFill>
+        </p:spPr>
+        <p:style>
+          <a:lnRef idx="2">
+            <a:schemeClr val="accent1">
+              <a:shade val="50000"/>
+            </a:schemeClr>
+          </a:lnRef>
+          <a:fillRef idx="1">
+            <a:schemeClr val="accent1"/>
+          </a:fillRef>
+          <a:effectRef idx="0">
+            <a:schemeClr val="accent1"/>
+          </a:effectRef>
+          <a:fontRef idx="minor">
+            <a:schemeClr val="lt1"/>
+          </a:fontRef>
+        </p:style>
+        <p:txBody>
+          <a:bodyPr rtlCol="0" anchor="ctr"/>
+          <a:lstStyle/>
+          <a:p>
+            <a:pPr algn="ctr"/>
+            <a:endParaRPr lang="en-US"/>
+          </a:p>
+        </p:txBody>
+      </p:sp>
+      <p:sp>
+        <p:nvSpPr>
+          <p:cNvPr id="20" name="Oval 19">
+            <a:extLst>
+              <a:ext uri="{FF2B5EF4-FFF2-40B4-BE49-F238E27FC236}">
+                <a16:creationId xmlns:a16="http://schemas.microsoft.com/office/drawing/2014/main" id="{E53C1F00-2970-264E-8F3C-13F5A89C374D}"/>
+              </a:ext>
+            </a:extLst>
+          </p:cNvPr>
+          <p:cNvSpPr/>
+          <p:nvPr/>
+        </p:nvSpPr>
+        <p:spPr>
+          <a:xfrm>
+            <a:off x="7391401" y="5186360"/>
+            <a:ext cx="314325" cy="314325"/>
+          </a:xfrm>
+          <a:prstGeom prst="ellipse">
+            <a:avLst/>
+          </a:prstGeom>
+          <a:solidFill>
+            <a:srgbClr val="FF00E5"/>
+          </a:solidFill>
+        </p:spPr>
+        <p:style>
+          <a:lnRef idx="2">
+            <a:schemeClr val="accent1">
+              <a:shade val="50000"/>
+            </a:schemeClr>
+          </a:lnRef>
+          <a:fillRef idx="1">
+            <a:schemeClr val="accent1"/>
+          </a:fillRef>
+          <a:effectRef idx="0">
+            <a:schemeClr val="accent1"/>
+          </a:effectRef>
+          <a:fontRef idx="minor">
+            <a:schemeClr val="lt1"/>
+          </a:fontRef>
+        </p:style>
+        <p:txBody>
+          <a:bodyPr rtlCol="0" anchor="ctr"/>
+          <a:lstStyle/>
+          <a:p>
+            <a:pPr algn="ctr"/>
+            <a:endParaRPr lang="en-US"/>
+          </a:p>
+        </p:txBody>
+      </p:sp>
+      <p:sp>
+        <p:nvSpPr>
+          <p:cNvPr id="21" name="Oval 20">
+            <a:extLst>
+              <a:ext uri="{FF2B5EF4-FFF2-40B4-BE49-F238E27FC236}">
+                <a16:creationId xmlns:a16="http://schemas.microsoft.com/office/drawing/2014/main" id="{CBE665D8-BD16-C443-A7DB-33C745F5F4C3}"/>
+              </a:ext>
+            </a:extLst>
+          </p:cNvPr>
+          <p:cNvSpPr/>
+          <p:nvPr/>
+        </p:nvSpPr>
+        <p:spPr>
+          <a:xfrm>
+            <a:off x="8334375" y="2800349"/>
+            <a:ext cx="314325" cy="314325"/>
+          </a:xfrm>
+          <a:prstGeom prst="ellipse">
+            <a:avLst/>
+          </a:prstGeom>
+          <a:solidFill>
+            <a:srgbClr val="00B0F0"/>
+          </a:solidFill>
+        </p:spPr>
+        <p:style>
+          <a:lnRef idx="2">
+            <a:schemeClr val="accent1">
+              <a:shade val="50000"/>
+            </a:schemeClr>
+          </a:lnRef>
+          <a:fillRef idx="1">
+            <a:schemeClr val="accent1"/>
+          </a:fillRef>
+          <a:effectRef idx="0">
+            <a:schemeClr val="accent1"/>
+          </a:effectRef>
+          <a:fontRef idx="minor">
+            <a:schemeClr val="lt1"/>
+          </a:fontRef>
+        </p:style>
+        <p:txBody>
+          <a:bodyPr rtlCol="0" anchor="ctr"/>
+          <a:lstStyle/>
+          <a:p>
+            <a:pPr algn="ctr"/>
+            <a:endParaRPr lang="en-US"/>
+          </a:p>
+        </p:txBody>
+      </p:sp>
+      <p:sp>
+        <p:nvSpPr>
+          <p:cNvPr id="22" name="Oval 21">
+            <a:extLst>
+              <a:ext uri="{FF2B5EF4-FFF2-40B4-BE49-F238E27FC236}">
+                <a16:creationId xmlns:a16="http://schemas.microsoft.com/office/drawing/2014/main" id="{8716A6E8-5194-1843-8740-7CFE1E71AC8C}"/>
+              </a:ext>
+            </a:extLst>
+          </p:cNvPr>
+          <p:cNvSpPr/>
+          <p:nvPr/>
+        </p:nvSpPr>
+        <p:spPr>
+          <a:xfrm>
+            <a:off x="7391400" y="3050382"/>
+            <a:ext cx="314325" cy="314325"/>
+          </a:xfrm>
+          <a:prstGeom prst="ellipse">
+            <a:avLst/>
+          </a:prstGeom>
+          <a:solidFill>
+            <a:srgbClr val="FFFF00"/>
+          </a:solidFill>
+        </p:spPr>
+        <p:style>
+          <a:lnRef idx="2">
+            <a:schemeClr val="accent1">
+              <a:shade val="50000"/>
+            </a:schemeClr>
+          </a:lnRef>
+          <a:fillRef idx="1">
+            <a:schemeClr val="accent1"/>
+          </a:fillRef>
+          <a:effectRef idx="0">
+            <a:schemeClr val="accent1"/>
+          </a:effectRef>
+          <a:fontRef idx="minor">
+            <a:schemeClr val="lt1"/>
+          </a:fontRef>
+        </p:style>
+        <p:txBody>
+          <a:bodyPr rtlCol="0" anchor="ctr"/>
+          <a:lstStyle/>
+          <a:p>
+            <a:pPr algn="ctr"/>
+            <a:endParaRPr lang="en-US"/>
+          </a:p>
+        </p:txBody>
+      </p:sp>
+      <p:sp>
+        <p:nvSpPr>
+          <p:cNvPr id="23" name="Oval 22">
+            <a:extLst>
+              <a:ext uri="{FF2B5EF4-FFF2-40B4-BE49-F238E27FC236}">
+                <a16:creationId xmlns:a16="http://schemas.microsoft.com/office/drawing/2014/main" id="{AC7232C0-D3C4-874D-B786-BB148BFF7049}"/>
+              </a:ext>
+            </a:extLst>
+          </p:cNvPr>
+          <p:cNvSpPr/>
+          <p:nvPr/>
+        </p:nvSpPr>
+        <p:spPr>
+          <a:xfrm>
+            <a:off x="7891464" y="4410074"/>
+            <a:ext cx="314325" cy="314325"/>
+          </a:xfrm>
+          <a:prstGeom prst="ellipse">
+            <a:avLst/>
+          </a:prstGeom>
+          <a:solidFill>
+            <a:srgbClr val="00B0F0"/>
+          </a:solidFill>
+        </p:spPr>
+        <p:style>
+          <a:lnRef idx="2">
+            <a:schemeClr val="accent1">
+              <a:shade val="50000"/>
+            </a:schemeClr>
+          </a:lnRef>
+          <a:fillRef idx="1">
+            <a:schemeClr val="accent1"/>
+          </a:fillRef>
+          <a:effectRef idx="0">
+            <a:schemeClr val="accent1"/>
+          </a:effectRef>
+          <a:fontRef idx="minor">
+            <a:schemeClr val="lt1"/>
+          </a:fontRef>
+        </p:style>
+        <p:txBody>
+          <a:bodyPr rtlCol="0" anchor="ctr"/>
+          <a:lstStyle/>
+          <a:p>
+            <a:pPr algn="ctr"/>
+            <a:endParaRPr lang="en-US"/>
+          </a:p>
+        </p:txBody>
+      </p:sp>
+      <p:sp>
+        <p:nvSpPr>
+          <p:cNvPr id="24" name="Oval 23">
+            <a:extLst>
+              <a:ext uri="{FF2B5EF4-FFF2-40B4-BE49-F238E27FC236}">
+                <a16:creationId xmlns:a16="http://schemas.microsoft.com/office/drawing/2014/main" id="{CFB75B72-7751-E244-927A-357FEE2AD292}"/>
+              </a:ext>
+            </a:extLst>
+          </p:cNvPr>
+          <p:cNvSpPr/>
+          <p:nvPr/>
+        </p:nvSpPr>
+        <p:spPr>
+          <a:xfrm>
+            <a:off x="8491538" y="3752848"/>
+            <a:ext cx="314325" cy="314325"/>
+          </a:xfrm>
+          <a:prstGeom prst="ellipse">
+            <a:avLst/>
+          </a:prstGeom>
+          <a:solidFill>
+            <a:srgbClr val="002060"/>
+          </a:solidFill>
+        </p:spPr>
+        <p:style>
+          <a:lnRef idx="2">
+            <a:schemeClr val="accent1">
+              <a:shade val="50000"/>
+            </a:schemeClr>
+          </a:lnRef>
+          <a:fillRef idx="1">
+            <a:schemeClr val="accent1"/>
+          </a:fillRef>
+          <a:effectRef idx="0">
+            <a:schemeClr val="accent1"/>
+          </a:effectRef>
+          <a:fontRef idx="minor">
+            <a:schemeClr val="lt1"/>
+          </a:fontRef>
+        </p:style>
+        <p:txBody>
+          <a:bodyPr rtlCol="0" anchor="ctr"/>
+          <a:lstStyle/>
+          <a:p>
+            <a:pPr algn="ctr"/>
+            <a:endParaRPr lang="en-US"/>
+          </a:p>
+        </p:txBody>
+      </p:sp>
+      <p:sp>
+        <p:nvSpPr>
+          <p:cNvPr id="25" name="Oval 24">
+            <a:extLst>
+              <a:ext uri="{FF2B5EF4-FFF2-40B4-BE49-F238E27FC236}">
+                <a16:creationId xmlns:a16="http://schemas.microsoft.com/office/drawing/2014/main" id="{5A90B763-4A6C-AE44-B10A-CAC54BEA55F6}"/>
+              </a:ext>
+            </a:extLst>
+          </p:cNvPr>
+          <p:cNvSpPr/>
+          <p:nvPr/>
+        </p:nvSpPr>
+        <p:spPr>
+          <a:xfrm>
+            <a:off x="7043738" y="4710111"/>
+            <a:ext cx="314325" cy="314325"/>
+          </a:xfrm>
+          <a:prstGeom prst="ellipse">
+            <a:avLst/>
+          </a:prstGeom>
+          <a:solidFill>
+            <a:srgbClr val="FFFF00"/>
+          </a:solidFill>
+        </p:spPr>
+        <p:style>
+          <a:lnRef idx="2">
+            <a:schemeClr val="accent1">
+              <a:shade val="50000"/>
+            </a:schemeClr>
+          </a:lnRef>
+          <a:fillRef idx="1">
+            <a:schemeClr val="accent1"/>
+          </a:fillRef>
+          <a:effectRef idx="0">
+            <a:schemeClr val="accent1"/>
+          </a:effectRef>
+          <a:fontRef idx="minor">
+            <a:schemeClr val="lt1"/>
+          </a:fontRef>
+        </p:style>
+        <p:txBody>
+          <a:bodyPr rtlCol="0" anchor="ctr"/>
+          <a:lstStyle/>
+          <a:p>
+            <a:pPr algn="ctr"/>
+            <a:endParaRPr lang="en-US"/>
+          </a:p>
+        </p:txBody>
+      </p:sp>
+      <p:sp>
+        <p:nvSpPr>
+          <p:cNvPr id="26" name="Oval 25">
+            <a:extLst>
+              <a:ext uri="{FF2B5EF4-FFF2-40B4-BE49-F238E27FC236}">
+                <a16:creationId xmlns:a16="http://schemas.microsoft.com/office/drawing/2014/main" id="{E608D13B-D12C-924F-8139-3E7E8F9E180F}"/>
+              </a:ext>
+            </a:extLst>
+          </p:cNvPr>
+          <p:cNvSpPr/>
+          <p:nvPr/>
+        </p:nvSpPr>
+        <p:spPr>
+          <a:xfrm>
+            <a:off x="6653212" y="3867149"/>
+            <a:ext cx="314325" cy="314325"/>
+          </a:xfrm>
+          <a:prstGeom prst="ellipse">
+            <a:avLst/>
+          </a:prstGeom>
+          <a:solidFill>
+            <a:srgbClr val="92D050"/>
+          </a:solidFill>
+        </p:spPr>
+        <p:style>
+          <a:lnRef idx="2">
+            <a:schemeClr val="accent1">
+              <a:shade val="50000"/>
+            </a:schemeClr>
+          </a:lnRef>
+          <a:fillRef idx="1">
+            <a:schemeClr val="accent1"/>
+          </a:fillRef>
+          <a:effectRef idx="0">
+            <a:schemeClr val="accent1"/>
+          </a:effectRef>
+          <a:fontRef idx="minor">
+            <a:schemeClr val="lt1"/>
+          </a:fontRef>
+        </p:style>
+        <p:txBody>
+          <a:bodyPr rtlCol="0" anchor="ctr"/>
+          <a:lstStyle/>
+          <a:p>
+            <a:pPr algn="ctr"/>
+            <a:endParaRPr lang="en-US"/>
+          </a:p>
+        </p:txBody>
+      </p:sp>
+      <p:sp>
+        <p:nvSpPr>
+          <p:cNvPr id="27" name="Oval 26">
+            <a:extLst>
+              <a:ext uri="{FF2B5EF4-FFF2-40B4-BE49-F238E27FC236}">
+                <a16:creationId xmlns:a16="http://schemas.microsoft.com/office/drawing/2014/main" id="{6549C0F0-8986-694D-A0BD-8647118E99FE}"/>
+              </a:ext>
+            </a:extLst>
+          </p:cNvPr>
+          <p:cNvSpPr/>
+          <p:nvPr/>
+        </p:nvSpPr>
+        <p:spPr>
+          <a:xfrm>
+            <a:off x="7891463" y="3378993"/>
+            <a:ext cx="314325" cy="314325"/>
+          </a:xfrm>
+          <a:prstGeom prst="ellipse">
+            <a:avLst/>
+          </a:prstGeom>
+          <a:solidFill>
+            <a:srgbClr val="FFC000"/>
+          </a:solidFill>
+        </p:spPr>
+        <p:style>
+          <a:lnRef idx="2">
+            <a:schemeClr val="accent1">
+              <a:shade val="50000"/>
+            </a:schemeClr>
+          </a:lnRef>
+          <a:fillRef idx="1">
+            <a:schemeClr val="accent1"/>
+          </a:fillRef>
+          <a:effectRef idx="0">
+            <a:schemeClr val="accent1"/>
+          </a:effectRef>
+          <a:fontRef idx="minor">
+            <a:schemeClr val="lt1"/>
+          </a:fontRef>
+        </p:style>
+        <p:txBody>
+          <a:bodyPr rtlCol="0" anchor="ctr"/>
+          <a:lstStyle/>
+          <a:p>
+            <a:pPr algn="ctr"/>
+            <a:endParaRPr lang="en-US"/>
+          </a:p>
+        </p:txBody>
+      </p:sp>
+      <p:sp>
+        <p:nvSpPr>
+          <p:cNvPr id="28" name="TextBox 27">
+            <a:extLst>
+              <a:ext uri="{FF2B5EF4-FFF2-40B4-BE49-F238E27FC236}">
+                <a16:creationId xmlns:a16="http://schemas.microsoft.com/office/drawing/2014/main" id="{EA335B55-8B52-5644-A550-2710A16DB226}"/>
+              </a:ext>
+            </a:extLst>
+          </p:cNvPr>
+          <p:cNvSpPr txBox="1"/>
+          <p:nvPr/>
+        </p:nvSpPr>
+        <p:spPr>
+          <a:xfrm>
+            <a:off x="2717006" y="1991378"/>
+            <a:ext cx="2164558" cy="523220"/>
+          </a:xfrm>
+          <a:prstGeom prst="rect">
+            <a:avLst/>
+          </a:prstGeom>
+          <a:noFill/>
+        </p:spPr>
+        <p:txBody>
+          <a:bodyPr wrap="square" rtlCol="0">
+            <a:spAutoFit/>
+          </a:bodyPr>
+          <a:lstStyle/>
+          <a:p>
+            <a:r>
+              <a:rPr lang="en-US" sz="2800" dirty="0"/>
+              <a:t>Community 1</a:t>
+            </a:r>
+          </a:p>
+        </p:txBody>
+      </p:sp>
+      <p:sp>
+        <p:nvSpPr>
+          <p:cNvPr id="29" name="TextBox 28">
+            <a:extLst>
+              <a:ext uri="{FF2B5EF4-FFF2-40B4-BE49-F238E27FC236}">
+                <a16:creationId xmlns:a16="http://schemas.microsoft.com/office/drawing/2014/main" id="{BC52BB93-C1D8-A04D-98AA-48CAD4AC9990}"/>
+              </a:ext>
+            </a:extLst>
+          </p:cNvPr>
+          <p:cNvSpPr txBox="1"/>
+          <p:nvPr/>
+        </p:nvSpPr>
+        <p:spPr>
+          <a:xfrm>
+            <a:off x="6667500" y="2015520"/>
+            <a:ext cx="2164558" cy="523220"/>
+          </a:xfrm>
+          <a:prstGeom prst="rect">
+            <a:avLst/>
+          </a:prstGeom>
+          <a:noFill/>
+        </p:spPr>
+        <p:txBody>
+          <a:bodyPr wrap="square" rtlCol="0">
+            <a:spAutoFit/>
+          </a:bodyPr>
+          <a:lstStyle/>
+          <a:p>
+            <a:r>
+              <a:rPr lang="en-US" sz="2800" dirty="0"/>
+              <a:t>Community 2</a:t>
+            </a:r>
           </a:p>
         </p:txBody>
       </p:sp>
     </p:spTree>
     <p:extLst>
       <p:ext uri="{BB962C8B-B14F-4D97-AF65-F5344CB8AC3E}">
-        <p14:creationId xmlns:p14="http://schemas.microsoft.com/office/powerpoint/2010/main" val="4079415005"/>
+        <p14:creationId xmlns:p14="http://schemas.microsoft.com/office/powerpoint/2010/main" val="3055002149"/>
       </p:ext>
     </p:extLst>
   </p:cSld>
@@ -10496,43 +14913,34 @@
           </a:p>
         </p:txBody>
       </p:sp>
-      <p:sp>
-        <p:nvSpPr>
-          <p:cNvPr id="3" name="Content Placeholder 2">
+      <p:graphicFrame>
+        <p:nvGraphicFramePr>
+          <p:cNvPr id="12" name="Diagram 11">
             <a:extLst>
               <a:ext uri="{FF2B5EF4-FFF2-40B4-BE49-F238E27FC236}">
-                <a16:creationId xmlns:a16="http://schemas.microsoft.com/office/drawing/2014/main" id="{653EEF6E-04AB-1745-84FB-768D011D176C}"/>
+                <a16:creationId xmlns:a16="http://schemas.microsoft.com/office/drawing/2014/main" id="{8B3002D7-459F-0B49-B4AD-4140562B12BC}"/>
               </a:ext>
             </a:extLst>
           </p:cNvPr>
-          <p:cNvSpPr>
-            <a:spLocks noGrp="1"/>
-          </p:cNvSpPr>
+          <p:cNvGraphicFramePr/>
           <p:nvPr>
-            <p:ph idx="1"/>
+            <p:extLst>
+              <p:ext uri="{D42A27DB-BD31-4B8C-83A1-F6EECF244321}">
+                <p14:modId xmlns:p14="http://schemas.microsoft.com/office/powerpoint/2010/main" val="662949717"/>
+              </p:ext>
+            </p:extLst>
           </p:nvPr>
-        </p:nvSpPr>
-        <p:spPr/>
-        <p:txBody>
-          <a:bodyPr/>
-          <a:lstStyle/>
-          <a:p>
-            <a:r>
-              <a:rPr lang="en-US" dirty="0"/>
-              <a:t>Stochastic (ecological drift – random birth and death events in the absence of selection) </a:t>
-            </a:r>
-          </a:p>
-          <a:p>
-            <a:r>
-              <a:rPr lang="en-US" dirty="0"/>
-              <a:t>Deterministic</a:t>
-            </a:r>
-          </a:p>
-          <a:p>
-            <a:endParaRPr lang="en-US" dirty="0"/>
-          </a:p>
-        </p:txBody>
-      </p:sp>
+        </p:nvGraphicFramePr>
+        <p:xfrm>
+          <a:off x="2489993" y="1690688"/>
+          <a:ext cx="7212013" cy="4808009"/>
+        </p:xfrm>
+        <a:graphic>
+          <a:graphicData uri="http://schemas.openxmlformats.org/drawingml/2006/diagram">
+            <dgm:relIds xmlns:dgm="http://schemas.openxmlformats.org/drawingml/2006/diagram" xmlns:r="http://schemas.openxmlformats.org/officeDocument/2006/relationships" r:dm="rId3" r:lo="rId4" r:qs="rId5" r:cs="rId6"/>
+          </a:graphicData>
+        </a:graphic>
+      </p:graphicFrame>
     </p:spTree>
     <p:extLst>
       <p:ext uri="{BB962C8B-B14F-4D97-AF65-F5344CB8AC3E}">

</xml_diff>

<commit_message>
Chapter 1 Scripts Update
</commit_message>
<xml_diff>
--- a/Projects/Chapter1/community-assembly.pptx
+++ b/Projects/Chapter1/community-assembly.pptx
@@ -5,7 +5,7 @@
     <p:sldMasterId id="2147483648" r:id="rId1"/>
   </p:sldMasterIdLst>
   <p:notesMasterIdLst>
-    <p:notesMasterId r:id="rId33"/>
+    <p:notesMasterId r:id="rId35"/>
   </p:notesMasterIdLst>
   <p:sldIdLst>
     <p:sldId id="256" r:id="rId2"/>
@@ -39,6 +39,8 @@
     <p:sldId id="265" r:id="rId30"/>
     <p:sldId id="260" r:id="rId31"/>
     <p:sldId id="262" r:id="rId32"/>
+    <p:sldId id="294" r:id="rId33"/>
+    <p:sldId id="295" r:id="rId34"/>
   </p:sldIdLst>
   <p:sldSz cx="12192000" cy="6858000"/>
   <p:notesSz cx="6858000" cy="9144000"/>
@@ -25813,6 +25815,29 @@
               <a:t>Because we want to understand the evolutionary and ecological mechanisms that govern microbial community composition at local scales, thus shaping large scale patterns of microbial biogeography. Community composition affects community function with profound impacts on the wider ecosystem functioning and biodiversity.  </a:t>
             </a:r>
           </a:p>
+          <a:p>
+            <a:endParaRPr lang="en-US" dirty="0"/>
+          </a:p>
+          <a:p>
+            <a:r>
+              <a:rPr lang="en-US" dirty="0"/>
+              <a:t>This study aims to develop an in-depth understanding of cryoconite community interactions and assembly processes. Particular questions of interest include:</a:t>
+            </a:r>
+          </a:p>
+          <a:p>
+            <a:r>
+              <a:rPr lang="en-US" dirty="0"/>
+              <a:t>(</a:t>
+            </a:r>
+            <a:r>
+              <a:rPr lang="en-US" dirty="0" err="1"/>
+              <a:t>i</a:t>
+            </a:r>
+            <a:r>
+              <a:rPr lang="en-US" dirty="0"/>
+              <a:t>) Do cryoconite community exhibit nonrandom co-occurrence patterns?</a:t>
+            </a:r>
+          </a:p>
         </p:txBody>
       </p:sp>
       <p:sp>
@@ -27306,6 +27331,376 @@
     <p:extLst>
       <p:ext uri="{BB962C8B-B14F-4D97-AF65-F5344CB8AC3E}">
         <p14:creationId xmlns:p14="http://schemas.microsoft.com/office/powerpoint/2010/main" val="3990178089"/>
+      </p:ext>
+    </p:extLst>
+  </p:cSld>
+  <p:clrMapOvr>
+    <a:masterClrMapping/>
+  </p:clrMapOvr>
+</p:notes>
+</file>
+
+<file path=ppt/notesSlides/notesSlide20.xml><?xml version="1.0" encoding="utf-8"?>
+<p:notes xmlns:a="http://schemas.openxmlformats.org/drawingml/2006/main" xmlns:r="http://schemas.openxmlformats.org/officeDocument/2006/relationships" xmlns:p="http://schemas.openxmlformats.org/presentationml/2006/main">
+  <p:cSld>
+    <p:spTree>
+      <p:nvGrpSpPr>
+        <p:cNvPr id="1" name=""/>
+        <p:cNvGrpSpPr/>
+        <p:nvPr/>
+      </p:nvGrpSpPr>
+      <p:grpSpPr>
+        <a:xfrm>
+          <a:off x="0" y="0"/>
+          <a:ext cx="0" cy="0"/>
+          <a:chOff x="0" y="0"/>
+          <a:chExt cx="0" cy="0"/>
+        </a:xfrm>
+      </p:grpSpPr>
+      <p:sp>
+        <p:nvSpPr>
+          <p:cNvPr id="2" name="Slide Image Placeholder 1"/>
+          <p:cNvSpPr>
+            <a:spLocks noGrp="1" noRot="1" noChangeAspect="1"/>
+          </p:cNvSpPr>
+          <p:nvPr>
+            <p:ph type="sldImg"/>
+          </p:nvPr>
+        </p:nvSpPr>
+        <p:spPr/>
+      </p:sp>
+      <p:sp>
+        <p:nvSpPr>
+          <p:cNvPr id="3" name="Notes Placeholder 2"/>
+          <p:cNvSpPr>
+            <a:spLocks noGrp="1"/>
+          </p:cNvSpPr>
+          <p:nvPr>
+            <p:ph type="body" idx="1"/>
+          </p:nvPr>
+        </p:nvSpPr>
+        <p:spPr/>
+        <p:txBody>
+          <a:bodyPr/>
+          <a:lstStyle/>
+          <a:p>
+            <a:r>
+              <a:rPr lang="en-US" dirty="0"/>
+              <a:t>Whilst multivariate analysis can assist us in investigating abiotic selection, microbial community assembly is also shaped by biotic selection. </a:t>
+            </a:r>
+          </a:p>
+          <a:p>
+            <a:endParaRPr lang="en-US" dirty="0"/>
+          </a:p>
+          <a:p>
+            <a:r>
+              <a:rPr lang="en-US" dirty="0"/>
+              <a:t>Biotic interactions may include top-down control through viral lysis and grazing, as well as microbe-microbe interactions.</a:t>
+            </a:r>
+          </a:p>
+          <a:p>
+            <a:endParaRPr lang="en-US" dirty="0"/>
+          </a:p>
+          <a:p>
+            <a:r>
+              <a:rPr lang="en-US" dirty="0"/>
+              <a:t>Due to technological restrictions, investigations of microbe-microbe interactions have typically been limited. With access to high-throughout sequencing, we can now construct co-occurrence networks in an attempt to decipher intra- and inter-specific interactions within communities.</a:t>
+            </a:r>
+          </a:p>
+          <a:p>
+            <a:endParaRPr lang="en-US" dirty="0"/>
+          </a:p>
+          <a:p>
+            <a:r>
+              <a:rPr lang="en-US" dirty="0"/>
+              <a:t>Previous research has indicated that microbial communities exhibit non-random co-occurrence patterns and module structures, suggesting that biotic selection plays a strong role in shaping community assembly.</a:t>
+            </a:r>
+          </a:p>
+          <a:p>
+            <a:endParaRPr lang="en-US" dirty="0"/>
+          </a:p>
+          <a:p>
+            <a:r>
+              <a:rPr lang="en-US" dirty="0"/>
+              <a:t>Communities may even </a:t>
+            </a:r>
+            <a:r>
+              <a:rPr lang="en-US" dirty="0" err="1"/>
+              <a:t>centre</a:t>
+            </a:r>
+            <a:r>
+              <a:rPr lang="en-US" dirty="0"/>
+              <a:t> around keystone species, that maintain the functioning of the community as a whole. </a:t>
+            </a:r>
+          </a:p>
+        </p:txBody>
+      </p:sp>
+      <p:sp>
+        <p:nvSpPr>
+          <p:cNvPr id="4" name="Slide Number Placeholder 3"/>
+          <p:cNvSpPr>
+            <a:spLocks noGrp="1"/>
+          </p:cNvSpPr>
+          <p:nvPr>
+            <p:ph type="sldNum" sz="quarter" idx="5"/>
+          </p:nvPr>
+        </p:nvSpPr>
+        <p:spPr/>
+        <p:txBody>
+          <a:bodyPr/>
+          <a:lstStyle/>
+          <a:p>
+            <a:fld id="{91AE2140-D502-214A-B76B-E0784B2C949B}" type="slidenum">
+              <a:rPr lang="en-US" smtClean="0"/>
+              <a:t>31</a:t>
+            </a:fld>
+            <a:endParaRPr lang="en-US"/>
+          </a:p>
+        </p:txBody>
+      </p:sp>
+    </p:spTree>
+    <p:extLst>
+      <p:ext uri="{BB962C8B-B14F-4D97-AF65-F5344CB8AC3E}">
+        <p14:creationId xmlns:p14="http://schemas.microsoft.com/office/powerpoint/2010/main" val="2107534487"/>
+      </p:ext>
+    </p:extLst>
+  </p:cSld>
+  <p:clrMapOvr>
+    <a:masterClrMapping/>
+  </p:clrMapOvr>
+</p:notes>
+</file>
+
+<file path=ppt/notesSlides/notesSlide21.xml><?xml version="1.0" encoding="utf-8"?>
+<p:notes xmlns:a="http://schemas.openxmlformats.org/drawingml/2006/main" xmlns:r="http://schemas.openxmlformats.org/officeDocument/2006/relationships" xmlns:p="http://schemas.openxmlformats.org/presentationml/2006/main">
+  <p:cSld>
+    <p:spTree>
+      <p:nvGrpSpPr>
+        <p:cNvPr id="1" name=""/>
+        <p:cNvGrpSpPr/>
+        <p:nvPr/>
+      </p:nvGrpSpPr>
+      <p:grpSpPr>
+        <a:xfrm>
+          <a:off x="0" y="0"/>
+          <a:ext cx="0" cy="0"/>
+          <a:chOff x="0" y="0"/>
+          <a:chExt cx="0" cy="0"/>
+        </a:xfrm>
+      </p:grpSpPr>
+      <p:sp>
+        <p:nvSpPr>
+          <p:cNvPr id="2" name="Slide Image Placeholder 1"/>
+          <p:cNvSpPr>
+            <a:spLocks noGrp="1" noRot="1" noChangeAspect="1"/>
+          </p:cNvSpPr>
+          <p:nvPr>
+            <p:ph type="sldImg"/>
+          </p:nvPr>
+        </p:nvSpPr>
+        <p:spPr/>
+      </p:sp>
+      <p:sp>
+        <p:nvSpPr>
+          <p:cNvPr id="3" name="Notes Placeholder 2"/>
+          <p:cNvSpPr>
+            <a:spLocks noGrp="1"/>
+          </p:cNvSpPr>
+          <p:nvPr>
+            <p:ph type="body" idx="1"/>
+          </p:nvPr>
+        </p:nvSpPr>
+        <p:spPr/>
+        <p:txBody>
+          <a:bodyPr/>
+          <a:lstStyle/>
+          <a:p>
+            <a:r>
+              <a:rPr lang="en-US" dirty="0"/>
+              <a:t>Centrality – how close is a node to the network as a whole </a:t>
+            </a:r>
+          </a:p>
+          <a:p>
+            <a:pPr marL="0" marR="0" lvl="0" indent="0" algn="l" defTabSz="914400" rtl="0" eaLnBrk="1" fontAlgn="auto" latinLnBrk="0" hangingPunct="1">
+              <a:lnSpc>
+                <a:spcPct val="100000"/>
+              </a:lnSpc>
+              <a:spcBef>
+                <a:spcPts val="0"/>
+              </a:spcBef>
+              <a:spcAft>
+                <a:spcPts val="0"/>
+              </a:spcAft>
+              <a:buClrTx/>
+              <a:buSzTx/>
+              <a:buFontTx/>
+              <a:buNone/>
+              <a:tabLst/>
+              <a:defRPr/>
+            </a:pPr>
+            <a:r>
+              <a:rPr lang="en-US" dirty="0"/>
+              <a:t>Degree Centrality – number of links connected to a node (who has the most friends?)</a:t>
+            </a:r>
+          </a:p>
+          <a:p>
+            <a:r>
+              <a:rPr lang="en-US" dirty="0"/>
+              <a:t>Closeness Centrality -  average length of the shortest path between the node and all other nodes in the graph (how long does it take me on average to reach another node)</a:t>
+            </a:r>
+          </a:p>
+          <a:p>
+            <a:r>
+              <a:rPr lang="en-US" dirty="0"/>
+              <a:t>Betweenness Centrality – the number of times a node is crossed by each of the shortest routes between nodes (between any two nodes there is a shortest distance to travel. How many shortest distances is the node of interest within?)</a:t>
+            </a:r>
+          </a:p>
+          <a:p>
+            <a:endParaRPr lang="en-US" dirty="0"/>
+          </a:p>
+          <a:p>
+            <a:r>
+              <a:rPr lang="en-US" dirty="0"/>
+              <a:t>Clustering</a:t>
+            </a:r>
+          </a:p>
+          <a:p>
+            <a:r>
+              <a:rPr lang="en-US" dirty="0"/>
+              <a:t>What groups are within the network?</a:t>
+            </a:r>
+          </a:p>
+          <a:p>
+            <a:r>
+              <a:rPr lang="en-US" dirty="0"/>
+              <a:t>Clustering coefficient – how many connections are there to other nodes, compared to the POTENTIAL number of connections to other nodes within the group?</a:t>
+            </a:r>
+          </a:p>
+          <a:p>
+            <a:r>
+              <a:rPr lang="en-US" dirty="0"/>
+              <a:t>Clustering coefficient = 1 means there is a clique, so all nodes are connected to each other in a group</a:t>
+            </a:r>
+          </a:p>
+          <a:p>
+            <a:endParaRPr lang="en-US" dirty="0"/>
+          </a:p>
+          <a:p>
+            <a:endParaRPr lang="en-US" dirty="0"/>
+          </a:p>
+        </p:txBody>
+      </p:sp>
+      <p:sp>
+        <p:nvSpPr>
+          <p:cNvPr id="4" name="Slide Number Placeholder 3"/>
+          <p:cNvSpPr>
+            <a:spLocks noGrp="1"/>
+          </p:cNvSpPr>
+          <p:nvPr>
+            <p:ph type="sldNum" sz="quarter" idx="5"/>
+          </p:nvPr>
+        </p:nvSpPr>
+        <p:spPr/>
+        <p:txBody>
+          <a:bodyPr/>
+          <a:lstStyle/>
+          <a:p>
+            <a:fld id="{91AE2140-D502-214A-B76B-E0784B2C949B}" type="slidenum">
+              <a:rPr lang="en-US" smtClean="0"/>
+              <a:t>32</a:t>
+            </a:fld>
+            <a:endParaRPr lang="en-US"/>
+          </a:p>
+        </p:txBody>
+      </p:sp>
+    </p:spTree>
+    <p:extLst>
+      <p:ext uri="{BB962C8B-B14F-4D97-AF65-F5344CB8AC3E}">
+        <p14:creationId xmlns:p14="http://schemas.microsoft.com/office/powerpoint/2010/main" val="553393038"/>
+      </p:ext>
+    </p:extLst>
+  </p:cSld>
+  <p:clrMapOvr>
+    <a:masterClrMapping/>
+  </p:clrMapOvr>
+</p:notes>
+</file>
+
+<file path=ppt/notesSlides/notesSlide22.xml><?xml version="1.0" encoding="utf-8"?>
+<p:notes xmlns:a="http://schemas.openxmlformats.org/drawingml/2006/main" xmlns:r="http://schemas.openxmlformats.org/officeDocument/2006/relationships" xmlns:p="http://schemas.openxmlformats.org/presentationml/2006/main">
+  <p:cSld>
+    <p:spTree>
+      <p:nvGrpSpPr>
+        <p:cNvPr id="1" name=""/>
+        <p:cNvGrpSpPr/>
+        <p:nvPr/>
+      </p:nvGrpSpPr>
+      <p:grpSpPr>
+        <a:xfrm>
+          <a:off x="0" y="0"/>
+          <a:ext cx="0" cy="0"/>
+          <a:chOff x="0" y="0"/>
+          <a:chExt cx="0" cy="0"/>
+        </a:xfrm>
+      </p:grpSpPr>
+      <p:sp>
+        <p:nvSpPr>
+          <p:cNvPr id="2" name="Slide Image Placeholder 1"/>
+          <p:cNvSpPr>
+            <a:spLocks noGrp="1" noRot="1" noChangeAspect="1"/>
+          </p:cNvSpPr>
+          <p:nvPr>
+            <p:ph type="sldImg"/>
+          </p:nvPr>
+        </p:nvSpPr>
+        <p:spPr/>
+      </p:sp>
+      <p:sp>
+        <p:nvSpPr>
+          <p:cNvPr id="3" name="Notes Placeholder 2"/>
+          <p:cNvSpPr>
+            <a:spLocks noGrp="1"/>
+          </p:cNvSpPr>
+          <p:nvPr>
+            <p:ph type="body" idx="1"/>
+          </p:nvPr>
+        </p:nvSpPr>
+        <p:spPr/>
+        <p:txBody>
+          <a:bodyPr/>
+          <a:lstStyle/>
+          <a:p>
+            <a:endParaRPr lang="en-US" dirty="0"/>
+          </a:p>
+        </p:txBody>
+      </p:sp>
+      <p:sp>
+        <p:nvSpPr>
+          <p:cNvPr id="4" name="Slide Number Placeholder 3"/>
+          <p:cNvSpPr>
+            <a:spLocks noGrp="1"/>
+          </p:cNvSpPr>
+          <p:nvPr>
+            <p:ph type="sldNum" sz="quarter" idx="5"/>
+          </p:nvPr>
+        </p:nvSpPr>
+        <p:spPr/>
+        <p:txBody>
+          <a:bodyPr/>
+          <a:lstStyle/>
+          <a:p>
+            <a:fld id="{91AE2140-D502-214A-B76B-E0784B2C949B}" type="slidenum">
+              <a:rPr lang="en-US" smtClean="0"/>
+              <a:t>33</a:t>
+            </a:fld>
+            <a:endParaRPr lang="en-US"/>
+          </a:p>
+        </p:txBody>
+      </p:sp>
+    </p:spTree>
+    <p:extLst>
+      <p:ext uri="{BB962C8B-B14F-4D97-AF65-F5344CB8AC3E}">
+        <p14:creationId xmlns:p14="http://schemas.microsoft.com/office/powerpoint/2010/main" val="2121078948"/>
       </p:ext>
     </p:extLst>
   </p:cSld>
@@ -38439,6 +38834,222 @@
     <p:extLst>
       <p:ext uri="{BB962C8B-B14F-4D97-AF65-F5344CB8AC3E}">
         <p14:creationId xmlns:p14="http://schemas.microsoft.com/office/powerpoint/2010/main" val="1804698877"/>
+      </p:ext>
+    </p:extLst>
+  </p:cSld>
+  <p:clrMapOvr>
+    <a:masterClrMapping/>
+  </p:clrMapOvr>
+</p:sld>
+</file>
+
+<file path=ppt/slides/slide32.xml><?xml version="1.0" encoding="utf-8"?>
+<p:sld xmlns:a="http://schemas.openxmlformats.org/drawingml/2006/main" xmlns:r="http://schemas.openxmlformats.org/officeDocument/2006/relationships" xmlns:p="http://schemas.openxmlformats.org/presentationml/2006/main">
+  <p:cSld>
+    <p:spTree>
+      <p:nvGrpSpPr>
+        <p:cNvPr id="1" name=""/>
+        <p:cNvGrpSpPr/>
+        <p:nvPr/>
+      </p:nvGrpSpPr>
+      <p:grpSpPr>
+        <a:xfrm>
+          <a:off x="0" y="0"/>
+          <a:ext cx="0" cy="0"/>
+          <a:chOff x="0" y="0"/>
+          <a:chExt cx="0" cy="0"/>
+        </a:xfrm>
+      </p:grpSpPr>
+      <p:sp>
+        <p:nvSpPr>
+          <p:cNvPr id="2" name="Title 1">
+            <a:extLst>
+              <a:ext uri="{FF2B5EF4-FFF2-40B4-BE49-F238E27FC236}">
+                <a16:creationId xmlns:a16="http://schemas.microsoft.com/office/drawing/2014/main" id="{91708ED6-3AC3-C74A-BC09-4ACE99BE8CEA}"/>
+              </a:ext>
+            </a:extLst>
+          </p:cNvPr>
+          <p:cNvSpPr>
+            <a:spLocks noGrp="1"/>
+          </p:cNvSpPr>
+          <p:nvPr>
+            <p:ph type="title"/>
+          </p:nvPr>
+        </p:nvSpPr>
+        <p:spPr>
+          <a:solidFill>
+            <a:srgbClr val="5C9BD5"/>
+          </a:solidFill>
+        </p:spPr>
+        <p:txBody>
+          <a:bodyPr/>
+          <a:lstStyle/>
+          <a:p>
+            <a:r>
+              <a:rPr lang="en-US" dirty="0">
+                <a:solidFill>
+                  <a:schemeClr val="bg1"/>
+                </a:solidFill>
+              </a:rPr>
+              <a:t>Centrality and Clustering</a:t>
+            </a:r>
+          </a:p>
+        </p:txBody>
+      </p:sp>
+      <p:sp>
+        <p:nvSpPr>
+          <p:cNvPr id="3" name="Content Placeholder 2">
+            <a:extLst>
+              <a:ext uri="{FF2B5EF4-FFF2-40B4-BE49-F238E27FC236}">
+                <a16:creationId xmlns:a16="http://schemas.microsoft.com/office/drawing/2014/main" id="{AE5C1FCC-630C-704F-9B87-76F833E6EB7A}"/>
+              </a:ext>
+            </a:extLst>
+          </p:cNvPr>
+          <p:cNvSpPr>
+            <a:spLocks noGrp="1"/>
+          </p:cNvSpPr>
+          <p:nvPr>
+            <p:ph idx="1"/>
+          </p:nvPr>
+        </p:nvSpPr>
+        <p:spPr/>
+        <p:txBody>
+          <a:bodyPr/>
+          <a:lstStyle/>
+          <a:p>
+            <a:r>
+              <a:rPr lang="en-US" dirty="0"/>
+              <a:t>Degree Centrality</a:t>
+            </a:r>
+          </a:p>
+          <a:p>
+            <a:r>
+              <a:rPr lang="en-US" dirty="0"/>
+              <a:t>Closeness Centrality</a:t>
+            </a:r>
+          </a:p>
+          <a:p>
+            <a:r>
+              <a:rPr lang="en-US" dirty="0"/>
+              <a:t>Betweenness Centrality</a:t>
+            </a:r>
+          </a:p>
+          <a:p>
+            <a:r>
+              <a:rPr lang="en-US" dirty="0"/>
+              <a:t>Clustering coefficient</a:t>
+            </a:r>
+          </a:p>
+          <a:p>
+            <a:endParaRPr lang="en-US" dirty="0"/>
+          </a:p>
+        </p:txBody>
+      </p:sp>
+    </p:spTree>
+    <p:extLst>
+      <p:ext uri="{BB962C8B-B14F-4D97-AF65-F5344CB8AC3E}">
+        <p14:creationId xmlns:p14="http://schemas.microsoft.com/office/powerpoint/2010/main" val="3748687434"/>
+      </p:ext>
+    </p:extLst>
+  </p:cSld>
+  <p:clrMapOvr>
+    <a:masterClrMapping/>
+  </p:clrMapOvr>
+</p:sld>
+</file>
+
+<file path=ppt/slides/slide33.xml><?xml version="1.0" encoding="utf-8"?>
+<p:sld xmlns:a="http://schemas.openxmlformats.org/drawingml/2006/main" xmlns:r="http://schemas.openxmlformats.org/officeDocument/2006/relationships" xmlns:p="http://schemas.openxmlformats.org/presentationml/2006/main">
+  <p:cSld>
+    <p:spTree>
+      <p:nvGrpSpPr>
+        <p:cNvPr id="1" name=""/>
+        <p:cNvGrpSpPr/>
+        <p:nvPr/>
+      </p:nvGrpSpPr>
+      <p:grpSpPr>
+        <a:xfrm>
+          <a:off x="0" y="0"/>
+          <a:ext cx="0" cy="0"/>
+          <a:chOff x="0" y="0"/>
+          <a:chExt cx="0" cy="0"/>
+        </a:xfrm>
+      </p:grpSpPr>
+      <p:sp>
+        <p:nvSpPr>
+          <p:cNvPr id="2" name="Title 1">
+            <a:extLst>
+              <a:ext uri="{FF2B5EF4-FFF2-40B4-BE49-F238E27FC236}">
+                <a16:creationId xmlns:a16="http://schemas.microsoft.com/office/drawing/2014/main" id="{EB9EBC78-4FE8-2C4B-B3E9-180A5A12FE77}"/>
+              </a:ext>
+            </a:extLst>
+          </p:cNvPr>
+          <p:cNvSpPr>
+            <a:spLocks noGrp="1"/>
+          </p:cNvSpPr>
+          <p:nvPr>
+            <p:ph type="title"/>
+          </p:nvPr>
+        </p:nvSpPr>
+        <p:spPr>
+          <a:solidFill>
+            <a:srgbClr val="5C9BD5"/>
+          </a:solidFill>
+        </p:spPr>
+        <p:txBody>
+          <a:bodyPr/>
+          <a:lstStyle/>
+          <a:p>
+            <a:r>
+              <a:rPr lang="en-US" dirty="0" err="1">
+                <a:solidFill>
+                  <a:schemeClr val="bg1"/>
+                </a:solidFill>
+              </a:rPr>
+              <a:t>Gephi</a:t>
+            </a:r>
+            <a:endParaRPr lang="en-US" dirty="0">
+              <a:solidFill>
+                <a:schemeClr val="bg1"/>
+              </a:solidFill>
+            </a:endParaRPr>
+          </a:p>
+        </p:txBody>
+      </p:sp>
+      <p:pic>
+        <p:nvPicPr>
+          <p:cNvPr id="6" name="Picture 5">
+            <a:extLst>
+              <a:ext uri="{FF2B5EF4-FFF2-40B4-BE49-F238E27FC236}">
+                <a16:creationId xmlns:a16="http://schemas.microsoft.com/office/drawing/2014/main" id="{D3ECF695-8101-B148-9E3A-CBC46B2DCD81}"/>
+              </a:ext>
+            </a:extLst>
+          </p:cNvPr>
+          <p:cNvPicPr>
+            <a:picLocks noChangeAspect="1"/>
+          </p:cNvPicPr>
+          <p:nvPr/>
+        </p:nvPicPr>
+        <p:blipFill>
+          <a:blip r:embed="rId3"/>
+          <a:stretch>
+            <a:fillRect/>
+          </a:stretch>
+        </p:blipFill>
+        <p:spPr>
+          <a:xfrm>
+            <a:off x="1788318" y="1858395"/>
+            <a:ext cx="8615363" cy="4735774"/>
+          </a:xfrm>
+          <a:prstGeom prst="rect">
+            <a:avLst/>
+          </a:prstGeom>
+        </p:spPr>
+      </p:pic>
+    </p:spTree>
+    <p:extLst>
+      <p:ext uri="{BB962C8B-B14F-4D97-AF65-F5344CB8AC3E}">
+        <p14:creationId xmlns:p14="http://schemas.microsoft.com/office/powerpoint/2010/main" val="4153186007"/>
       </p:ext>
     </p:extLst>
   </p:cSld>

</xml_diff>